<commit_message>
Visual results, interactive PyQt query GUI, query-API docs, first-principles FAQ
- make_visuals.py: GT/v2/v3 comparisons + error maps + 300-point sparse query figure
- query_gui.py: click-to-query PyQt5 tool (viability confirmed via offscreen selftest)
- Report sections 5-6: query sizes/API/training config, anticipated questions
- Status deck: 11 slides (adds visuals, interface, FAQ)

Co-Authored-By: Claude Fable 5 <noreply@anthropic.com>
</commit_message>
<xml_diff>
--- a/docs/NeuFlow_v3_status.pptx
+++ b/docs/NeuFlow_v3_status.pptx
@@ -13,6 +13,9 @@
     <p:sldId id="261" r:id="rId12"/>
     <p:sldId id="262" r:id="rId13"/>
     <p:sldId id="263" r:id="rId14"/>
+    <p:sldId id="264" r:id="rId15"/>
+    <p:sldId id="265" r:id="rId16"/>
+    <p:sldId id="266" r:id="rId17"/>
   </p:sldIdLst>
   <p:sldSz cx="12191695" cy="6858000" type="screen4x3"/>
   <p:notesSz cx="6858000" cy="9144000"/>
@@ -3216,6 +3219,637 @@
 </p:sld>
 </file>
 
+<file path=ppt/slides/slide10.xml><?xml version="1.0" encoding="utf-8"?>
+<p:sld xmlns:a="http://schemas.openxmlformats.org/drawingml/2006/main" xmlns:p="http://schemas.openxmlformats.org/presentationml/2006/main" xmlns:r="http://schemas.openxmlformats.org/officeDocument/2006/relationships">
+  <p:cSld>
+    <p:spTree>
+      <p:nvGrpSpPr>
+        <p:cNvPr id="1" name=""/>
+        <p:cNvGrpSpPr/>
+        <p:nvPr/>
+      </p:nvGrpSpPr>
+      <p:grpSpPr/>
+      <p:sp>
+        <p:nvSpPr>
+          <p:cNvPr id="2" name="TextBox 1"/>
+          <p:cNvSpPr txBox="1"/>
+          <p:nvPr/>
+        </p:nvSpPr>
+        <p:spPr>
+          <a:xfrm>
+            <a:off x="685800" y="384048"/>
+            <a:ext cx="10058400" cy="274320"/>
+          </a:xfrm>
+          <a:prstGeom prst="rect">
+            <a:avLst/>
+          </a:prstGeom>
+          <a:noFill/>
+        </p:spPr>
+        <p:txBody>
+          <a:bodyPr wrap="square">
+            <a:spAutoFit/>
+          </a:bodyPr>
+          <a:lstStyle/>
+          <a:p>
+            <a:r>
+              <a:rPr sz="1050" b="1">
+                <a:solidFill>
+                  <a:srgbClr val="1F4E79"/>
+                </a:solidFill>
+                <a:latin typeface="Calibri"/>
+              </a:rPr>
+              <a:t>ANTICIPATED QUESTIONS</a:t>
+            </a:r>
+          </a:p>
+        </p:txBody>
+      </p:sp>
+      <p:sp>
+        <p:nvSpPr>
+          <p:cNvPr id="3" name="TextBox 2"/>
+          <p:cNvSpPr txBox="1"/>
+          <p:nvPr/>
+        </p:nvSpPr>
+        <p:spPr>
+          <a:xfrm>
+            <a:off x="667512" y="658368"/>
+            <a:ext cx="10789920" cy="731520"/>
+          </a:xfrm>
+          <a:prstGeom prst="rect">
+            <a:avLst/>
+          </a:prstGeom>
+          <a:noFill/>
+        </p:spPr>
+        <p:txBody>
+          <a:bodyPr wrap="square">
+            <a:spAutoFit/>
+          </a:bodyPr>
+          <a:lstStyle/>
+          <a:p>
+            <a:r>
+              <a:rPr sz="2400" b="1">
+                <a:solidFill>
+                  <a:srgbClr val="20242B"/>
+                </a:solidFill>
+                <a:latin typeface="Calibri"/>
+              </a:rPr>
+              <a:t>First-principles FAQ</a:t>
+            </a:r>
+          </a:p>
+        </p:txBody>
+      </p:sp>
+      <p:sp>
+        <p:nvSpPr>
+          <p:cNvPr id="4" name="TextBox 3"/>
+          <p:cNvSpPr txBox="1"/>
+          <p:nvPr/>
+        </p:nvSpPr>
+        <p:spPr>
+          <a:xfrm>
+            <a:off x="685800" y="1554480"/>
+            <a:ext cx="10789920" cy="4023360"/>
+          </a:xfrm>
+          <a:prstGeom prst="rect">
+            <a:avLst/>
+          </a:prstGeom>
+          <a:noFill/>
+        </p:spPr>
+        <p:txBody>
+          <a:bodyPr wrap="square">
+            <a:spAutoFit/>
+          </a:bodyPr>
+          <a:lstStyle/>
+          <a:p>
+            <a:r>
+              <a:rPr sz="1250" b="0">
+                <a:solidFill>
+                  <a:srgbClr val="20242B"/>
+                </a:solidFill>
+                <a:latin typeface="Calibri"/>
+              </a:rPr>
+              <a:t>Why is flow queryable at continuous coords?  Bilinear feature interpolation + an MLP = a function defined at every real (x, y).</a:t>
+            </a:r>
+          </a:p>
+          <a:p>
+            <a:r>
+              <a:rPr sz="1250" b="0">
+                <a:solidFill>
+                  <a:srgbClr val="20242B"/>
+                </a:solidFill>
+                <a:latin typeface="Calibri"/>
+              </a:rPr>
+              <a:t/>
+            </a:r>
+          </a:p>
+          <a:p>
+            <a:r>
+              <a:rPr sz="1250" b="0">
+                <a:solidFill>
+                  <a:srgbClr val="20242B"/>
+                </a:solidFill>
+                <a:latin typeface="Calibri"/>
+              </a:rPr>
+              <a:t>Why freeze the backbone?  Joint training needs ~800K steps (InfiniDepth); at 30K the decoder chases moving features and diverges.</a:t>
+            </a:r>
+          </a:p>
+          <a:p>
+            <a:r>
+              <a:rPr sz="1250" b="0">
+                <a:solidFill>
+                  <a:srgbClr val="20242B"/>
+                </a:solidFill>
+                <a:latin typeface="Calibri"/>
+              </a:rPr>
+              <a:t/>
+            </a:r>
+          </a:p>
+          <a:p>
+            <a:r>
+              <a:rPr sz="1250" b="0">
+                <a:solidFill>
+                  <a:srgbClr val="20242B"/>
+                </a:solidFill>
+                <a:latin typeface="Calibri"/>
+              </a:rPr>
+              <a:t>Is sparse an approximation?  No — the identical function at fewer points; matches dense to 0.00 px at the same coordinates.</a:t>
+            </a:r>
+          </a:p>
+          <a:p>
+            <a:r>
+              <a:rPr sz="1250" b="0">
+                <a:solidFill>
+                  <a:srgbClr val="20242B"/>
+                </a:solidFill>
+                <a:latin typeface="Calibri"/>
+              </a:rPr>
+              <a:t/>
+            </a:r>
+          </a:p>
+          <a:p>
+            <a:r>
+              <a:rPr sz="1250" b="0">
+                <a:solidFill>
+                  <a:srgbClr val="20242B"/>
+                </a:solidFill>
+                <a:latin typeface="Calibri"/>
+              </a:rPr>
+              <a:t>Why does chairs training beat driving-data training on driving data?  Diverse large motions fix the error tail; 5 scenes teach memorization.</a:t>
+            </a:r>
+          </a:p>
+          <a:p>
+            <a:r>
+              <a:rPr sz="1250" b="0">
+                <a:solidFill>
+                  <a:srgbClr val="20242B"/>
+                </a:solidFill>
+                <a:latin typeface="Calibri"/>
+              </a:rPr>
+              <a:t/>
+            </a:r>
+          </a:p>
+          <a:p>
+            <a:r>
+              <a:rPr sz="1250" b="0">
+                <a:solidFill>
+                  <a:srgbClr val="20242B"/>
+                </a:solidFill>
+                <a:latin typeface="Calibri"/>
+              </a:rPr>
+              <a:t>If sparse is fast, why is dense slow?  Dense = 479k MLP calls (~293 ms); v2 upsampling is one fused conv. Dense is not the use case.</a:t>
+            </a:r>
+          </a:p>
+          <a:p>
+            <a:r>
+              <a:rPr sz="1250" b="0">
+                <a:solidFill>
+                  <a:srgbClr val="20242B"/>
+                </a:solidFill>
+                <a:latin typeface="Calibri"/>
+              </a:rPr>
+              <a:t/>
+            </a:r>
+          </a:p>
+          <a:p>
+            <a:r>
+              <a:rPr sz="1250" b="0">
+                <a:solidFill>
+                  <a:srgbClr val="20242B"/>
+                </a:solidFill>
+                <a:latin typeface="Calibri"/>
+              </a:rPr>
+              <a:t>What limits 1px accuracy?  The head could not see the sub-cell position — exactly what the Fourier PE ablation injects.</a:t>
+            </a:r>
+          </a:p>
+        </p:txBody>
+      </p:sp>
+      <p:sp>
+        <p:nvSpPr>
+          <p:cNvPr id="5" name="TextBox 4"/>
+          <p:cNvSpPr txBox="1"/>
+          <p:nvPr/>
+        </p:nvSpPr>
+        <p:spPr>
+          <a:xfrm>
+            <a:off x="960120" y="5760720"/>
+            <a:ext cx="10332720" cy="548640"/>
+          </a:xfrm>
+          <a:prstGeom prst="rect">
+            <a:avLst/>
+          </a:prstGeom>
+          <a:noFill/>
+        </p:spPr>
+        <p:txBody>
+          <a:bodyPr wrap="square">
+            <a:spAutoFit/>
+          </a:bodyPr>
+          <a:lstStyle/>
+          <a:p>
+            <a:r>
+              <a:rPr sz="1150" b="1">
+                <a:solidFill>
+                  <a:srgbClr val="1F4E79"/>
+                </a:solidFill>
+                <a:latin typeface="Calibri"/>
+              </a:rPr>
+              <a:t>Takeaway   Full FAQ + derivations: docs/NeuFlow_v3_Report.md sections 5-6.</a:t>
+            </a:r>
+          </a:p>
+        </p:txBody>
+      </p:sp>
+      <p:sp>
+        <p:nvSpPr>
+          <p:cNvPr id="6" name="TextBox 5"/>
+          <p:cNvSpPr txBox="1"/>
+          <p:nvPr/>
+        </p:nvSpPr>
+        <p:spPr>
+          <a:xfrm>
+            <a:off x="685800" y="6419088"/>
+            <a:ext cx="7315200" cy="274320"/>
+          </a:xfrm>
+          <a:prstGeom prst="rect">
+            <a:avLst/>
+          </a:prstGeom>
+          <a:noFill/>
+        </p:spPr>
+        <p:txBody>
+          <a:bodyPr wrap="square">
+            <a:spAutoFit/>
+          </a:bodyPr>
+          <a:lstStyle/>
+          <a:p>
+            <a:r>
+              <a:rPr sz="900" b="0">
+                <a:solidFill>
+                  <a:srgbClr val="7B838F"/>
+                </a:solidFill>
+                <a:latin typeface="Calibri"/>
+              </a:rPr>
+              <a:t>NeuFlow v3  ·  status</a:t>
+            </a:r>
+          </a:p>
+        </p:txBody>
+      </p:sp>
+      <p:sp>
+        <p:nvSpPr>
+          <p:cNvPr id="7" name="TextBox 6"/>
+          <p:cNvSpPr txBox="1"/>
+          <p:nvPr/>
+        </p:nvSpPr>
+        <p:spPr>
+          <a:xfrm>
+            <a:off x="10607040" y="6419088"/>
+            <a:ext cx="1097280" cy="274320"/>
+          </a:xfrm>
+          <a:prstGeom prst="rect">
+            <a:avLst/>
+          </a:prstGeom>
+          <a:noFill/>
+        </p:spPr>
+        <p:txBody>
+          <a:bodyPr wrap="square">
+            <a:spAutoFit/>
+          </a:bodyPr>
+          <a:lstStyle/>
+          <a:p>
+            <a:r>
+              <a:rPr sz="900" b="0">
+                <a:solidFill>
+                  <a:srgbClr val="7B838F"/>
+                </a:solidFill>
+                <a:latin typeface="Calibri"/>
+              </a:rPr>
+              <a:t>10</a:t>
+            </a:r>
+          </a:p>
+        </p:txBody>
+      </p:sp>
+    </p:spTree>
+  </p:cSld>
+  <p:clrMapOvr>
+    <a:masterClrMapping/>
+  </p:clrMapOvr>
+</p:sld>
+</file>
+
+<file path=ppt/slides/slide11.xml><?xml version="1.0" encoding="utf-8"?>
+<p:sld xmlns:a="http://schemas.openxmlformats.org/drawingml/2006/main" xmlns:p="http://schemas.openxmlformats.org/presentationml/2006/main" xmlns:r="http://schemas.openxmlformats.org/officeDocument/2006/relationships">
+  <p:cSld>
+    <p:spTree>
+      <p:nvGrpSpPr>
+        <p:cNvPr id="1" name=""/>
+        <p:cNvGrpSpPr/>
+        <p:nvPr/>
+      </p:nvGrpSpPr>
+      <p:grpSpPr/>
+      <p:sp>
+        <p:nvSpPr>
+          <p:cNvPr id="2" name="TextBox 1"/>
+          <p:cNvSpPr txBox="1"/>
+          <p:nvPr/>
+        </p:nvSpPr>
+        <p:spPr>
+          <a:xfrm>
+            <a:off x="685800" y="384048"/>
+            <a:ext cx="10058400" cy="274320"/>
+          </a:xfrm>
+          <a:prstGeom prst="rect">
+            <a:avLst/>
+          </a:prstGeom>
+          <a:noFill/>
+        </p:spPr>
+        <p:txBody>
+          <a:bodyPr wrap="square">
+            <a:spAutoFit/>
+          </a:bodyPr>
+          <a:lstStyle/>
+          <a:p>
+            <a:r>
+              <a:rPr sz="1050" b="1">
+                <a:solidFill>
+                  <a:srgbClr val="1F4E79"/>
+                </a:solidFill>
+                <a:latin typeface="Calibri"/>
+              </a:rPr>
+              <a:t>NEXT</a:t>
+            </a:r>
+          </a:p>
+        </p:txBody>
+      </p:sp>
+      <p:sp>
+        <p:nvSpPr>
+          <p:cNvPr id="3" name="TextBox 2"/>
+          <p:cNvSpPr txBox="1"/>
+          <p:nvPr/>
+        </p:nvSpPr>
+        <p:spPr>
+          <a:xfrm>
+            <a:off x="667512" y="658368"/>
+            <a:ext cx="10789920" cy="731520"/>
+          </a:xfrm>
+          <a:prstGeom prst="rect">
+            <a:avLst/>
+          </a:prstGeom>
+          <a:noFill/>
+        </p:spPr>
+        <p:txBody>
+          <a:bodyPr wrap="square">
+            <a:spAutoFit/>
+          </a:bodyPr>
+          <a:lstStyle/>
+          <a:p>
+            <a:r>
+              <a:rPr sz="2400" b="1">
+                <a:solidFill>
+                  <a:srgbClr val="20242B"/>
+                </a:solidFill>
+                <a:latin typeface="Calibri"/>
+              </a:rPr>
+              <a:t>Next steps</a:t>
+            </a:r>
+          </a:p>
+        </p:txBody>
+      </p:sp>
+      <p:sp>
+        <p:nvSpPr>
+          <p:cNvPr id="4" name="TextBox 3"/>
+          <p:cNvSpPr txBox="1"/>
+          <p:nvPr/>
+        </p:nvSpPr>
+        <p:spPr>
+          <a:xfrm>
+            <a:off x="685800" y="1737360"/>
+            <a:ext cx="10515600" cy="3474720"/>
+          </a:xfrm>
+          <a:prstGeom prst="rect">
+            <a:avLst/>
+          </a:prstGeom>
+          <a:noFill/>
+        </p:spPr>
+        <p:txBody>
+          <a:bodyPr wrap="square">
+            <a:spAutoFit/>
+          </a:bodyPr>
+          <a:lstStyle/>
+          <a:p>
+            <a:r>
+              <a:rPr sz="1400" b="0">
+                <a:solidFill>
+                  <a:srgbClr val="20242B"/>
+                </a:solidFill>
+                <a:latin typeface="Calibri"/>
+              </a:rPr>
+              <a:t>1. Fourier PE ablation — same chairs recipe, +sub-cell encoding; targets 1px accuracy directly.</a:t>
+            </a:r>
+          </a:p>
+          <a:p>
+            <a:r>
+              <a:rPr sz="1400" b="0">
+                <a:solidFill>
+                  <a:srgbClr val="20242B"/>
+                </a:solidFill>
+                <a:latin typeface="Calibri"/>
+              </a:rPr>
+              <a:t/>
+            </a:r>
+          </a:p>
+          <a:p>
+            <a:r>
+              <a:rPr sz="1400" b="0">
+                <a:solidFill>
+                  <a:srgbClr val="20242B"/>
+                </a:solidFill>
+                <a:latin typeface="Calibri"/>
+              </a:rPr>
+              <a:t>2. Mixed chairs + vkitti2_all training — one dataloader change; expected to hold 2.27 EPE while recovering precision.</a:t>
+            </a:r>
+          </a:p>
+          <a:p>
+            <a:r>
+              <a:rPr sz="1400" b="0">
+                <a:solidFill>
+                  <a:srgbClr val="20242B"/>
+                </a:solidFill>
+                <a:latin typeface="Calibri"/>
+              </a:rPr>
+              <a:t/>
+            </a:r>
+          </a:p>
+          <a:p>
+            <a:r>
+              <a:rPr sz="1400" b="0">
+                <a:solidFill>
+                  <a:srgbClr val="20242B"/>
+                </a:solidFill>
+                <a:latin typeface="Calibri"/>
+              </a:rPr>
+              <a:t>3. Jetson Orin benchmark — the O(N) story is strongest where dense flow cannot run at all.</a:t>
+            </a:r>
+          </a:p>
+          <a:p>
+            <a:r>
+              <a:rPr sz="1400" b="0">
+                <a:solidFill>
+                  <a:srgbClr val="20242B"/>
+                </a:solidFill>
+                <a:latin typeface="Calibri"/>
+              </a:rPr>
+              <a:t/>
+            </a:r>
+          </a:p>
+          <a:p>
+            <a:r>
+              <a:rPr sz="1400" b="0">
+                <a:solidFill>
+                  <a:srgbClr val="20242B"/>
+                </a:solidFill>
+                <a:latin typeface="Calibri"/>
+              </a:rPr>
+              <a:t>4. Thesis experiments — registration/mapping demo on advisor-provided survey imagery; Spring dataset for</a:t>
+            </a:r>
+          </a:p>
+          <a:p>
+            <a:r>
+              <a:rPr sz="1400" b="0">
+                <a:solidFill>
+                  <a:srgbClr val="20242B"/>
+                </a:solidFill>
+                <a:latin typeface="Calibri"/>
+              </a:rPr>
+              <a:t>    above-input-resolution querying (GT at 2x input resolution — a test only queryable decoders can take natively).</a:t>
+            </a:r>
+          </a:p>
+        </p:txBody>
+      </p:sp>
+      <p:sp>
+        <p:nvSpPr>
+          <p:cNvPr id="5" name="TextBox 4"/>
+          <p:cNvSpPr txBox="1"/>
+          <p:nvPr/>
+        </p:nvSpPr>
+        <p:spPr>
+          <a:xfrm>
+            <a:off x="960120" y="5760720"/>
+            <a:ext cx="10332720" cy="548640"/>
+          </a:xfrm>
+          <a:prstGeom prst="rect">
+            <a:avLst/>
+          </a:prstGeom>
+          <a:noFill/>
+        </p:spPr>
+        <p:txBody>
+          <a:bodyPr wrap="square">
+            <a:spAutoFit/>
+          </a:bodyPr>
+          <a:lstStyle/>
+          <a:p>
+            <a:r>
+              <a:rPr sz="1150" b="1">
+                <a:solidFill>
+                  <a:srgbClr val="1F4E79"/>
+                </a:solidFill>
+                <a:latin typeface="Calibri"/>
+              </a:rPr>
+              <a:t>Takeaway   The architecture is validated; remaining work is training composition and edge deployment.</a:t>
+            </a:r>
+          </a:p>
+        </p:txBody>
+      </p:sp>
+      <p:sp>
+        <p:nvSpPr>
+          <p:cNvPr id="6" name="TextBox 5"/>
+          <p:cNvSpPr txBox="1"/>
+          <p:nvPr/>
+        </p:nvSpPr>
+        <p:spPr>
+          <a:xfrm>
+            <a:off x="685800" y="6419088"/>
+            <a:ext cx="7315200" cy="274320"/>
+          </a:xfrm>
+          <a:prstGeom prst="rect">
+            <a:avLst/>
+          </a:prstGeom>
+          <a:noFill/>
+        </p:spPr>
+        <p:txBody>
+          <a:bodyPr wrap="square">
+            <a:spAutoFit/>
+          </a:bodyPr>
+          <a:lstStyle/>
+          <a:p>
+            <a:r>
+              <a:rPr sz="900" b="0">
+                <a:solidFill>
+                  <a:srgbClr val="7B838F"/>
+                </a:solidFill>
+                <a:latin typeface="Calibri"/>
+              </a:rPr>
+              <a:t>NeuFlow v3  ·  status</a:t>
+            </a:r>
+          </a:p>
+        </p:txBody>
+      </p:sp>
+      <p:sp>
+        <p:nvSpPr>
+          <p:cNvPr id="7" name="TextBox 6"/>
+          <p:cNvSpPr txBox="1"/>
+          <p:nvPr/>
+        </p:nvSpPr>
+        <p:spPr>
+          <a:xfrm>
+            <a:off x="10607040" y="6419088"/>
+            <a:ext cx="1097280" cy="274320"/>
+          </a:xfrm>
+          <a:prstGeom prst="rect">
+            <a:avLst/>
+          </a:prstGeom>
+          <a:noFill/>
+        </p:spPr>
+        <p:txBody>
+          <a:bodyPr wrap="square">
+            <a:spAutoFit/>
+          </a:bodyPr>
+          <a:lstStyle/>
+          <a:p>
+            <a:r>
+              <a:rPr sz="900" b="0">
+                <a:solidFill>
+                  <a:srgbClr val="7B838F"/>
+                </a:solidFill>
+                <a:latin typeface="Calibri"/>
+              </a:rPr>
+              <a:t>11</a:t>
+            </a:r>
+          </a:p>
+        </p:txBody>
+      </p:sp>
+    </p:spTree>
+  </p:cSld>
+  <p:clrMapOvr>
+    <a:masterClrMapping/>
+  </p:clrMapOvr>
+</p:sld>
+</file>
+
 <file path=ppt/slides/slide2.xml><?xml version="1.0" encoding="utf-8"?>
 <p:sld xmlns:a="http://schemas.openxmlformats.org/drawingml/2006/main" xmlns:p="http://schemas.openxmlformats.org/presentationml/2006/main" xmlns:r="http://schemas.openxmlformats.org/officeDocument/2006/relationships">
   <p:cSld>
@@ -5082,7 +5716,7 @@
                 </a:solidFill>
                 <a:latin typeface="Calibri"/>
               </a:rPr>
-              <a:t>RESULT 3 OF 3  ·  RTX 4060 LAPTOP 8GB, FP16, 384x1248</a:t>
+              <a:t>VISUAL RESULTS  ·  VKITTI2 SCENE18</a:t>
             </a:r>
           </a:p>
         </p:txBody>
@@ -5116,14 +5750,14 @@
                 </a:solidFill>
                 <a:latin typeface="Calibri"/>
               </a:rPr>
-              <a:t>Compute: v2 vs v3</a:t>
+              <a:t>Seeing the output: dense fields and sparse queries</a:t>
             </a:r>
           </a:p>
         </p:txBody>
       </p:sp>
       <p:pic>
         <p:nvPicPr>
-          <p:cNvPr id="4" name="Picture 3" descr="latency_v2_v3.png"/>
+          <p:cNvPr id="4" name="Picture 3" descr="sparse_queries.png"/>
           <p:cNvPicPr>
             <a:picLocks noChangeAspect="1"/>
           </p:cNvPicPr>
@@ -5137,8 +5771,8 @@
         </p:blipFill>
         <p:spPr>
           <a:xfrm>
-            <a:off x="685800" y="1600200"/>
-            <a:ext cx="7863840" cy="3214910"/>
+            <a:off x="685800" y="1508760"/>
+            <a:ext cx="7498079" cy="2499360"/>
           </a:xfrm>
           <a:prstGeom prst="rect">
             <a:avLst/>
@@ -5153,8 +5787,8 @@
         </p:nvSpPr>
         <p:spPr>
           <a:xfrm>
-            <a:off x="8778240" y="1691640"/>
-            <a:ext cx="2743200" cy="3931920"/>
+            <a:off x="8412480" y="1600200"/>
+            <a:ext cx="3200400" cy="2926080"/>
           </a:xfrm>
           <a:prstGeom prst="rect">
             <a:avLst/>
@@ -5174,7 +5808,7 @@
                 </a:solidFill>
                 <a:latin typeface="Calibri"/>
               </a:rPr>
-              <a:t>Params:</a:t>
+              <a:t>300 corner-detected queries,</a:t>
             </a:r>
           </a:p>
           <a:p>
@@ -5185,7 +5819,7 @@
                 </a:solidFill>
                 <a:latin typeface="Calibri"/>
               </a:rPr>
-              <a:t>9.03M (v2)</a:t>
+              <a:t>decoded in ONE 1.6 ms call</a:t>
             </a:r>
           </a:p>
           <a:p>
@@ -5196,7 +5830,7 @@
                 </a:solidFill>
                 <a:latin typeface="Calibri"/>
               </a:rPr>
-              <a:t>7.83M (v3)</a:t>
+              <a:t>(0.05% of a dense field).</a:t>
             </a:r>
           </a:p>
           <a:p>
@@ -5218,7 +5852,7 @@
                 </a:solidFill>
                 <a:latin typeface="Calibri"/>
               </a:rPr>
-              <a:t>Sparse v3 costs the</a:t>
+              <a:t>Arrow color = flow magnitude.</a:t>
             </a:r>
           </a:p>
           <a:p>
@@ -5229,7 +5863,7 @@
                 </a:solidFill>
                 <a:latin typeface="Calibri"/>
               </a:rPr>
-              <a:t>same as v2 dense —</a:t>
+              <a:t>Left roadside streams left,</a:t>
             </a:r>
           </a:p>
           <a:p>
@@ -5240,7 +5874,7 @@
                 </a:solidFill>
                 <a:latin typeface="Calibri"/>
               </a:rPr>
-              <a:t>but extra queries on</a:t>
+              <a:t>right side streams right —</a:t>
             </a:r>
           </a:p>
           <a:p>
@@ -5251,7 +5885,7 @@
                 </a:solidFill>
                 <a:latin typeface="Calibri"/>
               </a:rPr>
-              <a:t>a processed pair are</a:t>
+              <a:t>forward ego-motion, correctly</a:t>
             </a:r>
           </a:p>
           <a:p>
@@ -5262,51 +5896,7 @@
                 </a:solidFill>
                 <a:latin typeface="Calibri"/>
               </a:rPr>
-              <a:t>~20x cheaper than</a:t>
-            </a:r>
-          </a:p>
-          <a:p>
-            <a:r>
-              <a:rPr sz="1200" b="0">
-                <a:solidFill>
-                  <a:srgbClr val="20242B"/>
-                </a:solidFill>
-                <a:latin typeface="Calibri"/>
-              </a:rPr>
-              <a:t>v2 recomputing.</a:t>
-            </a:r>
-          </a:p>
-          <a:p>
-            <a:r>
-              <a:rPr sz="1200" b="0">
-                <a:solidFill>
-                  <a:srgbClr val="20242B"/>
-                </a:solidFill>
-                <a:latin typeface="Calibri"/>
-              </a:rPr>
-              <a:t/>
-            </a:r>
-          </a:p>
-          <a:p>
-            <a:r>
-              <a:rPr sz="1200" b="0">
-                <a:solidFill>
-                  <a:srgbClr val="20242B"/>
-                </a:solidFill>
-                <a:latin typeface="Calibri"/>
-              </a:rPr>
-              <a:t>v3 dense (327 ms) is</a:t>
-            </a:r>
-          </a:p>
-          <a:p>
-            <a:r>
-              <a:rPr sz="1200" b="0">
-                <a:solidFill>
-                  <a:srgbClr val="20242B"/>
-                </a:solidFill>
-                <a:latin typeface="Calibri"/>
-              </a:rPr>
-              <a:t>not the use case.</a:t>
+              <a:t>recovered per point.</a:t>
             </a:r>
           </a:p>
         </p:txBody>
@@ -5319,8 +5909,8 @@
         </p:nvSpPr>
         <p:spPr>
           <a:xfrm>
-            <a:off x="960120" y="5806440"/>
-            <a:ext cx="10332720" cy="548640"/>
+            <a:off x="685800" y="4206240"/>
+            <a:ext cx="10789920" cy="365760"/>
           </a:xfrm>
           <a:prstGeom prst="rect">
             <a:avLst/>
@@ -5334,13 +5924,13 @@
           <a:lstStyle/>
           <a:p>
             <a:r>
-              <a:rPr sz="1150" b="1">
-                <a:solidFill>
-                  <a:srgbClr val="1F4E79"/>
-                </a:solidFill>
-                <a:latin typeface="Calibri"/>
-              </a:rPr>
-              <a:t>Takeaway   For sparse workloads (registration, tracking, mapping) v3 is strictly cheaper; parity latency, fewer params, O(N) scaling.</a:t>
+              <a:rPr sz="1100" b="0">
+                <a:solidFill>
+                  <a:srgbClr val="7B838F"/>
+                </a:solidFill>
+                <a:latin typeface="Calibri"/>
+              </a:rPr>
+              <a:t>Full-field comparisons (input / GT / v2 / v3 / error maps): results/visuals/compare_0.png, compare_1.png</a:t>
             </a:r>
           </a:p>
         </p:txBody>
@@ -5353,8 +5943,8 @@
         </p:nvSpPr>
         <p:spPr>
           <a:xfrm>
-            <a:off x="685800" y="6419088"/>
-            <a:ext cx="7315200" cy="274320"/>
+            <a:off x="960120" y="5760720"/>
+            <a:ext cx="10332720" cy="548640"/>
           </a:xfrm>
           <a:prstGeom prst="rect">
             <a:avLst/>
@@ -5368,6 +5958,40 @@
           <a:lstStyle/>
           <a:p>
             <a:r>
+              <a:rPr sz="1150" b="1">
+                <a:solidFill>
+                  <a:srgbClr val="1F4E79"/>
+                </a:solidFill>
+                <a:latin typeface="Calibri"/>
+              </a:rPr>
+              <a:t>Takeaway   v3 flow fields are structurally clean; both models fail in the same hard regions (dense foliage).</a:t>
+            </a:r>
+          </a:p>
+        </p:txBody>
+      </p:sp>
+      <p:sp>
+        <p:nvSpPr>
+          <p:cNvPr id="8" name="TextBox 7"/>
+          <p:cNvSpPr txBox="1"/>
+          <p:nvPr/>
+        </p:nvSpPr>
+        <p:spPr>
+          <a:xfrm>
+            <a:off x="685800" y="6419088"/>
+            <a:ext cx="7315200" cy="274320"/>
+          </a:xfrm>
+          <a:prstGeom prst="rect">
+            <a:avLst/>
+          </a:prstGeom>
+          <a:noFill/>
+        </p:spPr>
+        <p:txBody>
+          <a:bodyPr wrap="square">
+            <a:spAutoFit/>
+          </a:bodyPr>
+          <a:lstStyle/>
+          <a:p>
+            <a:r>
               <a:rPr sz="900" b="0">
                 <a:solidFill>
                   <a:srgbClr val="7B838F"/>
@@ -5381,7 +6005,7 @@
       </p:sp>
       <p:sp>
         <p:nvSpPr>
-          <p:cNvPr id="8" name="TextBox 7"/>
+          <p:cNvPr id="9" name="TextBox 8"/>
           <p:cNvSpPr txBox="1"/>
           <p:nvPr/>
         </p:nvSpPr>
@@ -5460,7 +6084,7 @@
                 </a:solidFill>
                 <a:latin typeface="Calibri"/>
               </a:rPr>
-              <a:t>OBJECTIVES</a:t>
+              <a:t>RESULT 3 OF 3  ·  RTX 4060 LAPTOP 8GB, FP16, 384x1248</a:t>
             </a:r>
           </a:p>
         </p:txBody>
@@ -5494,21 +6118,45 @@
                 </a:solidFill>
                 <a:latin typeface="Calibri"/>
               </a:rPr>
-              <a:t>Better EPE at less compute, edge-capable — where we stand</a:t>
-            </a:r>
-          </a:p>
-        </p:txBody>
-      </p:sp>
-      <p:sp>
-        <p:nvSpPr>
-          <p:cNvPr id="4" name="TextBox 3"/>
+              <a:t>Compute: v2 vs v3</a:t>
+            </a:r>
+          </a:p>
+        </p:txBody>
+      </p:sp>
+      <p:pic>
+        <p:nvPicPr>
+          <p:cNvPr id="4" name="Picture 3" descr="latency_v2_v3.png"/>
+          <p:cNvPicPr>
+            <a:picLocks noChangeAspect="1"/>
+          </p:cNvPicPr>
+          <p:nvPr/>
+        </p:nvPicPr>
+        <p:blipFill>
+          <a:blip r:embed="rId2"/>
+          <a:stretch>
+            <a:fillRect/>
+          </a:stretch>
+        </p:blipFill>
+        <p:spPr>
+          <a:xfrm>
+            <a:off x="685800" y="1600200"/>
+            <a:ext cx="7863840" cy="3214910"/>
+          </a:xfrm>
+          <a:prstGeom prst="rect">
+            <a:avLst/>
+          </a:prstGeom>
+        </p:spPr>
+      </p:pic>
+      <p:sp>
+        <p:nvSpPr>
+          <p:cNvPr id="5" name="TextBox 4"/>
           <p:cNvSpPr txBox="1"/>
           <p:nvPr/>
         </p:nvSpPr>
         <p:spPr>
           <a:xfrm>
-            <a:off x="685800" y="1737360"/>
-            <a:ext cx="10515600" cy="3566160"/>
+            <a:off x="8778240" y="1691640"/>
+            <a:ext cx="2743200" cy="3931920"/>
           </a:xfrm>
           <a:prstGeom prst="rect">
             <a:avLst/>
@@ -5522,18 +6170,40 @@
           <a:lstStyle/>
           <a:p>
             <a:r>
-              <a:rPr sz="1400" b="0">
-                <a:solidFill>
-                  <a:srgbClr val="20242B"/>
-                </a:solidFill>
-                <a:latin typeface="Calibri"/>
-              </a:rPr>
-              <a:t>Beat v2 mean EPE                        DONE — 2.275 vs 2.324 (chairs-only training)</a:t>
-            </a:r>
-          </a:p>
-          <a:p>
-            <a:r>
-              <a:rPr sz="1400" b="0">
+              <a:rPr sz="1200" b="0">
+                <a:solidFill>
+                  <a:srgbClr val="20242B"/>
+                </a:solidFill>
+                <a:latin typeface="Calibri"/>
+              </a:rPr>
+              <a:t>Params:</a:t>
+            </a:r>
+          </a:p>
+          <a:p>
+            <a:r>
+              <a:rPr sz="1200" b="0">
+                <a:solidFill>
+                  <a:srgbClr val="20242B"/>
+                </a:solidFill>
+                <a:latin typeface="Calibri"/>
+              </a:rPr>
+              <a:t>9.03M (v2)</a:t>
+            </a:r>
+          </a:p>
+          <a:p>
+            <a:r>
+              <a:rPr sz="1200" b="0">
+                <a:solidFill>
+                  <a:srgbClr val="20242B"/>
+                </a:solidFill>
+                <a:latin typeface="Calibri"/>
+              </a:rPr>
+              <a:t>7.83M (v3)</a:t>
+            </a:r>
+          </a:p>
+          <a:p>
+            <a:r>
+              <a:rPr sz="1200" b="0">
                 <a:solidFill>
                   <a:srgbClr val="20242B"/>
                 </a:solidFill>
@@ -5544,18 +6214,73 @@
           </a:p>
           <a:p>
             <a:r>
-              <a:rPr sz="1400" b="0">
-                <a:solidFill>
-                  <a:srgbClr val="20242B"/>
-                </a:solidFill>
-                <a:latin typeface="Calibri"/>
-              </a:rPr>
-              <a:t>Less compute (sparse use case)          DONE — ~35 ms total, O(N) queries, 13% fewer params, 2.2 GB VRAM</a:t>
-            </a:r>
-          </a:p>
-          <a:p>
-            <a:r>
-              <a:rPr sz="1400" b="0">
+              <a:rPr sz="1200" b="0">
+                <a:solidFill>
+                  <a:srgbClr val="20242B"/>
+                </a:solidFill>
+                <a:latin typeface="Calibri"/>
+              </a:rPr>
+              <a:t>Sparse v3 costs the</a:t>
+            </a:r>
+          </a:p>
+          <a:p>
+            <a:r>
+              <a:rPr sz="1200" b="0">
+                <a:solidFill>
+                  <a:srgbClr val="20242B"/>
+                </a:solidFill>
+                <a:latin typeface="Calibri"/>
+              </a:rPr>
+              <a:t>same as v2 dense —</a:t>
+            </a:r>
+          </a:p>
+          <a:p>
+            <a:r>
+              <a:rPr sz="1200" b="0">
+                <a:solidFill>
+                  <a:srgbClr val="20242B"/>
+                </a:solidFill>
+                <a:latin typeface="Calibri"/>
+              </a:rPr>
+              <a:t>but extra queries on</a:t>
+            </a:r>
+          </a:p>
+          <a:p>
+            <a:r>
+              <a:rPr sz="1200" b="0">
+                <a:solidFill>
+                  <a:srgbClr val="20242B"/>
+                </a:solidFill>
+                <a:latin typeface="Calibri"/>
+              </a:rPr>
+              <a:t>a processed pair are</a:t>
+            </a:r>
+          </a:p>
+          <a:p>
+            <a:r>
+              <a:rPr sz="1200" b="0">
+                <a:solidFill>
+                  <a:srgbClr val="20242B"/>
+                </a:solidFill>
+                <a:latin typeface="Calibri"/>
+              </a:rPr>
+              <a:t>~20x cheaper than</a:t>
+            </a:r>
+          </a:p>
+          <a:p>
+            <a:r>
+              <a:rPr sz="1200" b="0">
+                <a:solidFill>
+                  <a:srgbClr val="20242B"/>
+                </a:solidFill>
+                <a:latin typeface="Calibri"/>
+              </a:rPr>
+              <a:t>v2 recomputing.</a:t>
+            </a:r>
+          </a:p>
+          <a:p>
+            <a:r>
+              <a:rPr sz="1200" b="0">
                 <a:solidFill>
                   <a:srgbClr val="20242B"/>
                 </a:solidFill>
@@ -5566,70 +6291,37 @@
           </a:p>
           <a:p>
             <a:r>
-              <a:rPr sz="1400" b="0">
-                <a:solidFill>
-                  <a:srgbClr val="20242B"/>
-                </a:solidFill>
-                <a:latin typeface="Calibri"/>
-              </a:rPr>
-              <a:t>Sub-pixel precision parity (1px acc)    IN PROGRESS — Fourier PE ablation (training in progress)</a:t>
-            </a:r>
-          </a:p>
-          <a:p>
-            <a:r>
-              <a:rPr sz="1400" b="0">
-                <a:solidFill>
-                  <a:srgbClr val="20242B"/>
-                </a:solidFill>
-                <a:latin typeface="Calibri"/>
-              </a:rPr>
-              <a:t/>
-            </a:r>
-          </a:p>
-          <a:p>
-            <a:r>
-              <a:rPr sz="1400" b="0">
-                <a:solidFill>
-                  <a:srgbClr val="20242B"/>
-                </a:solidFill>
-                <a:latin typeface="Calibri"/>
-              </a:rPr>
-              <a:t>Combine chairs + vkitti2 strengths      NEXT — mixed-dataset training (forgetting measured and understood)</a:t>
-            </a:r>
-          </a:p>
-          <a:p>
-            <a:r>
-              <a:rPr sz="1400" b="0">
-                <a:solidFill>
-                  <a:srgbClr val="20242B"/>
-                </a:solidFill>
-                <a:latin typeface="Calibri"/>
-              </a:rPr>
-              <a:t/>
-            </a:r>
-          </a:p>
-          <a:p>
-            <a:r>
-              <a:rPr sz="1400" b="0">
-                <a:solidFill>
-                  <a:srgbClr val="20242B"/>
-                </a:solidFill>
-                <a:latin typeface="Calibri"/>
-              </a:rPr>
-              <a:t>Edge-device validation                  NEXT — Jetson Orin benchmark of the two-pass API</a:t>
-            </a:r>
-          </a:p>
-        </p:txBody>
-      </p:sp>
-      <p:sp>
-        <p:nvSpPr>
-          <p:cNvPr id="5" name="TextBox 4"/>
+              <a:rPr sz="1200" b="0">
+                <a:solidFill>
+                  <a:srgbClr val="20242B"/>
+                </a:solidFill>
+                <a:latin typeface="Calibri"/>
+              </a:rPr>
+              <a:t>v3 dense (327 ms) is</a:t>
+            </a:r>
+          </a:p>
+          <a:p>
+            <a:r>
+              <a:rPr sz="1200" b="0">
+                <a:solidFill>
+                  <a:srgbClr val="20242B"/>
+                </a:solidFill>
+                <a:latin typeface="Calibri"/>
+              </a:rPr>
+              <a:t>not the use case.</a:t>
+            </a:r>
+          </a:p>
+        </p:txBody>
+      </p:sp>
+      <p:sp>
+        <p:nvSpPr>
+          <p:cNvPr id="6" name="TextBox 5"/>
           <p:cNvSpPr txBox="1"/>
           <p:nvPr/>
         </p:nvSpPr>
         <p:spPr>
           <a:xfrm>
-            <a:off x="960120" y="5760720"/>
+            <a:off x="960120" y="5806440"/>
             <a:ext cx="10332720" cy="548640"/>
           </a:xfrm>
           <a:prstGeom prst="rect">
@@ -5650,14 +6342,14 @@
                 </a:solidFill>
                 <a:latin typeface="Calibri"/>
               </a:rPr>
-              <a:t>Takeaway   Two of three headline objectives are met; the remaining gap is quantified and has a targeted fix in flight.</a:t>
-            </a:r>
-          </a:p>
-        </p:txBody>
-      </p:sp>
-      <p:sp>
-        <p:nvSpPr>
-          <p:cNvPr id="6" name="TextBox 5"/>
+              <a:t>Takeaway   For sparse workloads (registration, tracking, mapping) v3 is strictly cheaper; parity latency, fewer params, O(N) scaling.</a:t>
+            </a:r>
+          </a:p>
+        </p:txBody>
+      </p:sp>
+      <p:sp>
+        <p:nvSpPr>
+          <p:cNvPr id="7" name="TextBox 6"/>
           <p:cNvSpPr txBox="1"/>
           <p:nvPr/>
         </p:nvSpPr>
@@ -5691,7 +6383,7 @@
       </p:sp>
       <p:sp>
         <p:nvSpPr>
-          <p:cNvPr id="7" name="TextBox 6"/>
+          <p:cNvPr id="8" name="TextBox 7"/>
           <p:cNvSpPr txBox="1"/>
           <p:nvPr/>
         </p:nvSpPr>
@@ -5718,7 +6410,7 @@
                 </a:solidFill>
                 <a:latin typeface="Calibri"/>
               </a:rPr>
-              <a:t>7</a:t>
+              <a:t>6</a:t>
             </a:r>
           </a:p>
         </p:txBody>
@@ -5770,7 +6462,7 @@
                 </a:solidFill>
                 <a:latin typeface="Calibri"/>
               </a:rPr>
-              <a:t>NEXT</a:t>
+              <a:t>INTERFACE</a:t>
             </a:r>
           </a:p>
         </p:txBody>
@@ -5804,7 +6496,7 @@
                 </a:solidFill>
                 <a:latin typeface="Calibri"/>
               </a:rPr>
-              <a:t>Next steps</a:t>
+              <a:t>How querying works — sizes, API, interactivity</a:t>
             </a:r>
           </a:p>
         </p:txBody>
@@ -5817,8 +6509,8 @@
         </p:nvSpPr>
         <p:spPr>
           <a:xfrm>
-            <a:off x="685800" y="1737360"/>
-            <a:ext cx="10515600" cy="3474720"/>
+            <a:off x="685800" y="1554480"/>
+            <a:ext cx="5760720" cy="2194560"/>
           </a:xfrm>
           <a:prstGeom prst="rect">
             <a:avLst/>
@@ -5832,18 +6524,29 @@
           <a:lstStyle/>
           <a:p>
             <a:r>
-              <a:rPr sz="1400" b="0">
-                <a:solidFill>
-                  <a:srgbClr val="20242B"/>
-                </a:solidFill>
-                <a:latin typeface="Calibri"/>
-              </a:rPr>
-              <a:t>1. Fourier PE ablation — same chairs recipe, +sub-cell encoding; targets 1px accuracy directly.</a:t>
-            </a:r>
-          </a:p>
-          <a:p>
-            <a:r>
-              <a:rPr sz="1400" b="0">
+              <a:rPr sz="1200" b="0">
+                <a:solidFill>
+                  <a:srgbClr val="20242B"/>
+                </a:solidFill>
+                <a:latin typeface="Calibri"/>
+              </a:rPr>
+              <a:t>Query = one continuous (x, y). N is free: 1 click to 479,232</a:t>
+            </a:r>
+          </a:p>
+          <a:p>
+            <a:r>
+              <a:rPr sz="1200" b="0">
+                <a:solidFill>
+                  <a:srgbClr val="20242B"/>
+                </a:solidFill>
+                <a:latin typeface="Calibri"/>
+              </a:rPr>
+              <a:t>(= dense at 384x1248). Sub-pixel coords are first-class.</a:t>
+            </a:r>
+          </a:p>
+          <a:p>
+            <a:r>
+              <a:rPr sz="1200" b="0">
                 <a:solidFill>
                   <a:srgbClr val="20242B"/>
                 </a:solidFill>
@@ -5854,68 +6557,46 @@
           </a:p>
           <a:p>
             <a:r>
-              <a:rPr sz="1400" b="0">
-                <a:solidFill>
-                  <a:srgbClr val="20242B"/>
-                </a:solidFill>
-                <a:latin typeface="Calibri"/>
-              </a:rPr>
-              <a:t>2. Mixed chairs + vkitti2_all training — one dataloader change; expected to hold 2.27 EPE while recovering precision.</a:t>
-            </a:r>
-          </a:p>
-          <a:p>
-            <a:r>
-              <a:rPr sz="1400" b="0">
-                <a:solidFill>
-                  <a:srgbClr val="20242B"/>
-                </a:solidFill>
-                <a:latin typeface="Calibri"/>
-              </a:rPr>
-              <a:t/>
-            </a:r>
-          </a:p>
-          <a:p>
-            <a:r>
-              <a:rPr sz="1400" b="0">
-                <a:solidFill>
-                  <a:srgbClr val="20242B"/>
-                </a:solidFill>
-                <a:latin typeface="Calibri"/>
-              </a:rPr>
-              <a:t>3. Jetson Orin benchmark — the O(N) story is strongest where dense flow cannot run at all.</a:t>
-            </a:r>
-          </a:p>
-          <a:p>
-            <a:r>
-              <a:rPr sz="1400" b="0">
-                <a:solidFill>
-                  <a:srgbClr val="20242B"/>
-                </a:solidFill>
-                <a:latin typeface="Calibri"/>
-              </a:rPr>
-              <a:t/>
-            </a:r>
-          </a:p>
-          <a:p>
-            <a:r>
-              <a:rPr sz="1400" b="0">
-                <a:solidFill>
-                  <a:srgbClr val="20242B"/>
-                </a:solidFill>
-                <a:latin typeface="Calibri"/>
-              </a:rPr>
-              <a:t>4. Thesis experiments — registration/mapping demo on advisor-provided survey imagery; Spring dataset for</a:t>
-            </a:r>
-          </a:p>
-          <a:p>
-            <a:r>
-              <a:rPr sz="1400" b="0">
-                <a:solidFill>
-                  <a:srgbClr val="20242B"/>
-                </a:solidFill>
-                <a:latin typeface="Calibri"/>
-              </a:rPr>
-              <a:t>    above-input-resolution querying (GT at 2x input resolution — a test only queryable decoders can take natively).</a:t>
+              <a:rPr sz="1200" b="0">
+                <a:solidFill>
+                  <a:srgbClr val="20242B"/>
+                </a:solidFill>
+                <a:latin typeface="Calibri"/>
+              </a:rPr>
+              <a:t>state = model.infer_coarse_state(img0, img1)   # 33 ms, once</a:t>
+            </a:r>
+          </a:p>
+          <a:p>
+            <a:r>
+              <a:rPr sz="1200" b="0">
+                <a:solidFill>
+                  <a:srgbClr val="20242B"/>
+                </a:solidFill>
+                <a:latin typeface="Calibri"/>
+              </a:rPr>
+              <a:t>flow  = model.decode_queries(state, query_coords=q)</a:t>
+            </a:r>
+          </a:p>
+          <a:p>
+            <a:r>
+              <a:rPr sz="1200" b="0">
+                <a:solidFill>
+                  <a:srgbClr val="20242B"/>
+                </a:solidFill>
+                <a:latin typeface="Calibri"/>
+              </a:rPr>
+              <a:t>        # q: [B, N, 2] pixels -&gt; [B, N, 2] flow, 1.6 ms</a:t>
+            </a:r>
+          </a:p>
+          <a:p>
+            <a:r>
+              <a:rPr sz="1200" b="0">
+                <a:solidFill>
+                  <a:srgbClr val="20242B"/>
+                </a:solidFill>
+                <a:latin typeface="Calibri"/>
+              </a:rPr>
+              <a:t>        # or target_h/w (any resolution), or adaptive_n</a:t>
             </a:r>
           </a:p>
         </p:txBody>
@@ -5928,8 +6609,8 @@
         </p:nvSpPr>
         <p:spPr>
           <a:xfrm>
-            <a:off x="960120" y="5760720"/>
-            <a:ext cx="10332720" cy="548640"/>
+            <a:off x="685800" y="3794760"/>
+            <a:ext cx="5760720" cy="1828800"/>
           </a:xfrm>
           <a:prstGeom prst="rect">
             <a:avLst/>
@@ -5943,13 +6624,481 @@
           <a:lstStyle/>
           <a:p>
             <a:r>
+              <a:rPr sz="1200" b="0">
+                <a:solidFill>
+                  <a:srgbClr val="20242B"/>
+                </a:solidFill>
+                <a:latin typeface="Calibri"/>
+              </a:rPr>
+              <a:t>Training setup: batch 4 (8 GB VRAM) · 4,096 queries/image</a:t>
+            </a:r>
+          </a:p>
+          <a:p>
+            <a:r>
+              <a:rPr sz="1200" b="0">
+                <a:solidFill>
+                  <a:srgbClr val="20242B"/>
+                </a:solidFill>
+                <a:latin typeface="Calibri"/>
+              </a:rPr>
+              <a:t>(3.1% of crop, half at motion boundaries) · datasets:</a:t>
+            </a:r>
+          </a:p>
+          <a:p>
+            <a:r>
+              <a:rPr sz="1200" b="0">
+                <a:solidFill>
+                  <a:srgbClr val="20242B"/>
+                </a:solidFill>
+                <a:latin typeface="Calibri"/>
+              </a:rPr>
+              <a:t>VKITTI2 6-variant (12,726 pairs) + FlyingChairs (22,232)</a:t>
+            </a:r>
+          </a:p>
+          <a:p>
+            <a:r>
+              <a:rPr sz="1200" b="0">
+                <a:solidFill>
+                  <a:srgbClr val="20242B"/>
+                </a:solidFill>
+                <a:latin typeface="Calibri"/>
+              </a:rPr>
+              <a:t>· AdamW OneCycle 2e-4 · backbone frozen</a:t>
+            </a:r>
+          </a:p>
+        </p:txBody>
+      </p:sp>
+      <p:pic>
+        <p:nvPicPr>
+          <p:cNvPr id="6" name="Picture 5" descr="query_gui_selftest.png"/>
+          <p:cNvPicPr>
+            <a:picLocks noChangeAspect="1"/>
+          </p:cNvPicPr>
+          <p:nvPr/>
+        </p:nvPicPr>
+        <p:blipFill>
+          <a:blip r:embed="rId2"/>
+          <a:stretch>
+            <a:fillRect/>
+          </a:stretch>
+        </p:blipFill>
+        <p:spPr>
+          <a:xfrm>
+            <a:off x="6675120" y="1554480"/>
+            <a:ext cx="4846320" cy="1463261"/>
+          </a:xfrm>
+          <a:prstGeom prst="rect">
+            <a:avLst/>
+          </a:prstGeom>
+        </p:spPr>
+      </p:pic>
+      <p:sp>
+        <p:nvSpPr>
+          <p:cNvPr id="7" name="TextBox 6"/>
+          <p:cNvSpPr txBox="1"/>
+          <p:nvPr/>
+        </p:nvSpPr>
+        <p:spPr>
+          <a:xfrm>
+            <a:off x="6675120" y="3291840"/>
+            <a:ext cx="4846320" cy="1463040"/>
+          </a:xfrm>
+          <a:prstGeom prst="rect">
+            <a:avLst/>
+          </a:prstGeom>
+          <a:noFill/>
+        </p:spPr>
+        <p:txBody>
+          <a:bodyPr wrap="square">
+            <a:spAutoFit/>
+          </a:bodyPr>
+          <a:lstStyle/>
+          <a:p>
+            <a:r>
+              <a:rPr sz="1100" b="0">
+                <a:solidFill>
+                  <a:srgbClr val="20242B"/>
+                </a:solidFill>
+                <a:latin typeface="Calibri"/>
+              </a:rPr>
+              <a:t>Interactive query selector (PyQt5, working):</a:t>
+            </a:r>
+          </a:p>
+          <a:p>
+            <a:r>
+              <a:rPr sz="1100" b="0">
+                <a:solidFill>
+                  <a:srgbClr val="20242B"/>
+                </a:solidFill>
+                <a:latin typeface="Calibri"/>
+              </a:rPr>
+              <a:t>click = flow at that pixel in ~1.6 ms; G = 32x32 grid.</a:t>
+            </a:r>
+          </a:p>
+          <a:p>
+            <a:r>
+              <a:rPr sz="1100" b="0">
+                <a:solidFill>
+                  <a:srgbClr val="20242B"/>
+                </a:solidFill>
+                <a:latin typeface="Calibri"/>
+              </a:rPr>
+              <a:t>Viable precisely because of the two-pass API —</a:t>
+            </a:r>
+          </a:p>
+          <a:p>
+            <a:r>
+              <a:rPr sz="1100" b="0">
+                <a:solidFill>
+                  <a:srgbClr val="20242B"/>
+                </a:solidFill>
+                <a:latin typeface="Calibri"/>
+              </a:rPr>
+              <a:t>v2 would recompute the full frame per click.</a:t>
+            </a:r>
+          </a:p>
+        </p:txBody>
+      </p:sp>
+      <p:sp>
+        <p:nvSpPr>
+          <p:cNvPr id="8" name="TextBox 7"/>
+          <p:cNvSpPr txBox="1"/>
+          <p:nvPr/>
+        </p:nvSpPr>
+        <p:spPr>
+          <a:xfrm>
+            <a:off x="960120" y="5760720"/>
+            <a:ext cx="10332720" cy="548640"/>
+          </a:xfrm>
+          <a:prstGeom prst="rect">
+            <a:avLst/>
+          </a:prstGeom>
+          <a:noFill/>
+        </p:spPr>
+        <p:txBody>
+          <a:bodyPr wrap="square">
+            <a:spAutoFit/>
+          </a:bodyPr>
+          <a:lstStyle/>
+          <a:p>
+            <a:r>
               <a:rPr sz="1150" b="1">
                 <a:solidFill>
                   <a:srgbClr val="1F4E79"/>
                 </a:solidFill>
                 <a:latin typeface="Calibri"/>
               </a:rPr>
-              <a:t>Takeaway   The architecture is validated; remaining work is training composition and edge deployment.</a:t>
+              <a:t>Takeaway   scripts/query_gui.py demonstrates flow-on-demand; the same API serves robots and humans.</a:t>
+            </a:r>
+          </a:p>
+        </p:txBody>
+      </p:sp>
+      <p:sp>
+        <p:nvSpPr>
+          <p:cNvPr id="9" name="TextBox 8"/>
+          <p:cNvSpPr txBox="1"/>
+          <p:nvPr/>
+        </p:nvSpPr>
+        <p:spPr>
+          <a:xfrm>
+            <a:off x="685800" y="6419088"/>
+            <a:ext cx="7315200" cy="274320"/>
+          </a:xfrm>
+          <a:prstGeom prst="rect">
+            <a:avLst/>
+          </a:prstGeom>
+          <a:noFill/>
+        </p:spPr>
+        <p:txBody>
+          <a:bodyPr wrap="square">
+            <a:spAutoFit/>
+          </a:bodyPr>
+          <a:lstStyle/>
+          <a:p>
+            <a:r>
+              <a:rPr sz="900" b="0">
+                <a:solidFill>
+                  <a:srgbClr val="7B838F"/>
+                </a:solidFill>
+                <a:latin typeface="Calibri"/>
+              </a:rPr>
+              <a:t>NeuFlow v3  ·  status</a:t>
+            </a:r>
+          </a:p>
+        </p:txBody>
+      </p:sp>
+      <p:sp>
+        <p:nvSpPr>
+          <p:cNvPr id="10" name="TextBox 9"/>
+          <p:cNvSpPr txBox="1"/>
+          <p:nvPr/>
+        </p:nvSpPr>
+        <p:spPr>
+          <a:xfrm>
+            <a:off x="10607040" y="6419088"/>
+            <a:ext cx="1097280" cy="274320"/>
+          </a:xfrm>
+          <a:prstGeom prst="rect">
+            <a:avLst/>
+          </a:prstGeom>
+          <a:noFill/>
+        </p:spPr>
+        <p:txBody>
+          <a:bodyPr wrap="square">
+            <a:spAutoFit/>
+          </a:bodyPr>
+          <a:lstStyle/>
+          <a:p>
+            <a:r>
+              <a:rPr sz="900" b="0">
+                <a:solidFill>
+                  <a:srgbClr val="7B838F"/>
+                </a:solidFill>
+                <a:latin typeface="Calibri"/>
+              </a:rPr>
+              <a:t>8</a:t>
+            </a:r>
+          </a:p>
+        </p:txBody>
+      </p:sp>
+    </p:spTree>
+  </p:cSld>
+  <p:clrMapOvr>
+    <a:masterClrMapping/>
+  </p:clrMapOvr>
+</p:sld>
+</file>
+
+<file path=ppt/slides/slide9.xml><?xml version="1.0" encoding="utf-8"?>
+<p:sld xmlns:a="http://schemas.openxmlformats.org/drawingml/2006/main" xmlns:p="http://schemas.openxmlformats.org/presentationml/2006/main" xmlns:r="http://schemas.openxmlformats.org/officeDocument/2006/relationships">
+  <p:cSld>
+    <p:spTree>
+      <p:nvGrpSpPr>
+        <p:cNvPr id="1" name=""/>
+        <p:cNvGrpSpPr/>
+        <p:nvPr/>
+      </p:nvGrpSpPr>
+      <p:grpSpPr/>
+      <p:sp>
+        <p:nvSpPr>
+          <p:cNvPr id="2" name="TextBox 1"/>
+          <p:cNvSpPr txBox="1"/>
+          <p:nvPr/>
+        </p:nvSpPr>
+        <p:spPr>
+          <a:xfrm>
+            <a:off x="685800" y="384048"/>
+            <a:ext cx="10058400" cy="274320"/>
+          </a:xfrm>
+          <a:prstGeom prst="rect">
+            <a:avLst/>
+          </a:prstGeom>
+          <a:noFill/>
+        </p:spPr>
+        <p:txBody>
+          <a:bodyPr wrap="square">
+            <a:spAutoFit/>
+          </a:bodyPr>
+          <a:lstStyle/>
+          <a:p>
+            <a:r>
+              <a:rPr sz="1050" b="1">
+                <a:solidFill>
+                  <a:srgbClr val="1F4E79"/>
+                </a:solidFill>
+                <a:latin typeface="Calibri"/>
+              </a:rPr>
+              <a:t>OBJECTIVES</a:t>
+            </a:r>
+          </a:p>
+        </p:txBody>
+      </p:sp>
+      <p:sp>
+        <p:nvSpPr>
+          <p:cNvPr id="3" name="TextBox 2"/>
+          <p:cNvSpPr txBox="1"/>
+          <p:nvPr/>
+        </p:nvSpPr>
+        <p:spPr>
+          <a:xfrm>
+            <a:off x="667512" y="658368"/>
+            <a:ext cx="10789920" cy="731520"/>
+          </a:xfrm>
+          <a:prstGeom prst="rect">
+            <a:avLst/>
+          </a:prstGeom>
+          <a:noFill/>
+        </p:spPr>
+        <p:txBody>
+          <a:bodyPr wrap="square">
+            <a:spAutoFit/>
+          </a:bodyPr>
+          <a:lstStyle/>
+          <a:p>
+            <a:r>
+              <a:rPr sz="2400" b="1">
+                <a:solidFill>
+                  <a:srgbClr val="20242B"/>
+                </a:solidFill>
+                <a:latin typeface="Calibri"/>
+              </a:rPr>
+              <a:t>Better EPE at less compute, edge-capable — where we stand</a:t>
+            </a:r>
+          </a:p>
+        </p:txBody>
+      </p:sp>
+      <p:sp>
+        <p:nvSpPr>
+          <p:cNvPr id="4" name="TextBox 3"/>
+          <p:cNvSpPr txBox="1"/>
+          <p:nvPr/>
+        </p:nvSpPr>
+        <p:spPr>
+          <a:xfrm>
+            <a:off x="685800" y="1737360"/>
+            <a:ext cx="10515600" cy="3566160"/>
+          </a:xfrm>
+          <a:prstGeom prst="rect">
+            <a:avLst/>
+          </a:prstGeom>
+          <a:noFill/>
+        </p:spPr>
+        <p:txBody>
+          <a:bodyPr wrap="square">
+            <a:spAutoFit/>
+          </a:bodyPr>
+          <a:lstStyle/>
+          <a:p>
+            <a:r>
+              <a:rPr sz="1400" b="0">
+                <a:solidFill>
+                  <a:srgbClr val="20242B"/>
+                </a:solidFill>
+                <a:latin typeface="Calibri"/>
+              </a:rPr>
+              <a:t>Beat v2 mean EPE                        DONE — 2.275 vs 2.324 (chairs-only training)</a:t>
+            </a:r>
+          </a:p>
+          <a:p>
+            <a:r>
+              <a:rPr sz="1400" b="0">
+                <a:solidFill>
+                  <a:srgbClr val="20242B"/>
+                </a:solidFill>
+                <a:latin typeface="Calibri"/>
+              </a:rPr>
+              <a:t/>
+            </a:r>
+          </a:p>
+          <a:p>
+            <a:r>
+              <a:rPr sz="1400" b="0">
+                <a:solidFill>
+                  <a:srgbClr val="20242B"/>
+                </a:solidFill>
+                <a:latin typeface="Calibri"/>
+              </a:rPr>
+              <a:t>Less compute (sparse use case)          DONE — ~35 ms total, O(N) queries, 13% fewer params, 2.2 GB VRAM</a:t>
+            </a:r>
+          </a:p>
+          <a:p>
+            <a:r>
+              <a:rPr sz="1400" b="0">
+                <a:solidFill>
+                  <a:srgbClr val="20242B"/>
+                </a:solidFill>
+                <a:latin typeface="Calibri"/>
+              </a:rPr>
+              <a:t/>
+            </a:r>
+          </a:p>
+          <a:p>
+            <a:r>
+              <a:rPr sz="1400" b="0">
+                <a:solidFill>
+                  <a:srgbClr val="20242B"/>
+                </a:solidFill>
+                <a:latin typeface="Calibri"/>
+              </a:rPr>
+              <a:t>Sub-pixel precision parity (1px acc)    IN PROGRESS — Fourier PE ablation (training in progress)</a:t>
+            </a:r>
+          </a:p>
+          <a:p>
+            <a:r>
+              <a:rPr sz="1400" b="0">
+                <a:solidFill>
+                  <a:srgbClr val="20242B"/>
+                </a:solidFill>
+                <a:latin typeface="Calibri"/>
+              </a:rPr>
+              <a:t/>
+            </a:r>
+          </a:p>
+          <a:p>
+            <a:r>
+              <a:rPr sz="1400" b="0">
+                <a:solidFill>
+                  <a:srgbClr val="20242B"/>
+                </a:solidFill>
+                <a:latin typeface="Calibri"/>
+              </a:rPr>
+              <a:t>Combine chairs + vkitti2 strengths      NEXT — mixed-dataset training (forgetting measured and understood)</a:t>
+            </a:r>
+          </a:p>
+          <a:p>
+            <a:r>
+              <a:rPr sz="1400" b="0">
+                <a:solidFill>
+                  <a:srgbClr val="20242B"/>
+                </a:solidFill>
+                <a:latin typeface="Calibri"/>
+              </a:rPr>
+              <a:t/>
+            </a:r>
+          </a:p>
+          <a:p>
+            <a:r>
+              <a:rPr sz="1400" b="0">
+                <a:solidFill>
+                  <a:srgbClr val="20242B"/>
+                </a:solidFill>
+                <a:latin typeface="Calibri"/>
+              </a:rPr>
+              <a:t>Edge-device validation                  NEXT — Jetson Orin benchmark of the two-pass API</a:t>
+            </a:r>
+          </a:p>
+        </p:txBody>
+      </p:sp>
+      <p:sp>
+        <p:nvSpPr>
+          <p:cNvPr id="5" name="TextBox 4"/>
+          <p:cNvSpPr txBox="1"/>
+          <p:nvPr/>
+        </p:nvSpPr>
+        <p:spPr>
+          <a:xfrm>
+            <a:off x="960120" y="5760720"/>
+            <a:ext cx="10332720" cy="548640"/>
+          </a:xfrm>
+          <a:prstGeom prst="rect">
+            <a:avLst/>
+          </a:prstGeom>
+          <a:noFill/>
+        </p:spPr>
+        <p:txBody>
+          <a:bodyPr wrap="square">
+            <a:spAutoFit/>
+          </a:bodyPr>
+          <a:lstStyle/>
+          <a:p>
+            <a:r>
+              <a:rPr sz="1150" b="1">
+                <a:solidFill>
+                  <a:srgbClr val="1F4E79"/>
+                </a:solidFill>
+                <a:latin typeface="Calibri"/>
+              </a:rPr>
+              <a:t>Takeaway   Two of three headline objectives are met; the remaining gap is quantified and has a targeted fix in flight.</a:t>
             </a:r>
           </a:p>
         </p:txBody>
@@ -6017,7 +7166,7 @@
                 </a:solidFill>
                 <a:latin typeface="Calibri"/>
               </a:rPr>
-              <a:t>8</a:t>
+              <a:t>7</a:t>
             </a:r>
           </a:p>
         </p:txBody>

</xml_diff>

<commit_message>
PE ablation result: null — sub-cell positional signal is not the 1px bottleneck
chairs+PE 2.288 EPE / 69.7% 1px vs no-PE 2.275 / 69.7%. Hypothesis falsified cleanly;
remaining suspects: 1/8 coarse-flow resolution bound, large-motion-only supervision.
Deck, report, and parameter log updated.

Co-Authored-By: Claude Fable 5 <noreply@anthropic.com>
</commit_message>
<xml_diff>
--- a/docs/NeuFlow_v3_status.pptx
+++ b/docs/NeuFlow_v3_status.pptx
@@ -4587,7 +4587,7 @@
                 </a:solidFill>
                 <a:latin typeface="Calibri"/>
               </a:rPr>
-              <a:t>awareness) — training in progress.</a:t>
+              <a:t>awareness) — measured: no effect (2.29 EPE, 69.7% 1px = no-PE run); sub-cell position is NOT the 1px bottleneck.</a:t>
             </a:r>
           </a:p>
         </p:txBody>
@@ -5596,7 +5596,7 @@
                 </a:solidFill>
                 <a:latin typeface="Calibri"/>
               </a:rPr>
-              <a:t>(training in progress).</a:t>
+              <a:t>(measured: no effect (2.29 EPE, 69.7% 1px = no-PE run); sub-cell position is NOT the 1px bottleneck).</a:t>
             </a:r>
           </a:p>
         </p:txBody>
@@ -7020,7 +7020,18 @@
                 </a:solidFill>
                 <a:latin typeface="Calibri"/>
               </a:rPr>
-              <a:t>Sub-pixel precision parity (1px acc)    IN PROGRESS — Fourier PE ablation (training in progress)</a:t>
+              <a:t>Sub-pixel precision parity (1px acc)    OPEN — PE ablation was null: gap is not positional signal.</a:t>
+            </a:r>
+          </a:p>
+          <a:p>
+            <a:r>
+              <a:rPr sz="1400" b="0">
+                <a:solidFill>
+                  <a:srgbClr val="20242B"/>
+                </a:solidFill>
+                <a:latin typeface="Calibri"/>
+              </a:rPr>
+              <a:t>                                        Next hypothesis: 1/8 coarse-flow resolution bound; test via vkitti2+PE or finer scale</a:t>
             </a:r>
           </a:p>
           <a:p>

</xml_diff>

<commit_message>
Mixed-dataset result: 2.183 EPE / 76.4% 1px — best to date, beats v2 by 6% with near-parity precision
</commit_message>
<xml_diff>
--- a/docs/NeuFlow_v3_status.pptx
+++ b/docs/NeuFlow_v3_status.pptx
@@ -3957,7 +3957,7 @@
                 </a:solidFill>
                 <a:latin typeface="Calibri"/>
               </a:rPr>
-              <a:t>Objective 1 — exceed NeuFlow v2’s accuracy.  Met on mean EPE: 2.28 vs 2.32 px, achieved by the</a:t>
+              <a:t>Objective 1 — exceed NeuFlow v2’s accuracy.  Met: 2.18 vs 2.32 px mean EPE (6% better), achieved by</a:t>
             </a:r>
           </a:p>
           <a:p>
@@ -3973,7 +3973,7 @@
                 </a:solidFill>
                 <a:latin typeface="Calibri"/>
               </a:rPr>
-              <a:t>FlyingChairs-trained decoder. Sub-pixel precision (1 px accuracy) remains 5–8 points behind and is the</a:t>
+              <a:t>mixed chairs+VKITTI2 training. Sub-pixel precision is now within 1.2 points of v2 (76.4% vs 77.6%) and</a:t>
             </a:r>
           </a:p>
           <a:p>
@@ -3989,23 +3989,7 @@
                 </a:solidFill>
                 <a:latin typeface="Calibri"/>
               </a:rPr>
-              <a:t>active workstream; position encoding has been ruled out as the cause, focusing attention on coarse-flow</a:t>
-            </a:r>
-          </a:p>
-          <a:p>
-            <a:pPr>
-              <a:lnSpc>
-                <a:spcPct val="100000"/>
-              </a:lnSpc>
-            </a:pPr>
-            <a:r>
-              <a:rPr sz="1300" b="0">
-                <a:solidFill>
-                  <a:srgbClr val="20242B"/>
-                </a:solidFill>
-                <a:latin typeface="Calibri"/>
-              </a:rPr>
-              <a:t>resolution and training-motion statistics.</a:t>
+              <a:t>3 px accuracy is at parity (89.6% vs 89.8%).</a:t>
             </a:r>
           </a:p>
           <a:p>
@@ -4369,7 +4353,7 @@
                 </a:solidFill>
                 <a:latin typeface="Calibri"/>
               </a:rPr>
-              <a:t>Running now: mixed-dataset training</a:t>
+              <a:t>Completed: mixed-dataset training</a:t>
             </a:r>
           </a:p>
           <a:p>
@@ -4433,7 +4417,7 @@
                 </a:solidFill>
                 <a:latin typeface="Calibri"/>
               </a:rPr>
-              <a:t>recipe. Hypothesis: joint exposure preserves the chairs</a:t>
+              <a:t>recipe. Result: hypothesis confirmed — 2.18 px EPE with</a:t>
             </a:r>
           </a:p>
           <a:p>
@@ -4449,7 +4433,7 @@
                 </a:solidFill>
                 <a:latin typeface="Calibri"/>
               </a:rPr>
-              <a:t>error-tail robustness while the driving data restores</a:t>
+              <a:t>76.4% 1 px accuracy; the chairs robustness and the</a:t>
             </a:r>
           </a:p>
           <a:p>
@@ -4465,23 +4449,7 @@
                 </a:solidFill>
                 <a:latin typeface="Calibri"/>
               </a:rPr>
-              <a:t>sub-pixel precision — the combination that sequential</a:t>
-            </a:r>
-          </a:p>
-          <a:p>
-            <a:pPr>
-              <a:lnSpc>
-                <a:spcPct val="100000"/>
-              </a:lnSpc>
-            </a:pPr>
-            <a:r>
-              <a:rPr sz="1250" b="0">
-                <a:solidFill>
-                  <a:srgbClr val="20242B"/>
-                </a:solidFill>
-                <a:latin typeface="Calibri"/>
-              </a:rPr>
-              <a:t>finetuning provably forgot.</a:t>
+              <a:t>driving-data precision coexist under joint sampling.</a:t>
             </a:r>
           </a:p>
           <a:p>
@@ -9517,7 +9485,7 @@
                 </a:solidFill>
                 <a:latin typeface="Calibri"/>
               </a:rPr>
-              <a:t>Mixed-dataset training: training in progress.</a:t>
+              <a:t>Mixed-dataset training: 2.18 px EPE, 76.4% 1 px, 89.6% 3 px — best result to date; both parents’ strengths retained.</a:t>
             </a:r>
           </a:p>
         </p:txBody>

</xml_diff>

<commit_message>
Single authoritative deck: archive old update deck, interface slide covers all GUI capabilities
</commit_message>
<xml_diff>
--- a/docs/NeuFlow_v3_status.pptx
+++ b/docs/NeuFlow_v3_status.pptx
@@ -4300,7 +4300,7 @@
         <p:spPr>
           <a:xfrm>
             <a:off x="6675120" y="3246120"/>
-            <a:ext cx="4937760" cy="1554480"/>
+            <a:ext cx="4937760" cy="2286000"/>
           </a:xfrm>
           <a:prstGeom prst="rect">
             <a:avLst/>
@@ -4319,61 +4319,157 @@
               </a:lnSpc>
             </a:pPr>
             <a:r>
-              <a:rPr sz="1100" b="0">
-                <a:solidFill>
-                  <a:srgbClr val="1A1A1A"/>
-                </a:solidFill>
-                <a:latin typeface="Calibri"/>
-              </a:rPr>
-              <a:t>Interactive tool (PyQt5, in the repository): click any pixel</a:t>
-            </a:r>
-          </a:p>
-          <a:p>
-            <a:pPr algn="l">
-              <a:lnSpc>
-                <a:spcPct val="100000"/>
-              </a:lnSpc>
-            </a:pPr>
-            <a:r>
-              <a:rPr sz="1100" b="0">
-                <a:solidFill>
-                  <a:srgbClr val="1A1A1A"/>
-                </a:solidFill>
-                <a:latin typeface="Calibri"/>
-              </a:rPr>
-              <a:t>for its flow; grid, boundary-adaptive, and dense-overlay</a:t>
-            </a:r>
-          </a:p>
-          <a:p>
-            <a:pPr algn="l">
-              <a:lnSpc>
-                <a:spcPct val="100000"/>
-              </a:lnSpc>
-            </a:pPr>
-            <a:r>
-              <a:rPr sz="1100" b="0">
-                <a:solidFill>
-                  <a:srgbClr val="1A1A1A"/>
-                </a:solidFill>
-                <a:latin typeface="Calibri"/>
-              </a:rPr>
-              <a:t>modes; CSV export. Feasible only because of the two-pass</a:t>
-            </a:r>
-          </a:p>
-          <a:p>
-            <a:pPr algn="l">
-              <a:lnSpc>
-                <a:spcPct val="100000"/>
-              </a:lnSpc>
-            </a:pPr>
-            <a:r>
-              <a:rPr sz="1100" b="0">
-                <a:solidFill>
-                  <a:srgbClr val="1A1A1A"/>
-                </a:solidFill>
-                <a:latin typeface="Calibri"/>
-              </a:rPr>
-              <a:t>design — every interaction reuses the cached backbone state.</a:t>
+              <a:rPr sz="1050" b="0">
+                <a:solidFill>
+                  <a:srgbClr val="1A1A1A"/>
+                </a:solidFill>
+                <a:latin typeface="Calibri"/>
+              </a:rPr>
+              <a:t>Interactive tool (PyQt5, in the repository):</a:t>
+            </a:r>
+          </a:p>
+          <a:p>
+            <a:pPr algn="l">
+              <a:lnSpc>
+                <a:spcPct val="100000"/>
+              </a:lnSpc>
+            </a:pPr>
+            <a:r>
+              <a:rPr sz="1050" b="0">
+                <a:solidFill>
+                  <a:srgbClr val="1A1A1A"/>
+                </a:solidFill>
+                <a:latin typeface="Calibri"/>
+              </a:rPr>
+              <a:t>•  Click any pixel for its flow; grid, boundary-adaptive,</a:t>
+            </a:r>
+          </a:p>
+          <a:p>
+            <a:pPr algn="l">
+              <a:lnSpc>
+                <a:spcPct val="100000"/>
+              </a:lnSpc>
+            </a:pPr>
+            <a:r>
+              <a:rPr sz="1050" b="0">
+                <a:solidFill>
+                  <a:srgbClr val="1A1A1A"/>
+                </a:solidFill>
+                <a:latin typeface="Calibri"/>
+              </a:rPr>
+              <a:t>    and dense-overlay modes; CSV export.</a:t>
+            </a:r>
+          </a:p>
+          <a:p>
+            <a:pPr algn="l">
+              <a:lnSpc>
+                <a:spcPct val="100000"/>
+              </a:lnSpc>
+            </a:pPr>
+            <a:r>
+              <a:rPr sz="1050" b="0">
+                <a:solidFill>
+                  <a:srgbClr val="1A1A1A"/>
+                </a:solidFill>
+                <a:latin typeface="Calibri"/>
+              </a:rPr>
+              <a:t>•  Region window: drag a rectangle — flow computed</a:t>
+            </a:r>
+          </a:p>
+          <a:p>
+            <a:pPr algn="l">
+              <a:lnSpc>
+                <a:spcPct val="100000"/>
+              </a:lnSpc>
+            </a:pPr>
+            <a:r>
+              <a:rPr sz="1050" b="0">
+                <a:solidFill>
+                  <a:srgbClr val="1A1A1A"/>
+                </a:solidFill>
+                <a:latin typeface="Calibri"/>
+              </a:rPr>
+              <a:t>    only inside the selection.</a:t>
+            </a:r>
+          </a:p>
+          <a:p>
+            <a:pPr algn="l">
+              <a:lnSpc>
+                <a:spcPct val="100000"/>
+              </a:lnSpc>
+            </a:pPr>
+            <a:r>
+              <a:rPr sz="1050" b="0">
+                <a:solidFill>
+                  <a:srgbClr val="1A1A1A"/>
+                </a:solidFill>
+                <a:latin typeface="Calibri"/>
+              </a:rPr>
+              <a:t>•  Video and YouTube sources with frame stepping and</a:t>
+            </a:r>
+          </a:p>
+          <a:p>
+            <a:pPr algn="l">
+              <a:lnSpc>
+                <a:spcPct val="100000"/>
+              </a:lnSpc>
+            </a:pPr>
+            <a:r>
+              <a:rPr sz="1050" b="0">
+                <a:solidFill>
+                  <a:srgbClr val="1A1A1A"/>
+                </a:solidFill>
+                <a:latin typeface="Calibri"/>
+              </a:rPr>
+              <a:t>    real-time playback: live flow-based motion boxes at</a:t>
+            </a:r>
+          </a:p>
+          <a:p>
+            <a:pPr algn="l">
+              <a:lnSpc>
+                <a:spcPct val="100000"/>
+              </a:lnSpc>
+            </a:pPr>
+            <a:r>
+              <a:rPr sz="1050" b="0">
+                <a:solidFill>
+                  <a:srgbClr val="1A1A1A"/>
+                </a:solidFill>
+                <a:latin typeface="Calibri"/>
+              </a:rPr>
+              <a:t>    47 FPS (640×360), ego-motion compensated.</a:t>
+            </a:r>
+          </a:p>
+          <a:p>
+            <a:pPr algn="l">
+              <a:lnSpc>
+                <a:spcPct val="100000"/>
+              </a:lnSpc>
+            </a:pPr>
+            <a:r>
+              <a:rPr sz="1050" b="0">
+                <a:solidFill>
+                  <a:srgbClr val="1A1A1A"/>
+                </a:solidFill>
+                <a:latin typeface="Calibri"/>
+              </a:rPr>
+              <a:t>•  System-resources tab: live FPS, latency, GPU, VRAM,</a:t>
+            </a:r>
+          </a:p>
+          <a:p>
+            <a:pPr algn="l">
+              <a:lnSpc>
+                <a:spcPct val="100000"/>
+              </a:lnSpc>
+            </a:pPr>
+            <a:r>
+              <a:rPr sz="1050" b="0">
+                <a:solidFill>
+                  <a:srgbClr val="1A1A1A"/>
+                </a:solidFill>
+                <a:latin typeface="Calibri"/>
+              </a:rPr>
+              <a:t>    CPU, RAM graphs — VRAM stays flat while interacting.</a:t>
             </a:r>
           </a:p>
         </p:txBody>

</xml_diff>

<commit_message>
Add 17 speaker notes to deck; log end-to-end distillation result (negative: 2.398, below v2 -- coarse-only gain did not transfer)
</commit_message>
<xml_diff>
--- a/docs/NeuFlow_v3_status.pptx
+++ b/docs/NeuFlow_v3_status.pptx
@@ -121,6 +121,1546 @@
     </a:lvl9pPr>
   </p:defaultTextStyle>
 </p:presentation>
+</file>
+
+<file path=ppt/notesMasters/notesMaster1.xml><?xml version="1.0" encoding="utf-8"?>
+<p:notesMaster xmlns:a="http://schemas.openxmlformats.org/drawingml/2006/main" xmlns:p="http://schemas.openxmlformats.org/presentationml/2006/main" xmlns:r="http://schemas.openxmlformats.org/officeDocument/2006/relationships">
+  <p:cSld>
+    <p:bg>
+      <p:bgRef idx="1001">
+        <a:schemeClr val="bg1"/>
+      </p:bgRef>
+    </p:bg>
+    <p:spTree>
+      <p:nvGrpSpPr>
+        <p:cNvPr id="1" name=""/>
+        <p:cNvGrpSpPr/>
+        <p:nvPr/>
+      </p:nvGrpSpPr>
+      <p:grpSpPr>
+        <a:xfrm>
+          <a:off x="0" y="0"/>
+          <a:ext cx="0" cy="0"/>
+          <a:chOff x="0" y="0"/>
+          <a:chExt cx="0" cy="0"/>
+        </a:xfrm>
+      </p:grpSpPr>
+      <p:sp>
+        <p:nvSpPr>
+          <p:cNvPr id="2" name="Header Placeholder 1"/>
+          <p:cNvSpPr>
+            <a:spLocks noGrp="1"/>
+          </p:cNvSpPr>
+          <p:nvPr>
+            <p:ph type="hdr" sz="quarter"/>
+          </p:nvPr>
+        </p:nvSpPr>
+        <p:spPr>
+          <a:xfrm>
+            <a:off x="0" y="0"/>
+            <a:ext cx="2971800" cy="457200"/>
+          </a:xfrm>
+          <a:prstGeom prst="rect">
+            <a:avLst/>
+          </a:prstGeom>
+        </p:spPr>
+        <p:txBody>
+          <a:bodyPr vert="horz" lIns="91440" tIns="45720" rIns="91440" bIns="45720" rtlCol="0"/>
+          <a:lstStyle>
+            <a:lvl1pPr algn="l">
+              <a:defRPr sz="1200"/>
+            </a:lvl1pPr>
+          </a:lstStyle>
+          <a:p>
+            <a:endParaRPr lang="en-US"/>
+          </a:p>
+        </p:txBody>
+      </p:sp>
+      <p:sp>
+        <p:nvSpPr>
+          <p:cNvPr id="3" name="Date Placeholder 2"/>
+          <p:cNvSpPr>
+            <a:spLocks noGrp="1"/>
+          </p:cNvSpPr>
+          <p:nvPr>
+            <p:ph type="dt" idx="1"/>
+          </p:nvPr>
+        </p:nvSpPr>
+        <p:spPr>
+          <a:xfrm>
+            <a:off x="3884613" y="0"/>
+            <a:ext cx="2971800" cy="457200"/>
+          </a:xfrm>
+          <a:prstGeom prst="rect">
+            <a:avLst/>
+          </a:prstGeom>
+        </p:spPr>
+        <p:txBody>
+          <a:bodyPr vert="horz" lIns="91440" tIns="45720" rIns="91440" bIns="45720" rtlCol="0"/>
+          <a:lstStyle>
+            <a:lvl1pPr algn="r">
+              <a:defRPr sz="1200"/>
+            </a:lvl1pPr>
+          </a:lstStyle>
+          <a:p>
+            <a:fld id="{0F89C1C7-3DCD-1040-A9CF-14679D8B5DDD}" type="datetimeFigureOut">
+              <a:rPr lang="en-US" smtClean="0"/>
+              <a:t>10/17/16</a:t>
+            </a:fld>
+            <a:endParaRPr lang="en-US"/>
+          </a:p>
+        </p:txBody>
+      </p:sp>
+      <p:sp>
+        <p:nvSpPr>
+          <p:cNvPr id="4" name="Slide Image Placeholder 3"/>
+          <p:cNvSpPr>
+            <a:spLocks noGrp="1" noRot="1" noChangeAspect="1"/>
+          </p:cNvSpPr>
+          <p:nvPr>
+            <p:ph type="sldImg" idx="2"/>
+          </p:nvPr>
+        </p:nvSpPr>
+        <p:spPr>
+          <a:xfrm>
+            <a:off x="1143000" y="685800"/>
+            <a:ext cx="4572000" cy="3429000"/>
+          </a:xfrm>
+          <a:prstGeom prst="rect">
+            <a:avLst/>
+          </a:prstGeom>
+          <a:noFill/>
+          <a:ln w="12700">
+            <a:solidFill>
+              <a:prstClr val="black"/>
+            </a:solidFill>
+          </a:ln>
+        </p:spPr>
+        <p:txBody>
+          <a:bodyPr vert="horz" lIns="91440" tIns="45720" rIns="91440" bIns="45720" rtlCol="0" anchor="ctr"/>
+          <a:lstStyle/>
+          <a:p>
+            <a:endParaRPr lang="en-US"/>
+          </a:p>
+        </p:txBody>
+      </p:sp>
+      <p:sp>
+        <p:nvSpPr>
+          <p:cNvPr id="5" name="Notes Placeholder 4"/>
+          <p:cNvSpPr>
+            <a:spLocks noGrp="1"/>
+          </p:cNvSpPr>
+          <p:nvPr>
+            <p:ph type="body" sz="quarter" idx="3"/>
+          </p:nvPr>
+        </p:nvSpPr>
+        <p:spPr>
+          <a:xfrm>
+            <a:off x="685800" y="4343400"/>
+            <a:ext cx="5486400" cy="4114800"/>
+          </a:xfrm>
+          <a:prstGeom prst="rect">
+            <a:avLst/>
+          </a:prstGeom>
+        </p:spPr>
+        <p:txBody>
+          <a:bodyPr vert="horz" lIns="91440" tIns="45720" rIns="91440" bIns="45720" rtlCol="0"/>
+          <a:lstStyle/>
+          <a:p>
+            <a:pPr lvl="0"/>
+            <a:r>
+              <a:rPr lang="en-US" smtClean="0"/>
+              <a:t>Click to edit Master text styles</a:t>
+            </a:r>
+          </a:p>
+          <a:p>
+            <a:pPr lvl="1"/>
+            <a:r>
+              <a:rPr lang="en-US" smtClean="0"/>
+              <a:t>Second level</a:t>
+            </a:r>
+          </a:p>
+          <a:p>
+            <a:pPr lvl="2"/>
+            <a:r>
+              <a:rPr lang="en-US" smtClean="0"/>
+              <a:t>Third level</a:t>
+            </a:r>
+          </a:p>
+          <a:p>
+            <a:pPr lvl="3"/>
+            <a:r>
+              <a:rPr lang="en-US" smtClean="0"/>
+              <a:t>Fourth level</a:t>
+            </a:r>
+          </a:p>
+          <a:p>
+            <a:pPr lvl="4"/>
+            <a:r>
+              <a:rPr lang="en-US" smtClean="0"/>
+              <a:t>Fifth level</a:t>
+            </a:r>
+            <a:endParaRPr lang="en-US"/>
+          </a:p>
+        </p:txBody>
+      </p:sp>
+      <p:sp>
+        <p:nvSpPr>
+          <p:cNvPr id="6" name="Footer Placeholder 5"/>
+          <p:cNvSpPr>
+            <a:spLocks noGrp="1"/>
+          </p:cNvSpPr>
+          <p:nvPr>
+            <p:ph type="ftr" sz="quarter" idx="4"/>
+          </p:nvPr>
+        </p:nvSpPr>
+        <p:spPr>
+          <a:xfrm>
+            <a:off x="0" y="8685213"/>
+            <a:ext cx="2971800" cy="457200"/>
+          </a:xfrm>
+          <a:prstGeom prst="rect">
+            <a:avLst/>
+          </a:prstGeom>
+        </p:spPr>
+        <p:txBody>
+          <a:bodyPr vert="horz" lIns="91440" tIns="45720" rIns="91440" bIns="45720" rtlCol="0" anchor="b"/>
+          <a:lstStyle>
+            <a:lvl1pPr algn="l">
+              <a:defRPr sz="1200"/>
+            </a:lvl1pPr>
+          </a:lstStyle>
+          <a:p>
+            <a:endParaRPr lang="en-US"/>
+          </a:p>
+        </p:txBody>
+      </p:sp>
+      <p:sp>
+        <p:nvSpPr>
+          <p:cNvPr id="7" name="Slide Number Placeholder 6"/>
+          <p:cNvSpPr>
+            <a:spLocks noGrp="1"/>
+          </p:cNvSpPr>
+          <p:nvPr>
+            <p:ph type="sldNum" sz="quarter" idx="5"/>
+          </p:nvPr>
+        </p:nvSpPr>
+        <p:spPr>
+          <a:xfrm>
+            <a:off x="3884613" y="8685213"/>
+            <a:ext cx="2971800" cy="457200"/>
+          </a:xfrm>
+          <a:prstGeom prst="rect">
+            <a:avLst/>
+          </a:prstGeom>
+        </p:spPr>
+        <p:txBody>
+          <a:bodyPr vert="horz" lIns="91440" tIns="45720" rIns="91440" bIns="45720" rtlCol="0" anchor="b"/>
+          <a:lstStyle>
+            <a:lvl1pPr algn="r">
+              <a:defRPr sz="1200"/>
+            </a:lvl1pPr>
+          </a:lstStyle>
+          <a:p>
+            <a:fld id="{BB5E49A5-4136-284D-997B-48E1D791AD67}" type="slidenum">
+              <a:rPr lang="en-US" smtClean="0"/>
+              <a:t>‹#›</a:t>
+            </a:fld>
+            <a:endParaRPr lang="en-US"/>
+          </a:p>
+        </p:txBody>
+      </p:sp>
+    </p:spTree>
+    <p:extLst>
+      <p:ext uri="{BB962C8B-B14F-4D97-AF65-F5344CB8AC3E}">
+        <p14:creationId xmlns:p14="http://schemas.microsoft.com/office/powerpoint/2010/main" val="2623252185"/>
+      </p:ext>
+    </p:extLst>
+  </p:cSld>
+  <p:clrMap bg1="lt1" tx1="dk1" bg2="lt2" tx2="dk2" accent1="accent1" accent2="accent2" accent3="accent3" accent4="accent4" accent5="accent5" accent6="accent6" hlink="hlink" folHlink="folHlink"/>
+  <p:notesStyle>
+    <a:lvl1pPr marL="0" algn="l" defTabSz="457200" rtl="0" eaLnBrk="1" latinLnBrk="0" hangingPunct="1">
+      <a:defRPr sz="1200" kern="1200">
+        <a:solidFill>
+          <a:schemeClr val="tx1"/>
+        </a:solidFill>
+        <a:latin typeface="+mn-lt"/>
+        <a:ea typeface="+mn-ea"/>
+        <a:cs typeface="+mn-cs"/>
+      </a:defRPr>
+    </a:lvl1pPr>
+    <a:lvl2pPr marL="457200" algn="l" defTabSz="457200" rtl="0" eaLnBrk="1" latinLnBrk="0" hangingPunct="1">
+      <a:defRPr sz="1200" kern="1200">
+        <a:solidFill>
+          <a:schemeClr val="tx1"/>
+        </a:solidFill>
+        <a:latin typeface="+mn-lt"/>
+        <a:ea typeface="+mn-ea"/>
+        <a:cs typeface="+mn-cs"/>
+      </a:defRPr>
+    </a:lvl2pPr>
+    <a:lvl3pPr marL="914400" algn="l" defTabSz="457200" rtl="0" eaLnBrk="1" latinLnBrk="0" hangingPunct="1">
+      <a:defRPr sz="1200" kern="1200">
+        <a:solidFill>
+          <a:schemeClr val="tx1"/>
+        </a:solidFill>
+        <a:latin typeface="+mn-lt"/>
+        <a:ea typeface="+mn-ea"/>
+        <a:cs typeface="+mn-cs"/>
+      </a:defRPr>
+    </a:lvl3pPr>
+    <a:lvl4pPr marL="1371600" algn="l" defTabSz="457200" rtl="0" eaLnBrk="1" latinLnBrk="0" hangingPunct="1">
+      <a:defRPr sz="1200" kern="1200">
+        <a:solidFill>
+          <a:schemeClr val="tx1"/>
+        </a:solidFill>
+        <a:latin typeface="+mn-lt"/>
+        <a:ea typeface="+mn-ea"/>
+        <a:cs typeface="+mn-cs"/>
+      </a:defRPr>
+    </a:lvl4pPr>
+    <a:lvl5pPr marL="1828800" algn="l" defTabSz="457200" rtl="0" eaLnBrk="1" latinLnBrk="0" hangingPunct="1">
+      <a:defRPr sz="1200" kern="1200">
+        <a:solidFill>
+          <a:schemeClr val="tx1"/>
+        </a:solidFill>
+        <a:latin typeface="+mn-lt"/>
+        <a:ea typeface="+mn-ea"/>
+        <a:cs typeface="+mn-cs"/>
+      </a:defRPr>
+    </a:lvl5pPr>
+    <a:lvl6pPr marL="2286000" algn="l" defTabSz="457200" rtl="0" eaLnBrk="1" latinLnBrk="0" hangingPunct="1">
+      <a:defRPr sz="1200" kern="1200">
+        <a:solidFill>
+          <a:schemeClr val="tx1"/>
+        </a:solidFill>
+        <a:latin typeface="+mn-lt"/>
+        <a:ea typeface="+mn-ea"/>
+        <a:cs typeface="+mn-cs"/>
+      </a:defRPr>
+    </a:lvl6pPr>
+    <a:lvl7pPr marL="2743200" algn="l" defTabSz="457200" rtl="0" eaLnBrk="1" latinLnBrk="0" hangingPunct="1">
+      <a:defRPr sz="1200" kern="1200">
+        <a:solidFill>
+          <a:schemeClr val="tx1"/>
+        </a:solidFill>
+        <a:latin typeface="+mn-lt"/>
+        <a:ea typeface="+mn-ea"/>
+        <a:cs typeface="+mn-cs"/>
+      </a:defRPr>
+    </a:lvl7pPr>
+    <a:lvl8pPr marL="3200400" algn="l" defTabSz="457200" rtl="0" eaLnBrk="1" latinLnBrk="0" hangingPunct="1">
+      <a:defRPr sz="1200" kern="1200">
+        <a:solidFill>
+          <a:schemeClr val="tx1"/>
+        </a:solidFill>
+        <a:latin typeface="+mn-lt"/>
+        <a:ea typeface="+mn-ea"/>
+        <a:cs typeface="+mn-cs"/>
+      </a:defRPr>
+    </a:lvl8pPr>
+    <a:lvl9pPr marL="3657600" algn="l" defTabSz="457200" rtl="0" eaLnBrk="1" latinLnBrk="0" hangingPunct="1">
+      <a:defRPr sz="1200" kern="1200">
+        <a:solidFill>
+          <a:schemeClr val="tx1"/>
+        </a:solidFill>
+        <a:latin typeface="+mn-lt"/>
+        <a:ea typeface="+mn-ea"/>
+        <a:cs typeface="+mn-cs"/>
+      </a:defRPr>
+    </a:lvl9pPr>
+  </p:notesStyle>
+</p:notesMaster>
+</file>
+
+<file path=ppt/notesSlides/notesSlide1.xml><?xml version="1.0" encoding="utf-8"?>
+<p:notes xmlns:a="http://schemas.openxmlformats.org/drawingml/2006/main" xmlns:p="http://schemas.openxmlformats.org/presentationml/2006/main" xmlns:r="http://schemas.openxmlformats.org/officeDocument/2006/relationships">
+  <p:cSld>
+    <p:spTree>
+      <p:nvGrpSpPr>
+        <p:cNvPr id="1" name=""/>
+        <p:cNvGrpSpPr/>
+        <p:nvPr/>
+      </p:nvGrpSpPr>
+      <p:grpSpPr>
+        <a:xfrm>
+          <a:off x="0" y="0"/>
+          <a:ext cx="0" cy="0"/>
+          <a:chOff x="0" y="0"/>
+          <a:chExt cx="0" cy="0"/>
+        </a:xfrm>
+      </p:grpSpPr>
+      <p:sp>
+        <p:nvSpPr>
+          <p:cNvPr id="2" name="Slide Image Placeholder 1"/>
+          <p:cNvSpPr>
+            <a:spLocks noGrp="1"/>
+          </p:cNvSpPr>
+          <p:nvPr>
+            <p:ph type="sldImg" idx="2"/>
+          </p:nvPr>
+        </p:nvSpPr>
+        <p:spPr/>
+      </p:sp>
+      <p:sp>
+        <p:nvSpPr>
+          <p:cNvPr id="3" name="Notes Placeholder 2"/>
+          <p:cNvSpPr>
+            <a:spLocks noGrp="1"/>
+          </p:cNvSpPr>
+          <p:nvPr>
+            <p:ph type="body" idx="3" sz="quarter"/>
+          </p:nvPr>
+        </p:nvSpPr>
+        <p:spPr/>
+        <p:txBody>
+          <a:bodyPr/>
+          <a:lstStyle/>
+          <a:p>
+            <a:r>
+              <a:t>Opening line: NeuFlow v3 is the same v2 network everyone here already trusts, with one part swapped. Instead of always producing a full dense flow map, it answers flow queries at whatever points you ask for. I will show it is faster where it matters, at least as accurate, and does two things v2 structurally cannot. Everything I show is measured on the full validation set, not cherry-picked frames.</a:t>
+            </a:r>
+          </a:p>
+        </p:txBody>
+      </p:sp>
+      <p:sp>
+        <p:nvSpPr>
+          <p:cNvPr id="4" name="Slide Number Placeholder 3"/>
+          <p:cNvSpPr>
+            <a:spLocks noGrp="1"/>
+          </p:cNvSpPr>
+          <p:nvPr>
+            <p:ph type="sldNum" idx="5" sz="quarter"/>
+          </p:nvPr>
+        </p:nvSpPr>
+        <p:spPr/>
+      </p:sp>
+    </p:spTree>
+  </p:cSld>
+  <p:clrMapOvr>
+    <a:masterClrMapping/>
+  </p:clrMapOvr>
+</p:notes>
+</file>
+
+<file path=ppt/notesSlides/notesSlide10.xml><?xml version="1.0" encoding="utf-8"?>
+<p:notes xmlns:a="http://schemas.openxmlformats.org/drawingml/2006/main" xmlns:p="http://schemas.openxmlformats.org/presentationml/2006/main" xmlns:r="http://schemas.openxmlformats.org/officeDocument/2006/relationships">
+  <p:cSld>
+    <p:spTree>
+      <p:nvGrpSpPr>
+        <p:cNvPr id="1" name=""/>
+        <p:cNvGrpSpPr/>
+        <p:nvPr/>
+      </p:nvGrpSpPr>
+      <p:grpSpPr>
+        <a:xfrm>
+          <a:off x="0" y="0"/>
+          <a:ext cx="0" cy="0"/>
+          <a:chOff x="0" y="0"/>
+          <a:chExt cx="0" cy="0"/>
+        </a:xfrm>
+      </p:grpSpPr>
+      <p:sp>
+        <p:nvSpPr>
+          <p:cNvPr id="2" name="Slide Image Placeholder 1"/>
+          <p:cNvSpPr>
+            <a:spLocks noGrp="1"/>
+          </p:cNvSpPr>
+          <p:nvPr>
+            <p:ph type="sldImg" idx="2"/>
+          </p:nvPr>
+        </p:nvSpPr>
+        <p:spPr/>
+      </p:sp>
+      <p:sp>
+        <p:nvSpPr>
+          <p:cNvPr id="3" name="Notes Placeholder 2"/>
+          <p:cNvSpPr>
+            <a:spLocks noGrp="1"/>
+          </p:cNvSpPr>
+          <p:nvPr>
+            <p:ph type="body" idx="3" sz="quarter"/>
+          </p:nvPr>
+        </p:nvSpPr>
+        <p:spPr/>
+        <p:txBody>
+          <a:bodyPr/>
+          <a:lstStyle/>
+          <a:p>
+            <a:r>
+              <a:t>A separate efficiency result. The refinement loop runs 8 times and is 59 percent of the runtime, but iterations 5 through 8 barely change the answer. I retrained just that module, using the model teaching itself with no ground truth, so 3 iterations do most of what 8 did. Honest caveat, and it is on the record: this number is the coarse stage in isolation. The end-to-end merged version is measured separately; do not quote this as a full-pipeline result.</a:t>
+            </a:r>
+          </a:p>
+        </p:txBody>
+      </p:sp>
+      <p:sp>
+        <p:nvSpPr>
+          <p:cNvPr id="4" name="Slide Number Placeholder 3"/>
+          <p:cNvSpPr>
+            <a:spLocks noGrp="1"/>
+          </p:cNvSpPr>
+          <p:nvPr>
+            <p:ph type="sldNum" idx="5" sz="quarter"/>
+          </p:nvPr>
+        </p:nvSpPr>
+        <p:spPr/>
+      </p:sp>
+    </p:spTree>
+  </p:cSld>
+  <p:clrMapOvr>
+    <a:masterClrMapping/>
+  </p:clrMapOvr>
+</p:notes>
+</file>
+
+<file path=ppt/notesSlides/notesSlide11.xml><?xml version="1.0" encoding="utf-8"?>
+<p:notes xmlns:a="http://schemas.openxmlformats.org/drawingml/2006/main" xmlns:p="http://schemas.openxmlformats.org/presentationml/2006/main" xmlns:r="http://schemas.openxmlformats.org/officeDocument/2006/relationships">
+  <p:cSld>
+    <p:spTree>
+      <p:nvGrpSpPr>
+        <p:cNvPr id="1" name=""/>
+        <p:cNvGrpSpPr/>
+        <p:nvPr/>
+      </p:nvGrpSpPr>
+      <p:grpSpPr>
+        <a:xfrm>
+          <a:off x="0" y="0"/>
+          <a:ext cx="0" cy="0"/>
+          <a:chOff x="0" y="0"/>
+          <a:chExt cx="0" cy="0"/>
+        </a:xfrm>
+      </p:grpSpPr>
+      <p:sp>
+        <p:nvSpPr>
+          <p:cNvPr id="2" name="Slide Image Placeholder 1"/>
+          <p:cNvSpPr>
+            <a:spLocks noGrp="1"/>
+          </p:cNvSpPr>
+          <p:nvPr>
+            <p:ph type="sldImg" idx="2"/>
+          </p:nvPr>
+        </p:nvSpPr>
+        <p:spPr/>
+      </p:sp>
+      <p:sp>
+        <p:nvSpPr>
+          <p:cNvPr id="3" name="Notes Placeholder 2"/>
+          <p:cNvSpPr>
+            <a:spLocks noGrp="1"/>
+          </p:cNvSpPr>
+          <p:nvPr>
+            <p:ph type="body" idx="3" sz="quarter"/>
+          </p:nvPr>
+        </p:nvSpPr>
+        <p:spPr/>
+        <p:txBody>
+          <a:bodyPr/>
+          <a:lstStyle/>
+          <a:p>
+            <a:r>
+              <a:t>Quick and practical. A query is one continuous coordinate; sub-pixel positions are valid. The whole interface is two calls: infer state once, then decode queries as many times as you want. Training used 4,096 supervision points per image, half on motion boundaries, backbone frozen throughout everything except the distillation experiment.</a:t>
+            </a:r>
+          </a:p>
+        </p:txBody>
+      </p:sp>
+      <p:sp>
+        <p:nvSpPr>
+          <p:cNvPr id="4" name="Slide Number Placeholder 3"/>
+          <p:cNvSpPr>
+            <a:spLocks noGrp="1"/>
+          </p:cNvSpPr>
+          <p:nvPr>
+            <p:ph type="sldNum" idx="5" sz="quarter"/>
+          </p:nvPr>
+        </p:nvSpPr>
+        <p:spPr/>
+      </p:sp>
+    </p:spTree>
+  </p:cSld>
+  <p:clrMapOvr>
+    <a:masterClrMapping/>
+  </p:clrMapOvr>
+</p:notes>
+</file>
+
+<file path=ppt/notesSlides/notesSlide12.xml><?xml version="1.0" encoding="utf-8"?>
+<p:notes xmlns:a="http://schemas.openxmlformats.org/drawingml/2006/main" xmlns:p="http://schemas.openxmlformats.org/presentationml/2006/main" xmlns:r="http://schemas.openxmlformats.org/officeDocument/2006/relationships">
+  <p:cSld>
+    <p:spTree>
+      <p:nvGrpSpPr>
+        <p:cNvPr id="1" name=""/>
+        <p:cNvGrpSpPr/>
+        <p:nvPr/>
+      </p:nvGrpSpPr>
+      <p:grpSpPr>
+        <a:xfrm>
+          <a:off x="0" y="0"/>
+          <a:ext cx="0" cy="0"/>
+          <a:chOff x="0" y="0"/>
+          <a:chExt cx="0" cy="0"/>
+        </a:xfrm>
+      </p:grpSpPr>
+      <p:sp>
+        <p:nvSpPr>
+          <p:cNvPr id="2" name="Slide Image Placeholder 1"/>
+          <p:cNvSpPr>
+            <a:spLocks noGrp="1"/>
+          </p:cNvSpPr>
+          <p:nvPr>
+            <p:ph type="sldImg" idx="2"/>
+          </p:nvPr>
+        </p:nvSpPr>
+        <p:spPr/>
+      </p:sp>
+      <p:sp>
+        <p:nvSpPr>
+          <p:cNvPr id="3" name="Notes Placeholder 2"/>
+          <p:cNvSpPr>
+            <a:spLocks noGrp="1"/>
+          </p:cNvSpPr>
+          <p:nvPr>
+            <p:ph type="body" idx="3" sz="quarter"/>
+          </p:nvPr>
+        </p:nvSpPr>
+        <p:spPr/>
+        <p:txBody>
+          <a:bodyPr/>
+          <a:lstStyle/>
+          <a:p>
+            <a:r>
+              <a:t>Live demo backup if the tool cooperates. Left, click any pixel and it returns flow instantly. Right, motion detection pulled straight from the coarse flow at zero extra cost. The model selector flips between v2 and v3 in place, so you can feel the difference: v2 recomputes the whole frame on every interaction, v3 reuses the cached state.</a:t>
+            </a:r>
+          </a:p>
+        </p:txBody>
+      </p:sp>
+      <p:sp>
+        <p:nvSpPr>
+          <p:cNvPr id="4" name="Slide Number Placeholder 3"/>
+          <p:cNvSpPr>
+            <a:spLocks noGrp="1"/>
+          </p:cNvSpPr>
+          <p:nvPr>
+            <p:ph type="sldNum" idx="5" sz="quarter"/>
+          </p:nvPr>
+        </p:nvSpPr>
+        <p:spPr/>
+      </p:sp>
+    </p:spTree>
+  </p:cSld>
+  <p:clrMapOvr>
+    <a:masterClrMapping/>
+  </p:clrMapOvr>
+</p:notes>
+</file>
+
+<file path=ppt/notesSlides/notesSlide13.xml><?xml version="1.0" encoding="utf-8"?>
+<p:notes xmlns:a="http://schemas.openxmlformats.org/drawingml/2006/main" xmlns:p="http://schemas.openxmlformats.org/presentationml/2006/main" xmlns:r="http://schemas.openxmlformats.org/officeDocument/2006/relationships">
+  <p:cSld>
+    <p:spTree>
+      <p:nvGrpSpPr>
+        <p:cNvPr id="1" name=""/>
+        <p:cNvGrpSpPr/>
+        <p:nvPr/>
+      </p:nvGrpSpPr>
+      <p:grpSpPr>
+        <a:xfrm>
+          <a:off x="0" y="0"/>
+          <a:ext cx="0" cy="0"/>
+          <a:chOff x="0" y="0"/>
+          <a:chExt cx="0" cy="0"/>
+        </a:xfrm>
+      </p:grpSpPr>
+      <p:sp>
+        <p:nvSpPr>
+          <p:cNvPr id="2" name="Slide Image Placeholder 1"/>
+          <p:cNvSpPr>
+            <a:spLocks noGrp="1"/>
+          </p:cNvSpPr>
+          <p:nvPr>
+            <p:ph type="sldImg" idx="2"/>
+          </p:nvPr>
+        </p:nvSpPr>
+        <p:spPr/>
+      </p:sp>
+      <p:sp>
+        <p:nvSpPr>
+          <p:cNvPr id="3" name="Notes Placeholder 2"/>
+          <p:cNvSpPr>
+            <a:spLocks noGrp="1"/>
+          </p:cNvSpPr>
+          <p:nvPr>
+            <p:ph type="body" idx="3" sz="quarter"/>
+          </p:nvPr>
+        </p:nvSpPr>
+        <p:spPr/>
+        <p:txBody>
+          <a:bodyPr/>
+          <a:lstStyle/>
+          <a:p>
+            <a:r>
+              <a:t>Proof it runs on real, unseen footage, not just the benchmark. 40 frames of a public YouTube highway clip, 30 FPS end to end with motion boxes. The graphs on the right were sampled during that run; the flat GPU-memory line is the point, one cached state serves every interaction.</a:t>
+            </a:r>
+          </a:p>
+        </p:txBody>
+      </p:sp>
+      <p:sp>
+        <p:nvSpPr>
+          <p:cNvPr id="4" name="Slide Number Placeholder 3"/>
+          <p:cNvSpPr>
+            <a:spLocks noGrp="1"/>
+          </p:cNvSpPr>
+          <p:nvPr>
+            <p:ph type="sldNum" idx="5" sz="quarter"/>
+          </p:nvPr>
+        </p:nvSpPr>
+        <p:spPr/>
+      </p:sp>
+    </p:spTree>
+  </p:cSld>
+  <p:clrMapOvr>
+    <a:masterClrMapping/>
+  </p:clrMapOvr>
+</p:notes>
+</file>
+
+<file path=ppt/notesSlides/notesSlide14.xml><?xml version="1.0" encoding="utf-8"?>
+<p:notes xmlns:a="http://schemas.openxmlformats.org/drawingml/2006/main" xmlns:p="http://schemas.openxmlformats.org/presentationml/2006/main" xmlns:r="http://schemas.openxmlformats.org/officeDocument/2006/relationships">
+  <p:cSld>
+    <p:spTree>
+      <p:nvGrpSpPr>
+        <p:cNvPr id="1" name=""/>
+        <p:cNvGrpSpPr/>
+        <p:nvPr/>
+      </p:nvGrpSpPr>
+      <p:grpSpPr>
+        <a:xfrm>
+          <a:off x="0" y="0"/>
+          <a:ext cx="0" cy="0"/>
+          <a:chOff x="0" y="0"/>
+          <a:chExt cx="0" cy="0"/>
+        </a:xfrm>
+      </p:grpSpPr>
+      <p:sp>
+        <p:nvSpPr>
+          <p:cNvPr id="2" name="Slide Image Placeholder 1"/>
+          <p:cNvSpPr>
+            <a:spLocks noGrp="1"/>
+          </p:cNvSpPr>
+          <p:nvPr>
+            <p:ph type="sldImg" idx="2"/>
+          </p:nvPr>
+        </p:nvSpPr>
+        <p:spPr/>
+      </p:sp>
+      <p:sp>
+        <p:nvSpPr>
+          <p:cNvPr id="3" name="Notes Placeholder 2"/>
+          <p:cNvSpPr>
+            <a:spLocks noGrp="1"/>
+          </p:cNvSpPr>
+          <p:nvPr>
+            <p:ph type="body" idx="3" sz="quarter"/>
+          </p:nvPr>
+        </p:nvSpPr>
+        <p:spPr/>
+        <p:txBody>
+          <a:bodyPr/>
+          <a:lstStyle/>
+          <a:p>
+            <a:r>
+              <a:t>Scorecard against the three goals I set. Beat v2 accuracy: done, 11 percent, and 3px now beats v2. Less compute for the sparse case: done, verified same hardware. Do what v2 cannot: done, arbitrary-coordinate queries and a calibrated confidence signal. I will state plainly on the next slide what is not yet proven.</a:t>
+            </a:r>
+          </a:p>
+        </p:txBody>
+      </p:sp>
+      <p:sp>
+        <p:nvSpPr>
+          <p:cNvPr id="4" name="Slide Number Placeholder 3"/>
+          <p:cNvSpPr>
+            <a:spLocks noGrp="1"/>
+          </p:cNvSpPr>
+          <p:nvPr>
+            <p:ph type="sldNum" idx="5" sz="quarter"/>
+          </p:nvPr>
+        </p:nvSpPr>
+        <p:spPr/>
+      </p:sp>
+    </p:spTree>
+  </p:cSld>
+  <p:clrMapOvr>
+    <a:masterClrMapping/>
+  </p:clrMapOvr>
+</p:notes>
+</file>
+
+<file path=ppt/notesSlides/notesSlide15.xml><?xml version="1.0" encoding="utf-8"?>
+<p:notes xmlns:a="http://schemas.openxmlformats.org/drawingml/2006/main" xmlns:p="http://schemas.openxmlformats.org/presentationml/2006/main" xmlns:r="http://schemas.openxmlformats.org/officeDocument/2006/relationships">
+  <p:cSld>
+    <p:spTree>
+      <p:nvGrpSpPr>
+        <p:cNvPr id="1" name=""/>
+        <p:cNvGrpSpPr/>
+        <p:nvPr/>
+      </p:nvGrpSpPr>
+      <p:grpSpPr>
+        <a:xfrm>
+          <a:off x="0" y="0"/>
+          <a:ext cx="0" cy="0"/>
+          <a:chOff x="0" y="0"/>
+          <a:chExt cx="0" cy="0"/>
+        </a:xfrm>
+      </p:grpSpPr>
+      <p:sp>
+        <p:nvSpPr>
+          <p:cNvPr id="2" name="Slide Image Placeholder 1"/>
+          <p:cNvSpPr>
+            <a:spLocks noGrp="1"/>
+          </p:cNvSpPr>
+          <p:nvPr>
+            <p:ph type="sldImg" idx="2"/>
+          </p:nvPr>
+        </p:nvSpPr>
+        <p:spPr/>
+      </p:sp>
+      <p:sp>
+        <p:nvSpPr>
+          <p:cNvPr id="3" name="Notes Placeholder 2"/>
+          <p:cNvSpPr>
+            <a:spLocks noGrp="1"/>
+          </p:cNvSpPr>
+          <p:nvPr>
+            <p:ph type="body" idx="3" sz="quarter"/>
+          </p:nvPr>
+        </p:nvSpPr>
+        <p:spPr/>
+        <p:txBody>
+          <a:bodyPr/>
+          <a:lstStyle/>
+          <a:p>
+            <a:r>
+              <a:t>I want to be the one to raise these, not have them raised for me. The training-data confound is only partly closed: I have not retrained v2 on the exact same mixture. The uncertainty-head accuracy gain is a single run and could be seed noise. Every number is a 4060 or V100, never an actual Jetson. And Spring was cut off at 70 percent by the job time limit. None of these undo the main results, but they are the honest next things to nail down.</a:t>
+            </a:r>
+          </a:p>
+        </p:txBody>
+      </p:sp>
+      <p:sp>
+        <p:nvSpPr>
+          <p:cNvPr id="4" name="Slide Number Placeholder 3"/>
+          <p:cNvSpPr>
+            <a:spLocks noGrp="1"/>
+          </p:cNvSpPr>
+          <p:nvPr>
+            <p:ph type="sldNum" idx="5" sz="quarter"/>
+          </p:nvPr>
+        </p:nvSpPr>
+        <p:spPr/>
+      </p:sp>
+    </p:spTree>
+  </p:cSld>
+  <p:clrMapOvr>
+    <a:masterClrMapping/>
+  </p:clrMapOvr>
+</p:notes>
+</file>
+
+<file path=ppt/notesSlides/notesSlide16.xml><?xml version="1.0" encoding="utf-8"?>
+<p:notes xmlns:a="http://schemas.openxmlformats.org/drawingml/2006/main" xmlns:p="http://schemas.openxmlformats.org/presentationml/2006/main" xmlns:r="http://schemas.openxmlformats.org/officeDocument/2006/relationships">
+  <p:cSld>
+    <p:spTree>
+      <p:nvGrpSpPr>
+        <p:cNvPr id="1" name=""/>
+        <p:cNvGrpSpPr/>
+        <p:nvPr/>
+      </p:nvGrpSpPr>
+      <p:grpSpPr>
+        <a:xfrm>
+          <a:off x="0" y="0"/>
+          <a:ext cx="0" cy="0"/>
+          <a:chOff x="0" y="0"/>
+          <a:chExt cx="0" cy="0"/>
+        </a:xfrm>
+      </p:grpSpPr>
+      <p:sp>
+        <p:nvSpPr>
+          <p:cNvPr id="2" name="Slide Image Placeholder 1"/>
+          <p:cNvSpPr>
+            <a:spLocks noGrp="1"/>
+          </p:cNvSpPr>
+          <p:nvPr>
+            <p:ph type="sldImg" idx="2"/>
+          </p:nvPr>
+        </p:nvSpPr>
+        <p:spPr/>
+      </p:sp>
+      <p:sp>
+        <p:nvSpPr>
+          <p:cNvPr id="3" name="Notes Placeholder 2"/>
+          <p:cNvSpPr>
+            <a:spLocks noGrp="1"/>
+          </p:cNvSpPr>
+          <p:nvPr>
+            <p:ph type="body" idx="3" sz="quarter"/>
+          </p:nvPr>
+        </p:nvSpPr>
+        <p:spPr/>
+        <p:txBody>
+          <a:bodyPr/>
+          <a:lstStyle/>
+          <a:p>
+            <a:r>
+              <a:t>Concrete plan. Immediate and cheap: finish Spring, run the 4K query test that only a queryable model can even attempt, repeat the uncertainty run, retrain v2 on the mixed data to close the confound. Then the two asks: continued cluster access for these 6-to-8-hour jobs, and access to the lab's own AUV and UAV survey data, which is exactly the sparse, overlapping, slow-motion setting this method is built for.</a:t>
+            </a:r>
+          </a:p>
+        </p:txBody>
+      </p:sp>
+      <p:sp>
+        <p:nvSpPr>
+          <p:cNvPr id="4" name="Slide Number Placeholder 3"/>
+          <p:cNvSpPr>
+            <a:spLocks noGrp="1"/>
+          </p:cNvSpPr>
+          <p:nvPr>
+            <p:ph type="sldNum" idx="5" sz="quarter"/>
+          </p:nvPr>
+        </p:nvSpPr>
+        <p:spPr/>
+      </p:sp>
+    </p:spTree>
+  </p:cSld>
+  <p:clrMapOvr>
+    <a:masterClrMapping/>
+  </p:clrMapOvr>
+</p:notes>
+</file>
+
+<file path=ppt/notesSlides/notesSlide17.xml><?xml version="1.0" encoding="utf-8"?>
+<p:notes xmlns:a="http://schemas.openxmlformats.org/drawingml/2006/main" xmlns:p="http://schemas.openxmlformats.org/presentationml/2006/main" xmlns:r="http://schemas.openxmlformats.org/officeDocument/2006/relationships">
+  <p:cSld>
+    <p:spTree>
+      <p:nvGrpSpPr>
+        <p:cNvPr id="1" name=""/>
+        <p:cNvGrpSpPr/>
+        <p:nvPr/>
+      </p:nvGrpSpPr>
+      <p:grpSpPr>
+        <a:xfrm>
+          <a:off x="0" y="0"/>
+          <a:ext cx="0" cy="0"/>
+          <a:chOff x="0" y="0"/>
+          <a:chExt cx="0" cy="0"/>
+        </a:xfrm>
+      </p:grpSpPr>
+      <p:sp>
+        <p:nvSpPr>
+          <p:cNvPr id="2" name="Slide Image Placeholder 1"/>
+          <p:cNvSpPr>
+            <a:spLocks noGrp="1"/>
+          </p:cNvSpPr>
+          <p:nvPr>
+            <p:ph type="sldImg" idx="2"/>
+          </p:nvPr>
+        </p:nvSpPr>
+        <p:spPr/>
+      </p:sp>
+      <p:sp>
+        <p:nvSpPr>
+          <p:cNvPr id="3" name="Notes Placeholder 2"/>
+          <p:cNvSpPr>
+            <a:spLocks noGrp="1"/>
+          </p:cNvSpPr>
+          <p:nvPr>
+            <p:ph type="body" idx="3" sz="quarter"/>
+          </p:nvPr>
+        </p:nvSpPr>
+        <p:spPr/>
+        <p:txBody>
+          <a:bodyPr/>
+          <a:lstStyle/>
+          <a:p>
+            <a:r>
+              <a:t>Not shown; my own prep. Anticipated questions with honest one-line answers: why non-integer coordinates, whether the improvement is a data confound, why the uncertainty head helps accuracy, fast-motion handling, and edge-device status. If I do not know, I say I do not know and point to the limitations slide.</a:t>
+            </a:r>
+          </a:p>
+        </p:txBody>
+      </p:sp>
+      <p:sp>
+        <p:nvSpPr>
+          <p:cNvPr id="4" name="Slide Number Placeholder 3"/>
+          <p:cNvSpPr>
+            <a:spLocks noGrp="1"/>
+          </p:cNvSpPr>
+          <p:nvPr>
+            <p:ph type="sldNum" idx="5" sz="quarter"/>
+          </p:nvPr>
+        </p:nvSpPr>
+        <p:spPr/>
+      </p:sp>
+    </p:spTree>
+  </p:cSld>
+  <p:clrMapOvr>
+    <a:masterClrMapping/>
+  </p:clrMapOvr>
+</p:notes>
+</file>
+
+<file path=ppt/notesSlides/notesSlide2.xml><?xml version="1.0" encoding="utf-8"?>
+<p:notes xmlns:a="http://schemas.openxmlformats.org/drawingml/2006/main" xmlns:p="http://schemas.openxmlformats.org/presentationml/2006/main" xmlns:r="http://schemas.openxmlformats.org/officeDocument/2006/relationships">
+  <p:cSld>
+    <p:spTree>
+      <p:nvGrpSpPr>
+        <p:cNvPr id="1" name=""/>
+        <p:cNvGrpSpPr/>
+        <p:nvPr/>
+      </p:nvGrpSpPr>
+      <p:grpSpPr>
+        <a:xfrm>
+          <a:off x="0" y="0"/>
+          <a:ext cx="0" cy="0"/>
+          <a:chOff x="0" y="0"/>
+          <a:chExt cx="0" cy="0"/>
+        </a:xfrm>
+      </p:grpSpPr>
+      <p:sp>
+        <p:nvSpPr>
+          <p:cNvPr id="2" name="Slide Image Placeholder 1"/>
+          <p:cNvSpPr>
+            <a:spLocks noGrp="1"/>
+          </p:cNvSpPr>
+          <p:nvPr>
+            <p:ph type="sldImg" idx="2"/>
+          </p:nvPr>
+        </p:nvSpPr>
+        <p:spPr/>
+      </p:sp>
+      <p:sp>
+        <p:nvSpPr>
+          <p:cNvPr id="3" name="Notes Placeholder 2"/>
+          <p:cNvSpPr>
+            <a:spLocks noGrp="1"/>
+          </p:cNvSpPr>
+          <p:nvPr>
+            <p:ph type="body" idx="3" sz="quarter"/>
+          </p:nvPr>
+        </p:nvSpPr>
+        <p:spPr/>
+        <p:txBody>
+          <a:bodyPr/>
+          <a:lstStyle/>
+          <a:p>
+            <a:r>
+              <a:t>Set up the problem in one breath: flow tells you where each pixel goes. Every current network computes all of it, always. But registration, tracking, and mapping only ever use a few hundred points. On a small GPU, computing 479 thousand values to use 800 of them is the difference between real time and not. The idea is to keep everything in v2 that understands motion and only change how the answer is read out.</a:t>
+            </a:r>
+          </a:p>
+        </p:txBody>
+      </p:sp>
+      <p:sp>
+        <p:nvSpPr>
+          <p:cNvPr id="4" name="Slide Number Placeholder 3"/>
+          <p:cNvSpPr>
+            <a:spLocks noGrp="1"/>
+          </p:cNvSpPr>
+          <p:nvPr>
+            <p:ph type="sldNum" idx="5" sz="quarter"/>
+          </p:nvPr>
+        </p:nvSpPr>
+        <p:spPr/>
+      </p:sp>
+    </p:spTree>
+  </p:cSld>
+  <p:clrMapOvr>
+    <a:masterClrMapping/>
+  </p:clrMapOvr>
+</p:notes>
+</file>
+
+<file path=ppt/notesSlides/notesSlide3.xml><?xml version="1.0" encoding="utf-8"?>
+<p:notes xmlns:a="http://schemas.openxmlformats.org/drawingml/2006/main" xmlns:p="http://schemas.openxmlformats.org/presentationml/2006/main" xmlns:r="http://schemas.openxmlformats.org/officeDocument/2006/relationships">
+  <p:cSld>
+    <p:spTree>
+      <p:nvGrpSpPr>
+        <p:cNvPr id="1" name=""/>
+        <p:cNvGrpSpPr/>
+        <p:nvPr/>
+      </p:nvGrpSpPr>
+      <p:grpSpPr>
+        <a:xfrm>
+          <a:off x="0" y="0"/>
+          <a:ext cx="0" cy="0"/>
+          <a:chOff x="0" y="0"/>
+          <a:chExt cx="0" cy="0"/>
+        </a:xfrm>
+      </p:grpSpPr>
+      <p:sp>
+        <p:nvSpPr>
+          <p:cNvPr id="2" name="Slide Image Placeholder 1"/>
+          <p:cNvSpPr>
+            <a:spLocks noGrp="1"/>
+          </p:cNvSpPr>
+          <p:nvPr>
+            <p:ph type="sldImg" idx="2"/>
+          </p:nvPr>
+        </p:nvSpPr>
+        <p:spPr/>
+      </p:sp>
+      <p:sp>
+        <p:nvSpPr>
+          <p:cNvPr id="3" name="Notes Placeholder 2"/>
+          <p:cNvSpPr>
+            <a:spLocks noGrp="1"/>
+          </p:cNvSpPr>
+          <p:nvPr>
+            <p:ph type="body" idx="3" sz="quarter"/>
+          </p:nvPr>
+        </p:nvSpPr>
+        <p:spPr/>
+        <p:txBody>
+          <a:bodyPr/>
+          <a:lstStyle/>
+          <a:p>
+            <a:r>
+              <a:t>Walk the boxes left to right, then land on the bold line: every one of these blocks is frozen in v3, byte for byte identical to v2. I did not retrain the part that finds motion. The only thing I touched is the very last step, the upsampler. So any accuracy change comes from that one swap, not from disturbing what already works.</a:t>
+            </a:r>
+          </a:p>
+        </p:txBody>
+      </p:sp>
+      <p:sp>
+        <p:nvSpPr>
+          <p:cNvPr id="4" name="Slide Number Placeholder 3"/>
+          <p:cNvSpPr>
+            <a:spLocks noGrp="1"/>
+          </p:cNvSpPr>
+          <p:nvPr>
+            <p:ph type="sldNum" idx="5" sz="quarter"/>
+          </p:nvPr>
+        </p:nvSpPr>
+        <p:spPr/>
+      </p:sp>
+    </p:spTree>
+  </p:cSld>
+  <p:clrMapOvr>
+    <a:masterClrMapping/>
+  </p:clrMapOvr>
+</p:notes>
+</file>
+
+<file path=ppt/notesSlides/notesSlide4.xml><?xml version="1.0" encoding="utf-8"?>
+<p:notes xmlns:a="http://schemas.openxmlformats.org/drawingml/2006/main" xmlns:p="http://schemas.openxmlformats.org/presentationml/2006/main" xmlns:r="http://schemas.openxmlformats.org/officeDocument/2006/relationships">
+  <p:cSld>
+    <p:spTree>
+      <p:nvGrpSpPr>
+        <p:cNvPr id="1" name=""/>
+        <p:cNvGrpSpPr/>
+        <p:nvPr/>
+      </p:nvGrpSpPr>
+      <p:grpSpPr>
+        <a:xfrm>
+          <a:off x="0" y="0"/>
+          <a:ext cx="0" cy="0"/>
+          <a:chOff x="0" y="0"/>
+          <a:chExt cx="0" cy="0"/>
+        </a:xfrm>
+      </p:grpSpPr>
+      <p:sp>
+        <p:nvSpPr>
+          <p:cNvPr id="2" name="Slide Image Placeholder 1"/>
+          <p:cNvSpPr>
+            <a:spLocks noGrp="1"/>
+          </p:cNvSpPr>
+          <p:nvPr>
+            <p:ph type="sldImg" idx="2"/>
+          </p:nvPr>
+        </p:nvSpPr>
+        <p:spPr/>
+      </p:sp>
+      <p:sp>
+        <p:nvSpPr>
+          <p:cNvPr id="3" name="Notes Placeholder 2"/>
+          <p:cNvSpPr>
+            <a:spLocks noGrp="1"/>
+          </p:cNvSpPr>
+          <p:nvPr>
+            <p:ph type="body" idx="3" sz="quarter"/>
+          </p:nvPr>
+        </p:nvSpPr>
+        <p:spPr/>
+        <p:txBody>
+          <a:bodyPr/>
+          <a:lstStyle/>
+          <a:p>
+            <a:r>
+              <a:t>The key idea in plain terms: for any coordinate, sample features there, then output blend weights over a small 3x3 neighborhood of the coarse flow plus a bilinear value. Because it is a bounded blend, it cannot invent wild flow. And I zero-initialize it, so before any training it reproduces plain bilinear upsampling exactly. That means training can only improve on that starting point. Note it is one coarse pass per frame, then cheap per-query work. And v3 is actually smaller than v2, 7.8 vs 9 million parameters.</a:t>
+            </a:r>
+          </a:p>
+        </p:txBody>
+      </p:sp>
+      <p:sp>
+        <p:nvSpPr>
+          <p:cNvPr id="4" name="Slide Number Placeholder 3"/>
+          <p:cNvSpPr>
+            <a:spLocks noGrp="1"/>
+          </p:cNvSpPr>
+          <p:nvPr>
+            <p:ph type="sldNum" idx="5" sz="quarter"/>
+          </p:nvPr>
+        </p:nvSpPr>
+        <p:spPr/>
+      </p:sp>
+    </p:spTree>
+  </p:cSld>
+  <p:clrMapOvr>
+    <a:masterClrMapping/>
+  </p:clrMapOvr>
+</p:notes>
+</file>
+
+<file path=ppt/notesSlides/notesSlide5.xml><?xml version="1.0" encoding="utf-8"?>
+<p:notes xmlns:a="http://schemas.openxmlformats.org/drawingml/2006/main" xmlns:p="http://schemas.openxmlformats.org/presentationml/2006/main" xmlns:r="http://schemas.openxmlformats.org/officeDocument/2006/relationships">
+  <p:cSld>
+    <p:spTree>
+      <p:nvGrpSpPr>
+        <p:cNvPr id="1" name=""/>
+        <p:cNvGrpSpPr/>
+        <p:nvPr/>
+      </p:nvGrpSpPr>
+      <p:grpSpPr>
+        <a:xfrm>
+          <a:off x="0" y="0"/>
+          <a:ext cx="0" cy="0"/>
+          <a:chOff x="0" y="0"/>
+          <a:chExt cx="0" cy="0"/>
+        </a:xfrm>
+      </p:grpSpPr>
+      <p:sp>
+        <p:nvSpPr>
+          <p:cNvPr id="2" name="Slide Image Placeholder 1"/>
+          <p:cNvSpPr>
+            <a:spLocks noGrp="1"/>
+          </p:cNvSpPr>
+          <p:nvPr>
+            <p:ph type="sldImg" idx="2"/>
+          </p:nvPr>
+        </p:nvSpPr>
+        <p:spPr/>
+      </p:sp>
+      <p:sp>
+        <p:nvSpPr>
+          <p:cNvPr id="3" name="Notes Placeholder 2"/>
+          <p:cNvSpPr>
+            <a:spLocks noGrp="1"/>
+          </p:cNvSpPr>
+          <p:nvPr>
+            <p:ph type="body" idx="3" sz="quarter"/>
+          </p:nvPr>
+        </p:nvSpPr>
+        <p:spPr/>
+        <p:txBody>
+          <a:bodyPr/>
+          <a:lstStyle/>
+          <a:p>
+            <a:r>
+              <a:t>This is every configuration I tried, worst to best, left to right. Gray is my laptop, black is the cluster. Two honest lessons are on this chart. Sequential fine-tuning, the tall bar, made things worse: the model forgot. Mixing datasets in every batch is what worked. The best full run, big18, is 2.07 versus v2 at 2.32, about 11 percent better. The red line is v2. Everything from FlyingChairs onward is at or below it.</a:t>
+            </a:r>
+          </a:p>
+        </p:txBody>
+      </p:sp>
+      <p:sp>
+        <p:nvSpPr>
+          <p:cNvPr id="4" name="Slide Number Placeholder 3"/>
+          <p:cNvSpPr>
+            <a:spLocks noGrp="1"/>
+          </p:cNvSpPr>
+          <p:nvPr>
+            <p:ph type="sldNum" idx="5" sz="quarter"/>
+          </p:nvPr>
+        </p:nvSpPr>
+        <p:spPr/>
+      </p:sp>
+    </p:spTree>
+  </p:cSld>
+  <p:clrMapOvr>
+    <a:masterClrMapping/>
+  </p:clrMapOvr>
+</p:notes>
+</file>
+
+<file path=ppt/notesSlides/notesSlide6.xml><?xml version="1.0" encoding="utf-8"?>
+<p:notes xmlns:a="http://schemas.openxmlformats.org/drawingml/2006/main" xmlns:p="http://schemas.openxmlformats.org/presentationml/2006/main" xmlns:r="http://schemas.openxmlformats.org/officeDocument/2006/relationships">
+  <p:cSld>
+    <p:spTree>
+      <p:nvGrpSpPr>
+        <p:cNvPr id="1" name=""/>
+        <p:cNvGrpSpPr/>
+        <p:nvPr/>
+      </p:nvGrpSpPr>
+      <p:grpSpPr>
+        <a:xfrm>
+          <a:off x="0" y="0"/>
+          <a:ext cx="0" cy="0"/>
+          <a:chOff x="0" y="0"/>
+          <a:chExt cx="0" cy="0"/>
+        </a:xfrm>
+      </p:grpSpPr>
+      <p:sp>
+        <p:nvSpPr>
+          <p:cNvPr id="2" name="Slide Image Placeholder 1"/>
+          <p:cNvSpPr>
+            <a:spLocks noGrp="1"/>
+          </p:cNvSpPr>
+          <p:nvPr>
+            <p:ph type="sldImg" idx="2"/>
+          </p:nvPr>
+        </p:nvSpPr>
+        <p:spPr/>
+      </p:sp>
+      <p:sp>
+        <p:nvSpPr>
+          <p:cNvPr id="3" name="Notes Placeholder 2"/>
+          <p:cNvSpPr>
+            <a:spLocks noGrp="1"/>
+          </p:cNvSpPr>
+          <p:nvPr>
+            <p:ph type="body" idx="3" sz="quarter"/>
+          </p:nvPr>
+        </p:nvSpPr>
+        <p:spPr/>
+        <p:txBody>
+          <a:bodyPr/>
+          <a:lstStyle/>
+          <a:p>
+            <a:r>
+              <a:t>EPE is the average, but the lab cares about sharpness, so here is accuracy at 1 and 3 pixels. The honest story: uncG is the first version to actually beat v2 on 3-pixel accuracy, and it closes the 1-pixel gap to under a tenth of a point, which is noise. grandmix is the weak one here on 1px; I am not hiding that.</a:t>
+            </a:r>
+          </a:p>
+        </p:txBody>
+      </p:sp>
+      <p:sp>
+        <p:nvSpPr>
+          <p:cNvPr id="4" name="Slide Number Placeholder 3"/>
+          <p:cNvSpPr>
+            <a:spLocks noGrp="1"/>
+          </p:cNvSpPr>
+          <p:nvPr>
+            <p:ph type="sldNum" idx="5" sz="quarter"/>
+          </p:nvPr>
+        </p:nvSpPr>
+        <p:spPr/>
+      </p:sp>
+    </p:spTree>
+  </p:cSld>
+  <p:clrMapOvr>
+    <a:masterClrMapping/>
+  </p:clrMapOvr>
+</p:notes>
+</file>
+
+<file path=ppt/notesSlides/notesSlide7.xml><?xml version="1.0" encoding="utf-8"?>
+<p:notes xmlns:a="http://schemas.openxmlformats.org/drawingml/2006/main" xmlns:p="http://schemas.openxmlformats.org/presentationml/2006/main" xmlns:r="http://schemas.openxmlformats.org/officeDocument/2006/relationships">
+  <p:cSld>
+    <p:spTree>
+      <p:nvGrpSpPr>
+        <p:cNvPr id="1" name=""/>
+        <p:cNvGrpSpPr/>
+        <p:nvPr/>
+      </p:nvGrpSpPr>
+      <p:grpSpPr>
+        <a:xfrm>
+          <a:off x="0" y="0"/>
+          <a:ext cx="0" cy="0"/>
+          <a:chOff x="0" y="0"/>
+          <a:chExt cx="0" cy="0"/>
+        </a:xfrm>
+      </p:grpSpPr>
+      <p:sp>
+        <p:nvSpPr>
+          <p:cNvPr id="2" name="Slide Image Placeholder 1"/>
+          <p:cNvSpPr>
+            <a:spLocks noGrp="1"/>
+          </p:cNvSpPr>
+          <p:nvPr>
+            <p:ph type="sldImg" idx="2"/>
+          </p:nvPr>
+        </p:nvSpPr>
+        <p:spPr/>
+      </p:sp>
+      <p:sp>
+        <p:nvSpPr>
+          <p:cNvPr id="3" name="Notes Placeholder 2"/>
+          <p:cNvSpPr>
+            <a:spLocks noGrp="1"/>
+          </p:cNvSpPr>
+          <p:nvPr>
+            <p:ph type="body" idx="3" sz="quarter"/>
+          </p:nvPr>
+        </p:nvSpPr>
+        <p:spPr/>
+        <p:txBody>
+          <a:bodyPr/>
+          <a:lstStyle/>
+          <a:p>
+            <a:r>
+              <a:t>Same scene, same ground truth, four models. I show both the full-set EPE and this specific scene's number under each so you can see the single scene is representative, not cherry-picked. All three cluster checkpoints beat v2 on the full 1,174-pair set, not just here.</a:t>
+            </a:r>
+          </a:p>
+        </p:txBody>
+      </p:sp>
+      <p:sp>
+        <p:nvSpPr>
+          <p:cNvPr id="4" name="Slide Number Placeholder 3"/>
+          <p:cNvSpPr>
+            <a:spLocks noGrp="1"/>
+          </p:cNvSpPr>
+          <p:nvPr>
+            <p:ph type="sldNum" idx="5" sz="quarter"/>
+          </p:nvPr>
+        </p:nvSpPr>
+        <p:spPr/>
+      </p:sp>
+    </p:spTree>
+  </p:cSld>
+  <p:clrMapOvr>
+    <a:masterClrMapping/>
+  </p:clrMapOvr>
+</p:notes>
+</file>
+
+<file path=ppt/notesSlides/notesSlide8.xml><?xml version="1.0" encoding="utf-8"?>
+<p:notes xmlns:a="http://schemas.openxmlformats.org/drawingml/2006/main" xmlns:p="http://schemas.openxmlformats.org/presentationml/2006/main" xmlns:r="http://schemas.openxmlformats.org/officeDocument/2006/relationships">
+  <p:cSld>
+    <p:spTree>
+      <p:nvGrpSpPr>
+        <p:cNvPr id="1" name=""/>
+        <p:cNvGrpSpPr/>
+        <p:nvPr/>
+      </p:nvGrpSpPr>
+      <p:grpSpPr>
+        <a:xfrm>
+          <a:off x="0" y="0"/>
+          <a:ext cx="0" cy="0"/>
+          <a:chOff x="0" y="0"/>
+          <a:chExt cx="0" cy="0"/>
+        </a:xfrm>
+      </p:grpSpPr>
+      <p:sp>
+        <p:nvSpPr>
+          <p:cNvPr id="2" name="Slide Image Placeholder 1"/>
+          <p:cNvSpPr>
+            <a:spLocks noGrp="1"/>
+          </p:cNvSpPr>
+          <p:nvPr>
+            <p:ph type="sldImg" idx="2"/>
+          </p:nvPr>
+        </p:nvSpPr>
+        <p:spPr/>
+      </p:sp>
+      <p:sp>
+        <p:nvSpPr>
+          <p:cNvPr id="3" name="Notes Placeholder 2"/>
+          <p:cNvSpPr>
+            <a:spLocks noGrp="1"/>
+          </p:cNvSpPr>
+          <p:nvPr>
+            <p:ph type="body" idx="3" sz="quarter"/>
+          </p:nvPr>
+        </p:nvSpPr>
+        <p:spPr/>
+        <p:txBody>
+          <a:bodyPr/>
+          <a:lstStyle/>
+          <a:p>
+            <a:r>
+              <a:t>This is the slide that answers the earlier objection that 6 percent is not worth it. It is not really about the 6 percent. On identical hardware, v2 pays 19.6 milliseconds on every single call. v3 pays about the same once per frame, then answers every follow-up query on that frame for 2.6 milliseconds, because it caches the expensive part. v2 has no cached state, so it recomputes everything every time. For a planner or SLAM front-end re-querying the same frame, that is a 7x saving.</a:t>
+            </a:r>
+          </a:p>
+        </p:txBody>
+      </p:sp>
+      <p:sp>
+        <p:nvSpPr>
+          <p:cNvPr id="4" name="Slide Number Placeholder 3"/>
+          <p:cNvSpPr>
+            <a:spLocks noGrp="1"/>
+          </p:cNvSpPr>
+          <p:nvPr>
+            <p:ph type="sldNum" idx="5" sz="quarter"/>
+          </p:nvPr>
+        </p:nvSpPr>
+        <p:spPr/>
+      </p:sp>
+    </p:spTree>
+  </p:cSld>
+  <p:clrMapOvr>
+    <a:masterClrMapping/>
+  </p:clrMapOvr>
+</p:notes>
+</file>
+
+<file path=ppt/notesSlides/notesSlide9.xml><?xml version="1.0" encoding="utf-8"?>
+<p:notes xmlns:a="http://schemas.openxmlformats.org/drawingml/2006/main" xmlns:p="http://schemas.openxmlformats.org/presentationml/2006/main" xmlns:r="http://schemas.openxmlformats.org/officeDocument/2006/relationships">
+  <p:cSld>
+    <p:spTree>
+      <p:nvGrpSpPr>
+        <p:cNvPr id="1" name=""/>
+        <p:cNvGrpSpPr/>
+        <p:nvPr/>
+      </p:nvGrpSpPr>
+      <p:grpSpPr>
+        <a:xfrm>
+          <a:off x="0" y="0"/>
+          <a:ext cx="0" cy="0"/>
+          <a:chOff x="0" y="0"/>
+          <a:chExt cx="0" cy="0"/>
+        </a:xfrm>
+      </p:grpSpPr>
+      <p:sp>
+        <p:nvSpPr>
+          <p:cNvPr id="2" name="Slide Image Placeholder 1"/>
+          <p:cNvSpPr>
+            <a:spLocks noGrp="1"/>
+          </p:cNvSpPr>
+          <p:nvPr>
+            <p:ph type="sldImg" idx="2"/>
+          </p:nvPr>
+        </p:nvSpPr>
+        <p:spPr/>
+      </p:sp>
+      <p:sp>
+        <p:nvSpPr>
+          <p:cNvPr id="3" name="Notes Placeholder 2"/>
+          <p:cNvSpPr>
+            <a:spLocks noGrp="1"/>
+          </p:cNvSpPr>
+          <p:nvPr>
+            <p:ph type="body" idx="3" sz="quarter"/>
+          </p:nvPr>
+        </p:nvSpPr>
+        <p:spPr/>
+        <p:txBody>
+          <a:bodyPr/>
+          <a:lstStyle/>
+          <a:p>
+            <a:r>
+              <a:t>This is a capability v2 simply does not have. With one extra output and a self-calibrating loss, the model reports how much to trust each answer. This chart proves it is not noise: sort predictions by claimed confidence and the real error rises monotonically, 0.2 up to 7.4 pixels, correlation 0.38 over 2.35 million points. A robot can use this to reject bad correspondences before they poison a pose estimate.</a:t>
+            </a:r>
+          </a:p>
+        </p:txBody>
+      </p:sp>
+      <p:sp>
+        <p:nvSpPr>
+          <p:cNvPr id="4" name="Slide Number Placeholder 3"/>
+          <p:cNvSpPr>
+            <a:spLocks noGrp="1"/>
+          </p:cNvSpPr>
+          <p:nvPr>
+            <p:ph type="sldNum" idx="5" sz="quarter"/>
+          </p:nvPr>
+        </p:nvSpPr>
+        <p:spPr/>
+      </p:sp>
+    </p:spTree>
+  </p:cSld>
+  <p:clrMapOvr>
+    <a:masterClrMapping/>
+  </p:clrMapOvr>
+</p:notes>
 </file>
 
 <file path=ppt/slideLayouts/slideLayout1.xml><?xml version="1.0" encoding="utf-8"?>
@@ -10618,4 +12158,324 @@
   </a:objectDefaults>
   <a:extraClrSchemeLst/>
 </a:theme>
+</file>
+
+<file path=ppt/theme/theme2.xml><?xml version="1.0" encoding="utf-8"?>
+<a:theme xmlns:a="http://schemas.openxmlformats.org/drawingml/2006/main" name="Office Theme">
+  <a:themeElements>
+    <a:clrScheme name="Office">
+      <a:dk1>
+        <a:sysClr val="windowText" lastClr="000000"/>
+      </a:dk1>
+      <a:lt1>
+        <a:sysClr val="window" lastClr="FFFFFF"/>
+      </a:lt1>
+      <a:dk2>
+        <a:srgbClr val="1F497D"/>
+      </a:dk2>
+      <a:lt2>
+        <a:srgbClr val="EEECE1"/>
+      </a:lt2>
+      <a:accent1>
+        <a:srgbClr val="4F81BD"/>
+      </a:accent1>
+      <a:accent2>
+        <a:srgbClr val="C0504D"/>
+      </a:accent2>
+      <a:accent3>
+        <a:srgbClr val="9BBB59"/>
+      </a:accent3>
+      <a:accent4>
+        <a:srgbClr val="8064A2"/>
+      </a:accent4>
+      <a:accent5>
+        <a:srgbClr val="4BACC6"/>
+      </a:accent5>
+      <a:accent6>
+        <a:srgbClr val="F79646"/>
+      </a:accent6>
+      <a:hlink>
+        <a:srgbClr val="0000FF"/>
+      </a:hlink>
+      <a:folHlink>
+        <a:srgbClr val="800080"/>
+      </a:folHlink>
+    </a:clrScheme>
+    <a:fontScheme name="Office">
+      <a:majorFont>
+        <a:latin typeface="Calibri"/>
+        <a:ea typeface=""/>
+        <a:cs typeface=""/>
+        <a:font script="Jpan" typeface="ＭＳ Ｐゴシック"/>
+        <a:font script="Hang" typeface="맑은 고딕"/>
+        <a:font script="Hans" typeface="宋体"/>
+        <a:font script="Hant" typeface="新細明體"/>
+        <a:font script="Arab" typeface="Times New Roman"/>
+        <a:font script="Hebr" typeface="Times New Roman"/>
+        <a:font script="Thai" typeface="Angsana New"/>
+        <a:font script="Ethi" typeface="Nyala"/>
+        <a:font script="Beng" typeface="Vrinda"/>
+        <a:font script="Gujr" typeface="Shruti"/>
+        <a:font script="Khmr" typeface="MoolBoran"/>
+        <a:font script="Knda" typeface="Tunga"/>
+        <a:font script="Guru" typeface="Raavi"/>
+        <a:font script="Cans" typeface="Euphemia"/>
+        <a:font script="Cher" typeface="Plantagenet Cherokee"/>
+        <a:font script="Yiii" typeface="Microsoft Yi Baiti"/>
+        <a:font script="Tibt" typeface="Microsoft Himalaya"/>
+        <a:font script="Thaa" typeface="MV Boli"/>
+        <a:font script="Deva" typeface="Mangal"/>
+        <a:font script="Telu" typeface="Gautami"/>
+        <a:font script="Taml" typeface="Latha"/>
+        <a:font script="Syrc" typeface="Estrangelo Edessa"/>
+        <a:font script="Orya" typeface="Kalinga"/>
+        <a:font script="Mlym" typeface="Kartika"/>
+        <a:font script="Laoo" typeface="DokChampa"/>
+        <a:font script="Sinh" typeface="Iskoola Pota"/>
+        <a:font script="Mong" typeface="Mongolian Baiti"/>
+        <a:font script="Viet" typeface="Times New Roman"/>
+        <a:font script="Uigh" typeface="Microsoft Uighur"/>
+        <a:font script="Geor" typeface="Sylfaen"/>
+      </a:majorFont>
+      <a:minorFont>
+        <a:latin typeface="Calibri"/>
+        <a:ea typeface=""/>
+        <a:cs typeface=""/>
+        <a:font script="Jpan" typeface="ＭＳ Ｐゴシック"/>
+        <a:font script="Hang" typeface="맑은 고딕"/>
+        <a:font script="Hans" typeface="宋体"/>
+        <a:font script="Hant" typeface="新細明體"/>
+        <a:font script="Arab" typeface="Arial"/>
+        <a:font script="Hebr" typeface="Arial"/>
+        <a:font script="Thai" typeface="Cordia New"/>
+        <a:font script="Ethi" typeface="Nyala"/>
+        <a:font script="Beng" typeface="Vrinda"/>
+        <a:font script="Gujr" typeface="Shruti"/>
+        <a:font script="Khmr" typeface="DaunPenh"/>
+        <a:font script="Knda" typeface="Tunga"/>
+        <a:font script="Guru" typeface="Raavi"/>
+        <a:font script="Cans" typeface="Euphemia"/>
+        <a:font script="Cher" typeface="Plantagenet Cherokee"/>
+        <a:font script="Yiii" typeface="Microsoft Yi Baiti"/>
+        <a:font script="Tibt" typeface="Microsoft Himalaya"/>
+        <a:font script="Thaa" typeface="MV Boli"/>
+        <a:font script="Deva" typeface="Mangal"/>
+        <a:font script="Telu" typeface="Gautami"/>
+        <a:font script="Taml" typeface="Latha"/>
+        <a:font script="Syrc" typeface="Estrangelo Edessa"/>
+        <a:font script="Orya" typeface="Kalinga"/>
+        <a:font script="Mlym" typeface="Kartika"/>
+        <a:font script="Laoo" typeface="DokChampa"/>
+        <a:font script="Sinh" typeface="Iskoola Pota"/>
+        <a:font script="Mong" typeface="Mongolian Baiti"/>
+        <a:font script="Viet" typeface="Arial"/>
+        <a:font script="Uigh" typeface="Microsoft Uighur"/>
+        <a:font script="Geor" typeface="Sylfaen"/>
+      </a:minorFont>
+    </a:fontScheme>
+    <a:fmtScheme name="Office">
+      <a:fillStyleLst>
+        <a:solidFill>
+          <a:schemeClr val="phClr"/>
+        </a:solidFill>
+        <a:gradFill rotWithShape="1">
+          <a:gsLst>
+            <a:gs pos="0">
+              <a:schemeClr val="phClr">
+                <a:tint val="50000"/>
+                <a:satMod val="300000"/>
+              </a:schemeClr>
+            </a:gs>
+            <a:gs pos="35000">
+              <a:schemeClr val="phClr">
+                <a:tint val="37000"/>
+                <a:satMod val="300000"/>
+              </a:schemeClr>
+            </a:gs>
+            <a:gs pos="100000">
+              <a:schemeClr val="phClr">
+                <a:tint val="15000"/>
+                <a:satMod val="350000"/>
+              </a:schemeClr>
+            </a:gs>
+          </a:gsLst>
+          <a:lin ang="16200000" scaled="1"/>
+        </a:gradFill>
+        <a:gradFill rotWithShape="1">
+          <a:gsLst>
+            <a:gs pos="0">
+              <a:schemeClr val="phClr">
+                <a:tint val="100000"/>
+                <a:shade val="100000"/>
+                <a:satMod val="130000"/>
+              </a:schemeClr>
+            </a:gs>
+            <a:gs pos="100000">
+              <a:schemeClr val="phClr">
+                <a:tint val="50000"/>
+                <a:shade val="100000"/>
+                <a:satMod val="350000"/>
+              </a:schemeClr>
+            </a:gs>
+          </a:gsLst>
+          <a:lin ang="16200000" scaled="0"/>
+        </a:gradFill>
+      </a:fillStyleLst>
+      <a:lnStyleLst>
+        <a:ln w="9525" cap="flat" cmpd="sng" algn="ctr">
+          <a:solidFill>
+            <a:schemeClr val="phClr">
+              <a:shade val="95000"/>
+              <a:satMod val="105000"/>
+            </a:schemeClr>
+          </a:solidFill>
+          <a:prstDash val="solid"/>
+        </a:ln>
+        <a:ln w="25400" cap="flat" cmpd="sng" algn="ctr">
+          <a:solidFill>
+            <a:schemeClr val="phClr"/>
+          </a:solidFill>
+          <a:prstDash val="solid"/>
+        </a:ln>
+        <a:ln w="38100" cap="flat" cmpd="sng" algn="ctr">
+          <a:solidFill>
+            <a:schemeClr val="phClr"/>
+          </a:solidFill>
+          <a:prstDash val="solid"/>
+        </a:ln>
+      </a:lnStyleLst>
+      <a:effectStyleLst>
+        <a:effectStyle>
+          <a:effectLst>
+            <a:outerShdw blurRad="40000" dist="20000" dir="5400000" rotWithShape="0">
+              <a:srgbClr val="000000">
+                <a:alpha val="38000"/>
+              </a:srgbClr>
+            </a:outerShdw>
+          </a:effectLst>
+        </a:effectStyle>
+        <a:effectStyle>
+          <a:effectLst>
+            <a:outerShdw blurRad="40000" dist="23000" dir="5400000" rotWithShape="0">
+              <a:srgbClr val="000000">
+                <a:alpha val="35000"/>
+              </a:srgbClr>
+            </a:outerShdw>
+          </a:effectLst>
+        </a:effectStyle>
+        <a:effectStyle>
+          <a:effectLst>
+            <a:outerShdw blurRad="40000" dist="23000" dir="5400000" rotWithShape="0">
+              <a:srgbClr val="000000">
+                <a:alpha val="35000"/>
+              </a:srgbClr>
+            </a:outerShdw>
+          </a:effectLst>
+          <a:scene3d>
+            <a:camera prst="orthographicFront">
+              <a:rot lat="0" lon="0" rev="0"/>
+            </a:camera>
+            <a:lightRig rig="threePt" dir="t">
+              <a:rot lat="0" lon="0" rev="1200000"/>
+            </a:lightRig>
+          </a:scene3d>
+          <a:sp3d>
+            <a:bevelT w="63500" h="25400"/>
+          </a:sp3d>
+        </a:effectStyle>
+      </a:effectStyleLst>
+      <a:bgFillStyleLst>
+        <a:solidFill>
+          <a:schemeClr val="phClr"/>
+        </a:solidFill>
+        <a:gradFill rotWithShape="1">
+          <a:gsLst>
+            <a:gs pos="0">
+              <a:schemeClr val="phClr">
+                <a:tint val="40000"/>
+                <a:satMod val="350000"/>
+              </a:schemeClr>
+            </a:gs>
+            <a:gs pos="40000">
+              <a:schemeClr val="phClr">
+                <a:tint val="45000"/>
+                <a:shade val="99000"/>
+                <a:satMod val="350000"/>
+              </a:schemeClr>
+            </a:gs>
+            <a:gs pos="100000">
+              <a:schemeClr val="phClr">
+                <a:shade val="20000"/>
+                <a:satMod val="255000"/>
+              </a:schemeClr>
+            </a:gs>
+          </a:gsLst>
+          <a:path path="circle">
+            <a:fillToRect l="50000" t="-80000" r="50000" b="180000"/>
+          </a:path>
+        </a:gradFill>
+        <a:gradFill rotWithShape="1">
+          <a:gsLst>
+            <a:gs pos="0">
+              <a:schemeClr val="phClr">
+                <a:tint val="80000"/>
+                <a:satMod val="300000"/>
+              </a:schemeClr>
+            </a:gs>
+            <a:gs pos="100000">
+              <a:schemeClr val="phClr">
+                <a:shade val="30000"/>
+                <a:satMod val="200000"/>
+              </a:schemeClr>
+            </a:gs>
+          </a:gsLst>
+          <a:path path="circle">
+            <a:fillToRect l="50000" t="50000" r="50000" b="50000"/>
+          </a:path>
+        </a:gradFill>
+      </a:bgFillStyleLst>
+    </a:fmtScheme>
+  </a:themeElements>
+  <a:objectDefaults>
+    <a:spDef>
+      <a:spPr/>
+      <a:bodyPr/>
+      <a:lstStyle/>
+      <a:style>
+        <a:lnRef idx="1">
+          <a:schemeClr val="accent1"/>
+        </a:lnRef>
+        <a:fillRef idx="3">
+          <a:schemeClr val="accent1"/>
+        </a:fillRef>
+        <a:effectRef idx="2">
+          <a:schemeClr val="accent1"/>
+        </a:effectRef>
+        <a:fontRef idx="minor">
+          <a:schemeClr val="lt1"/>
+        </a:fontRef>
+      </a:style>
+    </a:spDef>
+    <a:lnDef>
+      <a:spPr/>
+      <a:bodyPr/>
+      <a:lstStyle/>
+      <a:style>
+        <a:lnRef idx="2">
+          <a:schemeClr val="accent1"/>
+        </a:lnRef>
+        <a:fillRef idx="0">
+          <a:schemeClr val="accent1"/>
+        </a:fillRef>
+        <a:effectRef idx="1">
+          <a:schemeClr val="accent1"/>
+        </a:effectRef>
+        <a:fontRef idx="minor">
+          <a:schemeClr val="tx1"/>
+        </a:fontRef>
+      </a:style>
+    </a:lnDef>
+  </a:objectDefaults>
+  <a:extraClrSchemeLst/>
+</a:theme>
 </file>
</xml_diff>

<commit_message>
Correct calibration slide: numbers now from the leak-free uncertainty run (r=0.345, 0.31-6.72 px) not the old one
</commit_message>
<xml_diff>
--- a/docs/NeuFlow_v3_status.pptx
+++ b/docs/NeuFlow_v3_status.pptx
@@ -587,7 +587,7 @@
           <a:lstStyle/>
           <a:p>
             <a:r>
-              <a:t>This is the capability I am most confident about. The head predicts an error scale for every query alongside the flow itself. When you bin queries by predicted uncertainty, the actual error rises monotonically from 0.22 pixels in the confident bin to 7.4 in the least confident. It is not perfectly correlated, r is 0.38, but it is clearly informative and it is directly usable: weight correspondences in RANSAC, drop unreliable ones, or send more queries where the model is unsure. v2 has no equivalent output, so there is nothing to compare it against.</a:t>
+              <a:t>This is the capability I am most confident about. The head predicts an error scale for every query alongside the flow itself. When you bin queries by predicted uncertainty, the actual error rises monotonically from 0.22 pixels in the confident bin to 6.7 in the least confident, a twenty-one fold span. It is not perfectly correlated, r is 0.345, but it is clearly informative and it is directly usable: weight correspondences in RANSAC, drop unreliable ones, or send more queries where the model is unsure. v2 has no equivalent output, so there is nothing to compare it against.</a:t>
             </a:r>
           </a:p>
         </p:txBody>
@@ -5101,7 +5101,7 @@
                 </a:solidFill>
                 <a:latin typeface="Georgia"/>
               </a:rPr>
-              <a:t>monotonically from 0.22 px to 7.38 px.</a:t>
+              <a:t>monotonically from 0.31 px to 6.72 px,</a:t>
             </a:r>
           </a:p>
           <a:p>
@@ -5117,7 +5117,23 @@
                 </a:solidFill>
                 <a:latin typeface="Georgia"/>
               </a:rPr>
-              <a:t>Pearson r = 0.38 over 2.35M samples.</a:t>
+              <a:t>a 21x span. Pearson r = 0.345 over</a:t>
+            </a:r>
+          </a:p>
+          <a:p>
+            <a:pPr algn="l">
+              <a:lnSpc>
+                <a:spcPct val="118000"/>
+              </a:lnSpc>
+            </a:pPr>
+            <a:r>
+              <a:rPr sz="1150" b="0">
+                <a:solidFill>
+                  <a:srgbClr val="1A1A1A"/>
+                </a:solidFill>
+                <a:latin typeface="Georgia"/>
+              </a:rPr>
+              <a:t>2,348,000 samples.</a:t>
             </a:r>
           </a:p>
           <a:p>

</xml_diff>

<commit_message>
Withdraw both ablation claims: 90k-vs-100k evaluation shows checkpoint noise (0.038 px) exceeds between-run differences and reverses two orderings
</commit_message>
<xml_diff>
--- a/docs/NeuFlow_v3_status.pptx
+++ b/docs/NeuFlow_v3_status.pptx
@@ -1567,7 +1567,7 @@
           <a:lstStyle/>
           <a:p>
             <a:r>
-              <a:t>These two are the cleanest results in the project, because everything is held fixed except one thing. On the left, adding MPI-Sintel to the training mix made it slightly worse despite ten thousand extra pairs, so Sintel does not earn its place. On the right, adding the uncertainty head improved accuracy by two percent on identical data. That is a free gain from an auxiliary loss acting as a regulariser, and it also gives you a confidence signal, which is the next slide.</a:t>
+              <a:t>I want to show you a slide that removes two of my own results. I had claimed two clean ablations: that Sintel adds nothing, and that the uncertainty head helps by two percent. Then I evaluated a second checkpoint of the same runs, ten thousand steps earlier, and both conclusions reversed. Sintel helps at 90k and hurts at 100k. The uncertainty head hurts at 90k and helps at 100k. The differences I was interpreting are smaller than the variation between checkpoints of a single run. So with one seed and one checkpoint I cannot answer either question, and I am not going to pretend otherwise. What is robust is the coarse effect: adding driving data gains about 0.15 pixels at both checkpoints. To resolve anything finer I would need multiple seeds and an average over late checkpoints.</a:t>
             </a:r>
           </a:p>
         </p:txBody>
@@ -8305,7 +8305,7 @@
                 </a:solidFill>
                 <a:latin typeface="Georgia"/>
               </a:rPr>
-              <a:t>One seed per configuration</a:t>
+              <a:t>One seed, and checkpoint noise the size of the effects</a:t>
             </a:r>
           </a:p>
         </p:txBody>
@@ -8344,7 +8344,7 @@
                 </a:solidFill>
                 <a:latin typeface="Georgia"/>
               </a:rPr>
-              <a:t>Differences under about 0.05 px should not be over-read; I have not measured seed-to-seed variance.</a:t>
+              <a:t>Step 90k vs 100k of the same run moves EPE by up to 0.038 px, reversing two of the orderings. Nothing finer than about 0.05 px is resolvable here.</a:t>
             </a:r>
           </a:p>
         </p:txBody>
@@ -14386,7 +14386,7 @@
                 </a:solidFill>
                 <a:latin typeface="Georgia"/>
               </a:rPr>
-              <a:t>Best overall: 2.104 px</a:t>
+              <a:t>The three mixes land between 2.10 and 2.16 px</a:t>
             </a:r>
           </a:p>
           <a:p>
@@ -14398,7 +14398,7 @@
                 </a:solidFill>
                 <a:latin typeface="Georgia"/>
               </a:rPr>
-              <a:t>with uncertainty head,</a:t>
+              <a:t>and are not separable from one another.</a:t>
             </a:r>
           </a:p>
           <a:p>
@@ -14410,7 +14410,7 @@
                 </a:solidFill>
                 <a:latin typeface="Georgia"/>
               </a:rPr>
-              <a:t>trained on FlyingChairs + VKITTI2 + Sintel</a:t>
+              <a:t>See slide 9.</a:t>
             </a:r>
           </a:p>
         </p:txBody>
@@ -15557,14 +15557,14 @@
                 </a:solidFill>
                 <a:latin typeface="Georgia"/>
               </a:rPr>
-              <a:t>Two clean single-variable ablations</a:t>
+              <a:t>What this experiment can and cannot resolve</a:t>
             </a:r>
           </a:p>
         </p:txBody>
       </p:sp>
       <p:pic>
         <p:nvPicPr>
-          <p:cNvPr id="4" name="Picture 3" descr="ablations.png"/>
+          <p:cNvPr id="4" name="Picture 3" descr="checkpoint_noise.png"/>
           <p:cNvPicPr>
             <a:picLocks noChangeAspect="1"/>
           </p:cNvPicPr>
@@ -15578,8 +15578,8 @@
         </p:blipFill>
         <p:spPr>
           <a:xfrm>
-            <a:off x="1051560" y="1554480"/>
-            <a:ext cx="8778240" cy="3653588"/>
+            <a:off x="685800" y="1463040"/>
+            <a:ext cx="6858000" cy="3557255"/>
           </a:xfrm>
           <a:prstGeom prst="rect">
             <a:avLst/>
@@ -15594,72 +15594,331 @@
         </p:nvSpPr>
         <p:spPr>
           <a:xfrm>
-            <a:off x="685800" y="5257800"/>
-            <a:ext cx="10881360" cy="914400"/>
-          </a:xfrm>
-          <a:prstGeom prst="rect">
-            <a:avLst/>
-          </a:prstGeom>
-          <a:noFill/>
-        </p:spPr>
-        <p:txBody>
-          <a:bodyPr wrap="square">
-            <a:spAutoFit/>
-          </a:bodyPr>
-          <a:lstStyle/>
-          <a:p>
-            <a:pPr algn="l">
-              <a:lnSpc>
-                <a:spcPct val="120000"/>
-              </a:lnSpc>
-            </a:pPr>
-            <a:r>
-              <a:rPr sz="1200" b="0">
-                <a:solidFill>
-                  <a:srgbClr val="1A1A1A"/>
-                </a:solidFill>
-                <a:latin typeface="Georgia"/>
-              </a:rPr>
-              <a:t>Both pairs are identical in seed, schedule and every hyperparameter; one thing changes.</a:t>
-            </a:r>
-          </a:p>
-          <a:p>
-            <a:pPr algn="l">
-              <a:lnSpc>
-                <a:spcPct val="120000"/>
-              </a:lnSpc>
-            </a:pPr>
-            <a:r>
-              <a:rPr sz="1200" b="0">
-                <a:solidFill>
-                  <a:srgbClr val="1A1A1A"/>
-                </a:solidFill>
-                <a:latin typeface="Georgia"/>
-              </a:rPr>
-              <a:t>Adding MPI-Sintel to the mix costs 0.4% despite 10,410 extra pairs, so it does not earn its place.</a:t>
-            </a:r>
-          </a:p>
-          <a:p>
-            <a:pPr algn="l">
-              <a:lnSpc>
-                <a:spcPct val="120000"/>
-              </a:lnSpc>
-            </a:pPr>
-            <a:r>
-              <a:rPr sz="1200" b="0">
-                <a:solidFill>
-                  <a:srgbClr val="1A1A1A"/>
-                </a:solidFill>
-                <a:latin typeface="Georgia"/>
-              </a:rPr>
-              <a:t>The uncertainty head gains 2.0% while also producing a confidence value, so it is kept.</a:t>
-            </a:r>
-          </a:p>
-        </p:txBody>
-      </p:sp>
-      <p:sp>
-        <p:nvSpPr>
-          <p:cNvPr id="6" name="TextBox 5"/>
+            <a:off x="7818120" y="1600200"/>
+            <a:ext cx="3840480" cy="3566160"/>
+          </a:xfrm>
+          <a:prstGeom prst="rect">
+            <a:avLst/>
+          </a:prstGeom>
+          <a:noFill/>
+        </p:spPr>
+        <p:txBody>
+          <a:bodyPr wrap="square">
+            <a:spAutoFit/>
+          </a:bodyPr>
+          <a:lstStyle/>
+          <a:p>
+            <a:pPr algn="l">
+              <a:lnSpc>
+                <a:spcPct val="116000"/>
+              </a:lnSpc>
+            </a:pPr>
+            <a:r>
+              <a:rPr sz="1150" b="0">
+                <a:solidFill>
+                  <a:srgbClr val="1A1A1A"/>
+                </a:solidFill>
+                <a:latin typeface="Georgia"/>
+              </a:rPr>
+              <a:t>Evaluating step 90,000 and step 100,000</a:t>
+            </a:r>
+          </a:p>
+          <a:p>
+            <a:pPr algn="l">
+              <a:lnSpc>
+                <a:spcPct val="116000"/>
+              </a:lnSpc>
+            </a:pPr>
+            <a:r>
+              <a:rPr sz="1150" b="0">
+                <a:solidFill>
+                  <a:srgbClr val="1A1A1A"/>
+                </a:solidFill>
+                <a:latin typeface="Georgia"/>
+              </a:rPr>
+              <a:t>of the same four runs moves each result</a:t>
+            </a:r>
+          </a:p>
+          <a:p>
+            <a:pPr algn="l">
+              <a:lnSpc>
+                <a:spcPct val="116000"/>
+              </a:lnSpc>
+            </a:pPr>
+            <a:r>
+              <a:rPr sz="1150" b="0">
+                <a:solidFill>
+                  <a:srgbClr val="1A1A1A"/>
+                </a:solidFill>
+                <a:latin typeface="Georgia"/>
+              </a:rPr>
+              <a:t>by up to 0.038 px.</a:t>
+            </a:r>
+          </a:p>
+          <a:p>
+            <a:pPr algn="l">
+              <a:lnSpc>
+                <a:spcPct val="116000"/>
+              </a:lnSpc>
+            </a:pPr>
+            <a:r>
+              <a:rPr sz="1150" b="0">
+                <a:solidFill>
+                  <a:srgbClr val="1A1A1A"/>
+                </a:solidFill>
+                <a:latin typeface="Georgia"/>
+              </a:rPr>
+              <a:t/>
+            </a:r>
+          </a:p>
+          <a:p>
+            <a:pPr algn="l">
+              <a:lnSpc>
+                <a:spcPct val="116000"/>
+              </a:lnSpc>
+            </a:pPr>
+            <a:r>
+              <a:rPr sz="1150" b="0">
+                <a:solidFill>
+                  <a:srgbClr val="1A1A1A"/>
+                </a:solidFill>
+                <a:latin typeface="Georgia"/>
+              </a:rPr>
+              <a:t>The differences between the runs are the</a:t>
+            </a:r>
+          </a:p>
+          <a:p>
+            <a:pPr algn="l">
+              <a:lnSpc>
+                <a:spcPct val="116000"/>
+              </a:lnSpc>
+            </a:pPr>
+            <a:r>
+              <a:rPr sz="1150" b="0">
+                <a:solidFill>
+                  <a:srgbClr val="1A1A1A"/>
+                </a:solidFill>
+                <a:latin typeface="Georgia"/>
+              </a:rPr>
+              <a:t>same size. Two orderings reverse:</a:t>
+            </a:r>
+          </a:p>
+          <a:p>
+            <a:pPr algn="l">
+              <a:lnSpc>
+                <a:spcPct val="116000"/>
+              </a:lnSpc>
+            </a:pPr>
+            <a:r>
+              <a:rPr sz="1150" b="0">
+                <a:solidFill>
+                  <a:srgbClr val="1A1A1A"/>
+                </a:solidFill>
+                <a:latin typeface="Georgia"/>
+              </a:rPr>
+              <a:t/>
+            </a:r>
+          </a:p>
+          <a:p>
+            <a:pPr algn="l">
+              <a:lnSpc>
+                <a:spcPct val="116000"/>
+              </a:lnSpc>
+            </a:pPr>
+            <a:r>
+              <a:rPr sz="1150" b="0">
+                <a:solidFill>
+                  <a:srgbClr val="1A1A1A"/>
+                </a:solidFill>
+                <a:latin typeface="Georgia"/>
+              </a:rPr>
+              <a:t>  MPI-Sintel helps at 90k (-0.051),</a:t>
+            </a:r>
+          </a:p>
+          <a:p>
+            <a:pPr algn="l">
+              <a:lnSpc>
+                <a:spcPct val="116000"/>
+              </a:lnSpc>
+            </a:pPr>
+            <a:r>
+              <a:rPr sz="1150" b="0">
+                <a:solidFill>
+                  <a:srgbClr val="1A1A1A"/>
+                </a:solidFill>
+                <a:latin typeface="Georgia"/>
+              </a:rPr>
+              <a:t>  hurts at 100k (+0.009)</a:t>
+            </a:r>
+          </a:p>
+          <a:p>
+            <a:pPr algn="l">
+              <a:lnSpc>
+                <a:spcPct val="116000"/>
+              </a:lnSpc>
+            </a:pPr>
+            <a:r>
+              <a:rPr sz="1150" b="0">
+                <a:solidFill>
+                  <a:srgbClr val="1A1A1A"/>
+                </a:solidFill>
+                <a:latin typeface="Georgia"/>
+              </a:rPr>
+              <a:t/>
+            </a:r>
+          </a:p>
+          <a:p>
+            <a:pPr algn="l">
+              <a:lnSpc>
+                <a:spcPct val="116000"/>
+              </a:lnSpc>
+            </a:pPr>
+            <a:r>
+              <a:rPr sz="1150" b="0">
+                <a:solidFill>
+                  <a:srgbClr val="1A1A1A"/>
+                </a:solidFill>
+                <a:latin typeface="Georgia"/>
+              </a:rPr>
+              <a:t>  the uncertainty head hurts at 90k</a:t>
+            </a:r>
+          </a:p>
+          <a:p>
+            <a:pPr algn="l">
+              <a:lnSpc>
+                <a:spcPct val="116000"/>
+              </a:lnSpc>
+            </a:pPr>
+            <a:r>
+              <a:rPr sz="1150" b="0">
+                <a:solidFill>
+                  <a:srgbClr val="1A1A1A"/>
+                </a:solidFill>
+                <a:latin typeface="Georgia"/>
+              </a:rPr>
+              <a:t>  (+0.011), helps at 100k (-0.043)</a:t>
+            </a:r>
+          </a:p>
+          <a:p>
+            <a:pPr algn="l">
+              <a:lnSpc>
+                <a:spcPct val="116000"/>
+              </a:lnSpc>
+            </a:pPr>
+            <a:r>
+              <a:rPr sz="1150" b="0">
+                <a:solidFill>
+                  <a:srgbClr val="1A1A1A"/>
+                </a:solidFill>
+                <a:latin typeface="Georgia"/>
+              </a:rPr>
+              <a:t/>
+            </a:r>
+          </a:p>
+          <a:p>
+            <a:pPr algn="l">
+              <a:lnSpc>
+                <a:spcPct val="116000"/>
+              </a:lnSpc>
+            </a:pPr>
+            <a:r>
+              <a:rPr sz="1150" b="0">
+                <a:solidFill>
+                  <a:srgbClr val="1A1A1A"/>
+                </a:solidFill>
+                <a:latin typeface="Georgia"/>
+              </a:rPr>
+              <a:t>With one seed and one checkpoint,</a:t>
+            </a:r>
+          </a:p>
+          <a:p>
+            <a:pPr algn="l">
+              <a:lnSpc>
+                <a:spcPct val="116000"/>
+              </a:lnSpc>
+            </a:pPr>
+            <a:r>
+              <a:rPr sz="1150" b="0">
+                <a:solidFill>
+                  <a:srgbClr val="1A1A1A"/>
+                </a:solidFill>
+                <a:latin typeface="Georgia"/>
+              </a:rPr>
+              <a:t>neither question is answerable.</a:t>
+            </a:r>
+          </a:p>
+        </p:txBody>
+      </p:sp>
+      <p:sp>
+        <p:nvSpPr>
+          <p:cNvPr id="6" name="Rounded Rectangle 5"/>
+          <p:cNvSpPr/>
+          <p:nvPr/>
+        </p:nvSpPr>
+        <p:spPr>
+          <a:xfrm>
+            <a:off x="685800" y="5440680"/>
+            <a:ext cx="6858000" cy="777240"/>
+          </a:xfrm>
+          <a:prstGeom prst="roundRect">
+            <a:avLst/>
+          </a:prstGeom>
+          <a:solidFill>
+            <a:srgbClr val="EFEFEF"/>
+          </a:solidFill>
+          <a:ln w="9525">
+            <a:solidFill>
+              <a:srgbClr val="8A8A8A"/>
+            </a:solidFill>
+          </a:ln>
+          <a:effectLst/>
+        </p:spPr>
+        <p:style>
+          <a:lnRef idx="1">
+            <a:schemeClr val="accent1"/>
+          </a:lnRef>
+          <a:fillRef idx="3">
+            <a:schemeClr val="accent1"/>
+          </a:fillRef>
+          <a:effectRef idx="2">
+            <a:schemeClr val="accent1"/>
+          </a:effectRef>
+          <a:fontRef idx="minor">
+            <a:schemeClr val="lt1"/>
+          </a:fontRef>
+        </p:style>
+        <p:txBody>
+          <a:bodyPr rtlCol="0" anchor="ctr" wrap="square" lIns="73152" rIns="73152"/>
+          <a:lstStyle/>
+          <a:p>
+            <a:pPr algn="ctr"/>
+            <a:r>
+              <a:rPr sz="1100" b="0">
+                <a:solidFill>
+                  <a:srgbClr val="1A1A1A"/>
+                </a:solidFill>
+                <a:latin typeface="Georgia"/>
+              </a:rPr>
+              <a:t>What IS robust: adding driving data to FlyingChairs gains about 0.15 px and 5 points of 1-pixel</a:t>
+            </a:r>
+          </a:p>
+          <a:p>
+            <a:pPr algn="ctr"/>
+            <a:r>
+              <a:rPr sz="1100" b="0">
+                <a:solidFill>
+                  <a:srgbClr val="1A1A1A"/>
+                </a:solidFill>
+                <a:latin typeface="Georgia"/>
+              </a:rPr>
+              <a:t>accuracy at BOTH checkpoints. Everything finer than that is inside the noise.</a:t>
+            </a:r>
+          </a:p>
+        </p:txBody>
+      </p:sp>
+      <p:sp>
+        <p:nvSpPr>
+          <p:cNvPr id="7" name="TextBox 6"/>
           <p:cNvSpPr txBox="1"/>
           <p:nvPr/>
         </p:nvSpPr>
@@ -15698,7 +15957,7 @@
       </p:sp>
       <p:sp>
         <p:nvSpPr>
-          <p:cNvPr id="7" name="TextBox 6"/>
+          <p:cNvPr id="8" name="TextBox 7"/>
           <p:cNvSpPr txBox="1"/>
           <p:nvPr/>
         </p:nvSpPr>

</xml_diff>

<commit_message>
Clean re-runs with verified-frozen front end: withdraw the accuracy-parity claim, v3 is 2.6% behind v2; update report, README, deck and figures
</commit_message>
<xml_diff>
--- a/docs/NeuFlow_v3_status.pptx
+++ b/docs/NeuFlow_v3_status.pptx
@@ -1147,7 +1147,7 @@
           <a:lstStyle/>
           <a:p>
             <a:r>
-              <a:t>NeuFlow v2 is the lab's real-time flow network. Backbone, matching, refinement, then a convex upsampler that turns 1/8 resolution flow into full resolution. I freeze everything up to the coarse flow and change only the last stage. On our V100 it runs a full frame in 19.6 milliseconds at 2.324 pixels of error. Its limitation is structural: the output is always the same size and always costs the same, whether you need one pixel or all of them.</a:t>
+              <a:t>NeuFlow v2 is the lab's real-time flow network. Backbone, matching, refinement, then a convex upsampler that turns 1/8 resolution flow into full resolution. I freeze everything up to the coarse flow and change only the last stage. On our V100 it runs a full frame in 19.3 milliseconds at 2.324 pixels of error. Its limitation is structural: the output is always the same size and always costs the same, whether you need one pixel or all of them.</a:t>
             </a:r>
           </a:p>
         </p:txBody>
@@ -1497,7 +1497,7 @@
           <a:lstStyle/>
           <a:p>
             <a:r>
-              <a:t>Speed. Three of these four bars are not wins. Dense v3 is twelve percent slower than v2, and I want to flag that an earlier version of this deck claimed v3 dense was faster. That measurement was taken before the BatchNorm fix and on a different GPU. It was wrong and I have withdrawn it. A first sparse query is level with v2, not faster, because the coarse pass dominates and you cannot avoid it. The real win is the fourth bar: asking a second question about a frame you have already processed costs 2.6 milliseconds against v2's 19.6, because v2 has no cached state and must redo everything. That is structural, not a margin.</a:t>
+              <a:t>Speed. Three of these four bars are not wins. Dense v3 is twelve percent slower than v2, and I want to flag that an earlier version of this deck claimed v3 dense was faster. That measurement was taken before the BatchNorm fix and on a different GPU. It was wrong and I have withdrawn it. A first sparse query is level with v2, not faster, because the coarse pass dominates and you cannot avoid it. The real win is the fourth bar: asking a second question about a frame you have already processed costs 2.6 milliseconds against v2's 19.3, because v2 has no cached state and must redo everything. That is structural, not a margin.</a:t>
             </a:r>
           </a:p>
         </p:txBody>
@@ -5101,7 +5101,7 @@
                 </a:solidFill>
                 <a:latin typeface="Georgia"/>
               </a:rPr>
-              <a:t>monotonically from 0.31 px to 6.72 px,</a:t>
+              <a:t>monotonically from 0.48 px to 7.10 px,</a:t>
             </a:r>
           </a:p>
           <a:p>
@@ -5117,7 +5117,7 @@
                 </a:solidFill>
                 <a:latin typeface="Georgia"/>
               </a:rPr>
-              <a:t>a 21x span. Pearson r = 0.345 over</a:t>
+              <a:t>a 15x span. Pearson r = 0.318 over</a:t>
             </a:r>
           </a:p>
           <a:p>
@@ -6685,7 +6685,7 @@
                 </a:solidFill>
                 <a:latin typeface="Georgia"/>
               </a:rPr>
-              <a:t>fair comparison is 2.286 vs 2.324, a tie</a:t>
+              <a:t>best v3 2.384 vs 2.324; every config above v2</a:t>
             </a:r>
           </a:p>
         </p:txBody>
@@ -6802,7 +6802,7 @@
                 </a:solidFill>
                 <a:latin typeface="Georgia"/>
               </a:rPr>
-              <a:t>better numbers require in-domain training data</a:t>
+              <a:t>like-for-like 2.500, i.e. 7.6% behind</a:t>
             </a:r>
           </a:p>
         </p:txBody>
@@ -7036,7 +7036,7 @@
                 </a:solidFill>
                 <a:latin typeface="Georgia"/>
               </a:rPr>
-              <a:t>dense 12% slower; first query level</a:t>
+              <a:t>dense 14% slower; first query level</a:t>
             </a:r>
           </a:p>
         </p:txBody>
@@ -7153,7 +7153,7 @@
                 </a:solidFill>
                 <a:latin typeface="Georgia"/>
               </a:rPr>
-              <a:t>repeat query 7.7x cheaper (2.6 vs 19.6 ms)</a:t>
+              <a:t>repeat query 7.7x cheaper (2.6 vs 19.3 ms)</a:t>
             </a:r>
           </a:p>
         </p:txBody>
@@ -11211,7 +11211,7 @@
                 </a:solidFill>
                 <a:latin typeface="Georgia"/>
               </a:rPr>
-              <a:t>19.6 ms</a:t>
+              <a:t>19.3 ms</a:t>
             </a:r>
           </a:p>
         </p:txBody>
@@ -14092,7 +14092,7 @@
                 </a:solidFill>
                 <a:latin typeface="Georgia"/>
               </a:rPr>
-              <a:t>Accuracy: the fair comparison is a tie</a:t>
+              <a:t>Accuracy: the decoder costs 2.6 percent</a:t>
             </a:r>
           </a:p>
         </p:txBody>
@@ -14155,7 +14155,7 @@
                 </a:solidFill>
                 <a:latin typeface="Georgia"/>
               </a:rPr>
-              <a:t>Only the FlyingChairs run is a like-for-like</a:t>
+              <a:t>Every v3 configuration sits above v2.</a:t>
             </a:r>
           </a:p>
           <a:p>
@@ -14171,7 +14171,7 @@
                 </a:solidFill>
                 <a:latin typeface="Georgia"/>
               </a:rPr>
-              <a:t>comparison with v2: it never saw driving</a:t>
+              <a:t/>
             </a:r>
           </a:p>
           <a:p>
@@ -14187,7 +14187,7 @@
                 </a:solidFill>
                 <a:latin typeface="Georgia"/>
               </a:rPr>
-              <a:t>imagery, exactly as v2 never did.</a:t>
+              <a:t>Best: 2.384 against v2 at 2.324, so 2.6%</a:t>
             </a:r>
           </a:p>
           <a:p>
@@ -14203,6 +14203,38 @@
                 </a:solidFill>
                 <a:latin typeface="Georgia"/>
               </a:rPr>
+              <a:t>worse on mean error and 1.5 points worse</a:t>
+            </a:r>
+          </a:p>
+          <a:p>
+            <a:pPr algn="l">
+              <a:lnSpc>
+                <a:spcPct val="118000"/>
+              </a:lnSpc>
+            </a:pPr>
+            <a:r>
+              <a:rPr sz="1150" b="0">
+                <a:solidFill>
+                  <a:srgbClr val="1A1A1A"/>
+                </a:solidFill>
+                <a:latin typeface="Georgia"/>
+              </a:rPr>
+              <a:t>on 1-pixel accuracy.</a:t>
+            </a:r>
+          </a:p>
+          <a:p>
+            <a:pPr algn="l">
+              <a:lnSpc>
+                <a:spcPct val="118000"/>
+              </a:lnSpc>
+            </a:pPr>
+            <a:r>
+              <a:rPr sz="1150" b="0">
+                <a:solidFill>
+                  <a:srgbClr val="1A1A1A"/>
+                </a:solidFill>
+                <a:latin typeface="Georgia"/>
+              </a:rPr>
               <a:t/>
             </a:r>
           </a:p>
@@ -14219,7 +14251,7 @@
                 </a:solidFill>
                 <a:latin typeface="Georgia"/>
               </a:rPr>
-              <a:t>It scores 2.286 against v2 at 2.324.</a:t>
+              <a:t>Like-for-like, trained on FlyingChairs only</a:t>
             </a:r>
           </a:p>
           <a:p>
@@ -14235,7 +14267,7 @@
                 </a:solidFill>
                 <a:latin typeface="Georgia"/>
               </a:rPr>
-              <a:t>A 1.6% difference is a tie, not a win.</a:t>
+              <a:t>as v2 was, it is 2.500, or 7.6% behind.</a:t>
             </a:r>
           </a:p>
           <a:p>
@@ -14267,7 +14299,7 @@
                 </a:solidFill>
                 <a:latin typeface="Georgia"/>
               </a:rPr>
-              <a:t>The other three train on VKITTI2 imagery</a:t>
+              <a:t>The implicit decoder is less accurate than</a:t>
             </a:r>
           </a:p>
           <a:p>
@@ -14283,7 +14315,7 @@
                 </a:solidFill>
                 <a:latin typeface="Georgia"/>
               </a:rPr>
-              <a:t>from the same simulator and camera as the</a:t>
+              <a:t>the convex upsampler it replaces. The cause</a:t>
             </a:r>
           </a:p>
           <a:p>
@@ -14299,7 +14331,7 @@
                 </a:solidFill>
                 <a:latin typeface="Georgia"/>
               </a:rPr>
-              <a:t>test scenes. Their better numbers measure</a:t>
+              <a:t>is known and is not a training artefact:</a:t>
             </a:r>
           </a:p>
           <a:p>
@@ -14315,23 +14347,7 @@
                 </a:solidFill>
                 <a:latin typeface="Georgia"/>
               </a:rPr>
-              <a:t>domain advantage, not a better method,</a:t>
-            </a:r>
-          </a:p>
-          <a:p>
-            <a:pPr algn="l">
-              <a:lnSpc>
-                <a:spcPct val="118000"/>
-              </a:lnSpc>
-            </a:pPr>
-            <a:r>
-              <a:rPr sz="1150" b="0">
-                <a:solidFill>
-                  <a:srgbClr val="1A1A1A"/>
-                </a:solidFill>
-                <a:latin typeface="Georgia"/>
-              </a:rPr>
-              <a:t>and I do not present them as beating v2.</a:t>
+              <a:t>see the precision slide.</a:t>
             </a:r>
           </a:p>
         </p:txBody>
@@ -14386,7 +14402,7 @@
                 </a:solidFill>
                 <a:latin typeface="Georgia"/>
               </a:rPr>
-              <a:t>The three mixes land between 2.10 and 2.16 px</a:t>
+              <a:t>These replace an earlier set showing 2.10-2.29 px,</a:t>
             </a:r>
           </a:p>
           <a:p>
@@ -14398,7 +14414,7 @@
                 </a:solidFill>
                 <a:latin typeface="Georgia"/>
               </a:rPr>
-              <a:t>and are not separable from one another.</a:t>
+              <a:t>produced by runs whose frozen backbone was</a:t>
             </a:r>
           </a:p>
           <a:p>
@@ -14410,7 +14426,7 @@
                 </a:solidFill>
                 <a:latin typeface="Georgia"/>
               </a:rPr>
-              <a:t>See slide 9.</a:t>
+              <a:t>silently drifting. See slide 9.</a:t>
             </a:r>
           </a:p>
         </p:txBody>
@@ -15124,7 +15140,7 @@
                 </a:solidFill>
                 <a:latin typeface="Georgia"/>
               </a:rPr>
-              <a:t>Dense: v3 is 12% slower</a:t>
+              <a:t>Dense: v3 is 14% slower</a:t>
             </a:r>
           </a:p>
           <a:p>
@@ -15371,7 +15387,7 @@
                 </a:solidFill>
                 <a:latin typeface="Georgia"/>
               </a:rPr>
-              <a:t>2.6 ms against 19.6 ms.</a:t>
+              <a:t>2.6 ms against 19.3 ms.</a:t>
             </a:r>
           </a:p>
           <a:p>
@@ -15557,14 +15573,14 @@
                 </a:solidFill>
                 <a:latin typeface="Georgia"/>
               </a:rPr>
-              <a:t>What this experiment can and cannot resolve</a:t>
+              <a:t>What the frozen-backbone fix was worth</a:t>
             </a:r>
           </a:p>
         </p:txBody>
       </p:sp>
       <p:pic>
         <p:nvPicPr>
-          <p:cNvPr id="4" name="Picture 3" descr="checkpoint_noise.png"/>
+          <p:cNvPr id="4" name="Picture 3" descr="freeze_effect.png"/>
           <p:cNvPicPr>
             <a:picLocks noChangeAspect="1"/>
           </p:cNvPicPr>
@@ -15579,7 +15595,7 @@
         <p:spPr>
           <a:xfrm>
             <a:off x="685800" y="1463040"/>
-            <a:ext cx="6858000" cy="3557255"/>
+            <a:ext cx="6858000" cy="3554746"/>
           </a:xfrm>
           <a:prstGeom prst="rect">
             <a:avLst/>
@@ -15620,7 +15636,7 @@
                 </a:solidFill>
                 <a:latin typeface="Georgia"/>
               </a:rPr>
-              <a:t>Evaluating step 90,000 and step 100,000</a:t>
+              <a:t>BatchNorm updates its running statistics</a:t>
             </a:r>
           </a:p>
           <a:p>
@@ -15636,7 +15652,7 @@
                 </a:solidFill>
                 <a:latin typeface="Georgia"/>
               </a:rPr>
-              <a:t>of the same four runs moves each result</a:t>
+              <a:t>on every forward pass in train mode,</a:t>
             </a:r>
           </a:p>
           <a:p>
@@ -15652,7 +15668,7 @@
                 </a:solidFill>
                 <a:latin typeface="Georgia"/>
               </a:rPr>
-              <a:t>by up to 0.038 px.</a:t>
+              <a:t>whatever requires_grad says.</a:t>
             </a:r>
           </a:p>
           <a:p>
@@ -15684,7 +15700,7 @@
                 </a:solidFill>
                 <a:latin typeface="Georgia"/>
               </a:rPr>
-              <a:t>The differences between the runs are the</a:t>
+              <a:t>My first fix held them in eval mode once</a:t>
             </a:r>
           </a:p>
           <a:p>
@@ -15700,7 +15716,7 @@
                 </a:solidFill>
                 <a:latin typeface="Georgia"/>
               </a:rPr>
-              <a:t>same size. Two orderings reverse:</a:t>
+              <a:t>per epoch. The validation block calls</a:t>
             </a:r>
           </a:p>
           <a:p>
@@ -15716,6 +15732,38 @@
                 </a:solidFill>
                 <a:latin typeface="Georgia"/>
               </a:rPr>
+              <a:t>model.train() again every 5,000 steps,</a:t>
+            </a:r>
+          </a:p>
+          <a:p>
+            <a:pPr algn="l">
+              <a:lnSpc>
+                <a:spcPct val="116000"/>
+              </a:lnSpc>
+            </a:pPr>
+            <a:r>
+              <a:rPr sz="1150" b="0">
+                <a:solidFill>
+                  <a:srgbClr val="1A1A1A"/>
+                </a:solidFill>
+                <a:latin typeface="Georgia"/>
+              </a:rPr>
+              <a:t>which silently re-enabled them.</a:t>
+            </a:r>
+          </a:p>
+          <a:p>
+            <a:pPr algn="l">
+              <a:lnSpc>
+                <a:spcPct val="116000"/>
+              </a:lnSpc>
+            </a:pPr>
+            <a:r>
+              <a:rPr sz="1150" b="0">
+                <a:solidFill>
+                  <a:srgbClr val="1A1A1A"/>
+                </a:solidFill>
+                <a:latin typeface="Georgia"/>
+              </a:rPr>
               <a:t/>
             </a:r>
           </a:p>
@@ -15732,7 +15780,7 @@
                 </a:solidFill>
                 <a:latin typeface="Georgia"/>
               </a:rPr>
-              <a:t>  MPI-Sintel helps at 90k (-0.051),</a:t>
+              <a:t>Result: 24,765 updates during a run that</a:t>
             </a:r>
           </a:p>
           <a:p>
@@ -15748,7 +15796,7 @@
                 </a:solidFill>
                 <a:latin typeface="Georgia"/>
               </a:rPr>
-              <a:t>  hurts at 100k (+0.009)</a:t>
+              <a:t>was supposed to be frozen, worth about</a:t>
             </a:r>
           </a:p>
           <a:p>
@@ -15764,6 +15812,38 @@
                 </a:solidFill>
                 <a:latin typeface="Georgia"/>
               </a:rPr>
+              <a:t>0.25 px, which is what made v3 look</a:t>
+            </a:r>
+          </a:p>
+          <a:p>
+            <a:pPr algn="l">
+              <a:lnSpc>
+                <a:spcPct val="116000"/>
+              </a:lnSpc>
+            </a:pPr>
+            <a:r>
+              <a:rPr sz="1150" b="0">
+                <a:solidFill>
+                  <a:srgbClr val="1A1A1A"/>
+                </a:solidFill>
+                <a:latin typeface="Georgia"/>
+              </a:rPr>
+              <a:t>equal to v2.</a:t>
+            </a:r>
+          </a:p>
+          <a:p>
+            <a:pPr algn="l">
+              <a:lnSpc>
+                <a:spcPct val="116000"/>
+              </a:lnSpc>
+            </a:pPr>
+            <a:r>
+              <a:rPr sz="1150" b="0">
+                <a:solidFill>
+                  <a:srgbClr val="1A1A1A"/>
+                </a:solidFill>
+                <a:latin typeface="Georgia"/>
+              </a:rPr>
               <a:t/>
             </a:r>
           </a:p>
@@ -15780,7 +15860,7 @@
                 </a:solidFill>
                 <a:latin typeface="Georgia"/>
               </a:rPr>
-              <a:t>  the uncertainty head hurts at 90k</a:t>
+              <a:t>Now verified per checkpoint: all 137</a:t>
             </a:r>
           </a:p>
           <a:p>
@@ -15796,55 +15876,7 @@
                 </a:solidFill>
                 <a:latin typeface="Georgia"/>
               </a:rPr>
-              <a:t>  (+0.011), helps at 100k (-0.043)</a:t>
-            </a:r>
-          </a:p>
-          <a:p>
-            <a:pPr algn="l">
-              <a:lnSpc>
-                <a:spcPct val="116000"/>
-              </a:lnSpc>
-            </a:pPr>
-            <a:r>
-              <a:rPr sz="1150" b="0">
-                <a:solidFill>
-                  <a:srgbClr val="1A1A1A"/>
-                </a:solidFill>
-                <a:latin typeface="Georgia"/>
-              </a:rPr>
-              <a:t/>
-            </a:r>
-          </a:p>
-          <a:p>
-            <a:pPr algn="l">
-              <a:lnSpc>
-                <a:spcPct val="116000"/>
-              </a:lnSpc>
-            </a:pPr>
-            <a:r>
-              <a:rPr sz="1150" b="0">
-                <a:solidFill>
-                  <a:srgbClr val="1A1A1A"/>
-                </a:solidFill>
-                <a:latin typeface="Georgia"/>
-              </a:rPr>
-              <a:t>With one seed and one checkpoint,</a:t>
-            </a:r>
-          </a:p>
-          <a:p>
-            <a:pPr algn="l">
-              <a:lnSpc>
-                <a:spcPct val="116000"/>
-              </a:lnSpc>
-            </a:pPr>
-            <a:r>
-              <a:rPr sz="1150" b="0">
-                <a:solidFill>
-                  <a:srgbClr val="1A1A1A"/>
-                </a:solidFill>
-                <a:latin typeface="Georgia"/>
-              </a:rPr>
-              <a:t>neither question is answerable.</a:t>
+              <a:t>shared tensors bit-identical to v2.</a:t>
             </a:r>
           </a:p>
         </p:txBody>
@@ -15899,7 +15931,7 @@
                 </a:solidFill>
                 <a:latin typeface="Georgia"/>
               </a:rPr>
-              <a:t>What IS robust: adding driving data to FlyingChairs gains about 0.15 px and 5 points of 1-pixel</a:t>
+              <a:t>Every accuracy number in this deck comes from the frozen runs. The drifted ones are shown here only</a:t>
             </a:r>
           </a:p>
           <a:p>
@@ -15911,7 +15943,7 @@
                 </a:solidFill>
                 <a:latin typeface="Georgia"/>
               </a:rPr>
-              <a:t>accuracy at BOTH checkpoints. Everything finer than that is inside the noise.</a:t>
+              <a:t>to record what the error was worth.</a:t>
             </a:r>
           </a:p>
         </p:txBody>

</xml_diff>

<commit_message>
paper and deck: add the aerial scenario figure
TartanAir S1/S2/S3 illustrations alongside the driving ones. Also tightens the
4:3 figure geometry, which was leaving a gutter the panels did not fill.
</commit_message>
<xml_diff>
--- a/docs/NeuFlow_v3_status.pptx
+++ b/docs/NeuFlow_v3_status.pptx
@@ -7270,7 +7270,7 @@
         <p:spPr>
           <a:xfrm>
             <a:off x="960120" y="1463040"/>
-            <a:ext cx="10241280" cy="4063457"/>
+            <a:ext cx="10241280" cy="4086196"/>
           </a:xfrm>
           <a:prstGeom prst="rect">
             <a:avLst/>
@@ -7546,9 +7546,33 @@
           </a:p>
         </p:txBody>
       </p:sp>
-      <p:sp>
-        <p:nvSpPr>
-          <p:cNvPr id="4" name="TextBox 3"/>
+      <p:pic>
+        <p:nvPicPr>
+          <p:cNvPr id="4" name="Picture 3" descr="scenarios_tartanair.png"/>
+          <p:cNvPicPr>
+            <a:picLocks noChangeAspect="1"/>
+          </p:cNvPicPr>
+          <p:nvPr/>
+        </p:nvPicPr>
+        <p:blipFill>
+          <a:blip r:embed="rId2"/>
+          <a:stretch>
+            <a:fillRect/>
+          </a:stretch>
+        </p:blipFill>
+        <p:spPr>
+          <a:xfrm>
+            <a:off x="640080" y="1417320"/>
+            <a:ext cx="4779133" cy="4114800"/>
+          </a:xfrm>
+          <a:prstGeom prst="rect">
+            <a:avLst/>
+          </a:prstGeom>
+        </p:spPr>
+      </p:pic>
+      <p:sp>
+        <p:nvSpPr>
+          <p:cNvPr id="5" name="TextBox 4"/>
           <p:cNvSpPr txBox="1"/>
           <p:nvPr/>
         </p:nvSpPr>
@@ -7587,7 +7611,7 @@
       </p:sp>
       <p:sp>
         <p:nvSpPr>
-          <p:cNvPr id="5" name="TextBox 4"/>
+          <p:cNvPr id="6" name="TextBox 5"/>
           <p:cNvSpPr txBox="1"/>
           <p:nvPr/>
         </p:nvSpPr>
@@ -7626,7 +7650,7 @@
       </p:sp>
       <p:sp>
         <p:nvSpPr>
-          <p:cNvPr id="6" name="TextBox 5"/>
+          <p:cNvPr id="7" name="TextBox 6"/>
           <p:cNvSpPr txBox="1"/>
           <p:nvPr/>
         </p:nvSpPr>
@@ -7665,7 +7689,7 @@
       </p:sp>
       <p:sp>
         <p:nvSpPr>
-          <p:cNvPr id="7" name="Rectangle 6"/>
+          <p:cNvPr id="8" name="Rectangle 7"/>
           <p:cNvSpPr/>
           <p:nvPr/>
         </p:nvSpPr>
@@ -7709,7 +7733,7 @@
       </p:sp>
       <p:sp>
         <p:nvSpPr>
-          <p:cNvPr id="8" name="TextBox 7"/>
+          <p:cNvPr id="9" name="TextBox 8"/>
           <p:cNvSpPr txBox="1"/>
           <p:nvPr/>
         </p:nvSpPr>
@@ -7748,7 +7772,7 @@
       </p:sp>
       <p:sp>
         <p:nvSpPr>
-          <p:cNvPr id="9" name="TextBox 8"/>
+          <p:cNvPr id="10" name="TextBox 9"/>
           <p:cNvSpPr txBox="1"/>
           <p:nvPr/>
         </p:nvSpPr>
@@ -7787,7 +7811,7 @@
       </p:sp>
       <p:sp>
         <p:nvSpPr>
-          <p:cNvPr id="10" name="TextBox 9"/>
+          <p:cNvPr id="11" name="TextBox 10"/>
           <p:cNvSpPr txBox="1"/>
           <p:nvPr/>
         </p:nvSpPr>
@@ -7826,7 +7850,7 @@
       </p:sp>
       <p:sp>
         <p:nvSpPr>
-          <p:cNvPr id="11" name="TextBox 10"/>
+          <p:cNvPr id="12" name="TextBox 11"/>
           <p:cNvSpPr txBox="1"/>
           <p:nvPr/>
         </p:nvSpPr>
@@ -7865,7 +7889,7 @@
       </p:sp>
       <p:sp>
         <p:nvSpPr>
-          <p:cNvPr id="12" name="TextBox 11"/>
+          <p:cNvPr id="13" name="TextBox 12"/>
           <p:cNvSpPr txBox="1"/>
           <p:nvPr/>
         </p:nvSpPr>
@@ -7904,7 +7928,7 @@
       </p:sp>
       <p:sp>
         <p:nvSpPr>
-          <p:cNvPr id="13" name="TextBox 12"/>
+          <p:cNvPr id="14" name="TextBox 13"/>
           <p:cNvSpPr txBox="1"/>
           <p:nvPr/>
         </p:nvSpPr>
@@ -7943,7 +7967,7 @@
       </p:sp>
       <p:sp>
         <p:nvSpPr>
-          <p:cNvPr id="14" name="TextBox 13"/>
+          <p:cNvPr id="15" name="TextBox 14"/>
           <p:cNvSpPr txBox="1"/>
           <p:nvPr/>
         </p:nvSpPr>
@@ -7982,7 +8006,7 @@
       </p:sp>
       <p:sp>
         <p:nvSpPr>
-          <p:cNvPr id="15" name="TextBox 14"/>
+          <p:cNvPr id="16" name="TextBox 15"/>
           <p:cNvSpPr txBox="1"/>
           <p:nvPr/>
         </p:nvSpPr>
@@ -8021,7 +8045,7 @@
       </p:sp>
       <p:sp>
         <p:nvSpPr>
-          <p:cNvPr id="16" name="TextBox 15"/>
+          <p:cNvPr id="17" name="TextBox 16"/>
           <p:cNvSpPr txBox="1"/>
           <p:nvPr/>
         </p:nvSpPr>
@@ -8060,7 +8084,7 @@
       </p:sp>
       <p:sp>
         <p:nvSpPr>
-          <p:cNvPr id="17" name="TextBox 16"/>
+          <p:cNvPr id="18" name="TextBox 17"/>
           <p:cNvSpPr txBox="1"/>
           <p:nvPr/>
         </p:nvSpPr>
@@ -8099,7 +8123,7 @@
       </p:sp>
       <p:sp>
         <p:nvSpPr>
-          <p:cNvPr id="18" name="TextBox 17"/>
+          <p:cNvPr id="19" name="TextBox 18"/>
           <p:cNvSpPr txBox="1"/>
           <p:nvPr/>
         </p:nvSpPr>
@@ -8138,7 +8162,7 @@
       </p:sp>
       <p:sp>
         <p:nvSpPr>
-          <p:cNvPr id="19" name="TextBox 18"/>
+          <p:cNvPr id="20" name="TextBox 19"/>
           <p:cNvSpPr txBox="1"/>
           <p:nvPr/>
         </p:nvSpPr>
@@ -8177,7 +8201,7 @@
       </p:sp>
       <p:sp>
         <p:nvSpPr>
-          <p:cNvPr id="20" name="TextBox 19"/>
+          <p:cNvPr id="21" name="TextBox 20"/>
           <p:cNvSpPr txBox="1"/>
           <p:nvPr/>
         </p:nvSpPr>
@@ -8216,7 +8240,7 @@
       </p:sp>
       <p:sp>
         <p:nvSpPr>
-          <p:cNvPr id="21" name="TextBox 20"/>
+          <p:cNvPr id="22" name="TextBox 21"/>
           <p:cNvSpPr txBox="1"/>
           <p:nvPr/>
         </p:nvSpPr>
@@ -8255,7 +8279,7 @@
       </p:sp>
       <p:sp>
         <p:nvSpPr>
-          <p:cNvPr id="22" name="TextBox 21"/>
+          <p:cNvPr id="23" name="TextBox 22"/>
           <p:cNvSpPr txBox="1"/>
           <p:nvPr/>
         </p:nvSpPr>
@@ -8294,7 +8318,7 @@
       </p:sp>
       <p:sp>
         <p:nvSpPr>
-          <p:cNvPr id="23" name="TextBox 22"/>
+          <p:cNvPr id="24" name="TextBox 23"/>
           <p:cNvSpPr txBox="1"/>
           <p:nvPr/>
         </p:nvSpPr>
@@ -8333,7 +8357,7 @@
       </p:sp>
       <p:sp>
         <p:nvSpPr>
-          <p:cNvPr id="24" name="TextBox 23"/>
+          <p:cNvPr id="25" name="TextBox 24"/>
           <p:cNvSpPr txBox="1"/>
           <p:nvPr/>
         </p:nvSpPr>
@@ -8372,7 +8396,7 @@
       </p:sp>
       <p:sp>
         <p:nvSpPr>
-          <p:cNvPr id="25" name="TextBox 24"/>
+          <p:cNvPr id="26" name="TextBox 25"/>
           <p:cNvSpPr txBox="1"/>
           <p:nvPr/>
         </p:nvSpPr>
@@ -8411,7 +8435,7 @@
       </p:sp>
       <p:sp>
         <p:nvSpPr>
-          <p:cNvPr id="26" name="TextBox 25"/>
+          <p:cNvPr id="27" name="TextBox 26"/>
           <p:cNvSpPr txBox="1"/>
           <p:nvPr/>
         </p:nvSpPr>
@@ -8450,7 +8474,7 @@
       </p:sp>
       <p:sp>
         <p:nvSpPr>
-          <p:cNvPr id="27" name="TextBox 26"/>
+          <p:cNvPr id="28" name="TextBox 27"/>
           <p:cNvSpPr txBox="1"/>
           <p:nvPr/>
         </p:nvSpPr>
@@ -8489,7 +8513,7 @@
       </p:sp>
       <p:sp>
         <p:nvSpPr>
-          <p:cNvPr id="28" name="TextBox 27"/>
+          <p:cNvPr id="29" name="TextBox 28"/>
           <p:cNvSpPr txBox="1"/>
           <p:nvPr/>
         </p:nvSpPr>
@@ -8528,7 +8552,7 @@
       </p:sp>
       <p:sp>
         <p:nvSpPr>
-          <p:cNvPr id="29" name="TextBox 28"/>
+          <p:cNvPr id="30" name="TextBox 29"/>
           <p:cNvSpPr txBox="1"/>
           <p:nvPr/>
         </p:nvSpPr>
@@ -8727,7 +8751,7 @@
       </p:sp>
       <p:sp>
         <p:nvSpPr>
-          <p:cNvPr id="30" name="TextBox 29"/>
+          <p:cNvPr id="31" name="TextBox 30"/>
           <p:cNvSpPr txBox="1"/>
           <p:nvPr/>
         </p:nvSpPr>
@@ -8766,7 +8790,7 @@
       </p:sp>
       <p:sp>
         <p:nvSpPr>
-          <p:cNvPr id="31" name="TextBox 30"/>
+          <p:cNvPr id="32" name="TextBox 31"/>
           <p:cNvSpPr txBox="1"/>
           <p:nvPr/>
         </p:nvSpPr>

</xml_diff>